<commit_message>
improving the for examples (please finish the for examples and the python certificate soon...)
</commit_message>
<xml_diff>
--- a/Python/CONTROL FLOW STRUCTURES (lessons #7 - )/PowerPoints & PDFs/Lesson +#7 - Making decisions (CFGs) v2.pptx
+++ b/Python/CONTROL FLOW STRUCTURES (lessons #7 - )/PowerPoints & PDFs/Lesson +#7 - Making decisions (CFGs) v2.pptx
@@ -18,6 +18,8 @@
     <p:sldId id="270" r:id="rId12"/>
     <p:sldId id="274" r:id="rId13"/>
     <p:sldId id="271" r:id="rId14"/>
+    <p:sldId id="276" r:id="rId15"/>
+    <p:sldId id="275" r:id="rId16"/>
   </p:sldIdLst>
   <p:sldSz cx="12192000" cy="6858000"/>
   <p:notesSz cx="6858000" cy="9144000"/>
@@ -273,7 +275,7 @@
           <a:p>
             <a:fld id="{E87FDB18-98E6-4A2B-A3F6-0B25054C7CB3}" type="datetimeFigureOut">
               <a:rPr lang="en-US" smtClean="0"/>
-              <a:t>4/23/2026</a:t>
+              <a:t>5/11/2026</a:t>
             </a:fld>
             <a:endParaRPr lang="en-US"/>
           </a:p>
@@ -473,7 +475,7 @@
           <a:p>
             <a:fld id="{E87FDB18-98E6-4A2B-A3F6-0B25054C7CB3}" type="datetimeFigureOut">
               <a:rPr lang="en-US" smtClean="0"/>
-              <a:t>4/23/2026</a:t>
+              <a:t>5/11/2026</a:t>
             </a:fld>
             <a:endParaRPr lang="en-US"/>
           </a:p>
@@ -683,7 +685,7 @@
           <a:p>
             <a:fld id="{E87FDB18-98E6-4A2B-A3F6-0B25054C7CB3}" type="datetimeFigureOut">
               <a:rPr lang="en-US" smtClean="0"/>
-              <a:t>4/23/2026</a:t>
+              <a:t>5/11/2026</a:t>
             </a:fld>
             <a:endParaRPr lang="en-US"/>
           </a:p>
@@ -883,7 +885,7 @@
           <a:p>
             <a:fld id="{E87FDB18-98E6-4A2B-A3F6-0B25054C7CB3}" type="datetimeFigureOut">
               <a:rPr lang="en-US" smtClean="0"/>
-              <a:t>4/23/2026</a:t>
+              <a:t>5/11/2026</a:t>
             </a:fld>
             <a:endParaRPr lang="en-US"/>
           </a:p>
@@ -1159,7 +1161,7 @@
           <a:p>
             <a:fld id="{E87FDB18-98E6-4A2B-A3F6-0B25054C7CB3}" type="datetimeFigureOut">
               <a:rPr lang="en-US" smtClean="0"/>
-              <a:t>4/23/2026</a:t>
+              <a:t>5/11/2026</a:t>
             </a:fld>
             <a:endParaRPr lang="en-US"/>
           </a:p>
@@ -1427,7 +1429,7 @@
           <a:p>
             <a:fld id="{E87FDB18-98E6-4A2B-A3F6-0B25054C7CB3}" type="datetimeFigureOut">
               <a:rPr lang="en-US" smtClean="0"/>
-              <a:t>4/23/2026</a:t>
+              <a:t>5/11/2026</a:t>
             </a:fld>
             <a:endParaRPr lang="en-US"/>
           </a:p>
@@ -1842,7 +1844,7 @@
           <a:p>
             <a:fld id="{E87FDB18-98E6-4A2B-A3F6-0B25054C7CB3}" type="datetimeFigureOut">
               <a:rPr lang="en-US" smtClean="0"/>
-              <a:t>4/23/2026</a:t>
+              <a:t>5/11/2026</a:t>
             </a:fld>
             <a:endParaRPr lang="en-US"/>
           </a:p>
@@ -1984,7 +1986,7 @@
           <a:p>
             <a:fld id="{E87FDB18-98E6-4A2B-A3F6-0B25054C7CB3}" type="datetimeFigureOut">
               <a:rPr lang="en-US" smtClean="0"/>
-              <a:t>4/23/2026</a:t>
+              <a:t>5/11/2026</a:t>
             </a:fld>
             <a:endParaRPr lang="en-US"/>
           </a:p>
@@ -2097,7 +2099,7 @@
           <a:p>
             <a:fld id="{E87FDB18-98E6-4A2B-A3F6-0B25054C7CB3}" type="datetimeFigureOut">
               <a:rPr lang="en-US" smtClean="0"/>
-              <a:t>4/23/2026</a:t>
+              <a:t>5/11/2026</a:t>
             </a:fld>
             <a:endParaRPr lang="en-US"/>
           </a:p>
@@ -2410,7 +2412,7 @@
           <a:p>
             <a:fld id="{E87FDB18-98E6-4A2B-A3F6-0B25054C7CB3}" type="datetimeFigureOut">
               <a:rPr lang="en-US" smtClean="0"/>
-              <a:t>4/23/2026</a:t>
+              <a:t>5/11/2026</a:t>
             </a:fld>
             <a:endParaRPr lang="en-US"/>
           </a:p>
@@ -2699,7 +2701,7 @@
           <a:p>
             <a:fld id="{E87FDB18-98E6-4A2B-A3F6-0B25054C7CB3}" type="datetimeFigureOut">
               <a:rPr lang="en-US" smtClean="0"/>
-              <a:t>4/23/2026</a:t>
+              <a:t>5/11/2026</a:t>
             </a:fld>
             <a:endParaRPr lang="en-US"/>
           </a:p>
@@ -2942,7 +2944,7 @@
           <a:p>
             <a:fld id="{E87FDB18-98E6-4A2B-A3F6-0B25054C7CB3}" type="datetimeFigureOut">
               <a:rPr lang="en-US" smtClean="0"/>
-              <a:t>4/23/2026</a:t>
+              <a:t>5/11/2026</a:t>
             </a:fld>
             <a:endParaRPr lang="en-US"/>
           </a:p>
@@ -6110,8 +6112,8 @@
         </p:nvSpPr>
         <p:spPr>
           <a:xfrm>
-            <a:off x="2240678" y="3221820"/>
-            <a:ext cx="4523388" cy="369332"/>
+            <a:off x="3169836" y="3221820"/>
+            <a:ext cx="2443392" cy="369332"/>
           </a:xfrm>
           <a:prstGeom prst="rect">
             <a:avLst/>
@@ -6181,8 +6183,8 @@
         </p:nvSpPr>
         <p:spPr>
           <a:xfrm>
-            <a:off x="9192229" y="1574800"/>
-            <a:ext cx="502689" cy="1371600"/>
+            <a:off x="9123835" y="1560696"/>
+            <a:ext cx="504598" cy="1048547"/>
           </a:xfrm>
           <a:custGeom>
             <a:avLst/>
@@ -6207,6 +6209,150 @@
               <a:gd name="connsiteY8" fmla="*/ 685800 h 1371600"/>
               <a:gd name="connsiteX9" fmla="*/ 116871 w 502689"/>
               <a:gd name="connsiteY9" fmla="*/ 1371600 h 1371600"/>
+              <a:gd name="connsiteX0" fmla="*/ 320071 w 502689"/>
+              <a:gd name="connsiteY0" fmla="*/ 0 h 1155700"/>
+              <a:gd name="connsiteX1" fmla="*/ 269271 w 502689"/>
+              <a:gd name="connsiteY1" fmla="*/ 368300 h 1155700"/>
+              <a:gd name="connsiteX2" fmla="*/ 218471 w 502689"/>
+              <a:gd name="connsiteY2" fmla="*/ 1155700 h 1155700"/>
+              <a:gd name="connsiteX3" fmla="*/ 2571 w 502689"/>
+              <a:gd name="connsiteY3" fmla="*/ 647700 h 1155700"/>
+              <a:gd name="connsiteX4" fmla="*/ 91471 w 502689"/>
+              <a:gd name="connsiteY4" fmla="*/ 825500 h 1155700"/>
+              <a:gd name="connsiteX5" fmla="*/ 180371 w 502689"/>
+              <a:gd name="connsiteY5" fmla="*/ 1104900 h 1155700"/>
+              <a:gd name="connsiteX6" fmla="*/ 218471 w 502689"/>
+              <a:gd name="connsiteY6" fmla="*/ 1143000 h 1155700"/>
+              <a:gd name="connsiteX7" fmla="*/ 447071 w 502689"/>
+              <a:gd name="connsiteY7" fmla="*/ 800100 h 1155700"/>
+              <a:gd name="connsiteX8" fmla="*/ 497871 w 502689"/>
+              <a:gd name="connsiteY8" fmla="*/ 685800 h 1155700"/>
+              <a:gd name="connsiteX0" fmla="*/ 320071 w 503901"/>
+              <a:gd name="connsiteY0" fmla="*/ 0 h 1155700"/>
+              <a:gd name="connsiteX1" fmla="*/ 269271 w 503901"/>
+              <a:gd name="connsiteY1" fmla="*/ 368300 h 1155700"/>
+              <a:gd name="connsiteX2" fmla="*/ 218471 w 503901"/>
+              <a:gd name="connsiteY2" fmla="*/ 1155700 h 1155700"/>
+              <a:gd name="connsiteX3" fmla="*/ 2571 w 503901"/>
+              <a:gd name="connsiteY3" fmla="*/ 647700 h 1155700"/>
+              <a:gd name="connsiteX4" fmla="*/ 91471 w 503901"/>
+              <a:gd name="connsiteY4" fmla="*/ 825500 h 1155700"/>
+              <a:gd name="connsiteX5" fmla="*/ 180371 w 503901"/>
+              <a:gd name="connsiteY5" fmla="*/ 1104900 h 1155700"/>
+              <a:gd name="connsiteX6" fmla="*/ 285146 w 503901"/>
+              <a:gd name="connsiteY6" fmla="*/ 1076325 h 1155700"/>
+              <a:gd name="connsiteX7" fmla="*/ 447071 w 503901"/>
+              <a:gd name="connsiteY7" fmla="*/ 800100 h 1155700"/>
+              <a:gd name="connsiteX8" fmla="*/ 497871 w 503901"/>
+              <a:gd name="connsiteY8" fmla="*/ 685800 h 1155700"/>
+              <a:gd name="connsiteX0" fmla="*/ 320803 w 504633"/>
+              <a:gd name="connsiteY0" fmla="*/ 0 h 1139825"/>
+              <a:gd name="connsiteX1" fmla="*/ 270003 w 504633"/>
+              <a:gd name="connsiteY1" fmla="*/ 368300 h 1139825"/>
+              <a:gd name="connsiteX2" fmla="*/ 219203 w 504633"/>
+              <a:gd name="connsiteY2" fmla="*/ 1139825 h 1139825"/>
+              <a:gd name="connsiteX3" fmla="*/ 3303 w 504633"/>
+              <a:gd name="connsiteY3" fmla="*/ 647700 h 1139825"/>
+              <a:gd name="connsiteX4" fmla="*/ 92203 w 504633"/>
+              <a:gd name="connsiteY4" fmla="*/ 825500 h 1139825"/>
+              <a:gd name="connsiteX5" fmla="*/ 181103 w 504633"/>
+              <a:gd name="connsiteY5" fmla="*/ 1104900 h 1139825"/>
+              <a:gd name="connsiteX6" fmla="*/ 285878 w 504633"/>
+              <a:gd name="connsiteY6" fmla="*/ 1076325 h 1139825"/>
+              <a:gd name="connsiteX7" fmla="*/ 447803 w 504633"/>
+              <a:gd name="connsiteY7" fmla="*/ 800100 h 1139825"/>
+              <a:gd name="connsiteX8" fmla="*/ 498603 w 504633"/>
+              <a:gd name="connsiteY8" fmla="*/ 685800 h 1139825"/>
+              <a:gd name="connsiteX0" fmla="*/ 320803 w 504633"/>
+              <a:gd name="connsiteY0" fmla="*/ 0 h 1165945"/>
+              <a:gd name="connsiteX1" fmla="*/ 270003 w 504633"/>
+              <a:gd name="connsiteY1" fmla="*/ 368300 h 1165945"/>
+              <a:gd name="connsiteX2" fmla="*/ 219203 w 504633"/>
+              <a:gd name="connsiteY2" fmla="*/ 1139825 h 1165945"/>
+              <a:gd name="connsiteX3" fmla="*/ 3303 w 504633"/>
+              <a:gd name="connsiteY3" fmla="*/ 647700 h 1165945"/>
+              <a:gd name="connsiteX4" fmla="*/ 92203 w 504633"/>
+              <a:gd name="connsiteY4" fmla="*/ 825500 h 1165945"/>
+              <a:gd name="connsiteX5" fmla="*/ 181103 w 504633"/>
+              <a:gd name="connsiteY5" fmla="*/ 1104900 h 1165945"/>
+              <a:gd name="connsiteX6" fmla="*/ 285878 w 504633"/>
+              <a:gd name="connsiteY6" fmla="*/ 1076325 h 1165945"/>
+              <a:gd name="connsiteX7" fmla="*/ 447803 w 504633"/>
+              <a:gd name="connsiteY7" fmla="*/ 800100 h 1165945"/>
+              <a:gd name="connsiteX8" fmla="*/ 498603 w 504633"/>
+              <a:gd name="connsiteY8" fmla="*/ 685800 h 1165945"/>
+              <a:gd name="connsiteX0" fmla="*/ 320803 w 505571"/>
+              <a:gd name="connsiteY0" fmla="*/ 0 h 1165945"/>
+              <a:gd name="connsiteX1" fmla="*/ 270003 w 505571"/>
+              <a:gd name="connsiteY1" fmla="*/ 368300 h 1165945"/>
+              <a:gd name="connsiteX2" fmla="*/ 219203 w 505571"/>
+              <a:gd name="connsiteY2" fmla="*/ 1139825 h 1165945"/>
+              <a:gd name="connsiteX3" fmla="*/ 3303 w 505571"/>
+              <a:gd name="connsiteY3" fmla="*/ 647700 h 1165945"/>
+              <a:gd name="connsiteX4" fmla="*/ 92203 w 505571"/>
+              <a:gd name="connsiteY4" fmla="*/ 825500 h 1165945"/>
+              <a:gd name="connsiteX5" fmla="*/ 181103 w 505571"/>
+              <a:gd name="connsiteY5" fmla="*/ 1104900 h 1165945"/>
+              <a:gd name="connsiteX6" fmla="*/ 235078 w 505571"/>
+              <a:gd name="connsiteY6" fmla="*/ 1146175 h 1165945"/>
+              <a:gd name="connsiteX7" fmla="*/ 447803 w 505571"/>
+              <a:gd name="connsiteY7" fmla="*/ 800100 h 1165945"/>
+              <a:gd name="connsiteX8" fmla="*/ 498603 w 505571"/>
+              <a:gd name="connsiteY8" fmla="*/ 685800 h 1165945"/>
+              <a:gd name="connsiteX0" fmla="*/ 320803 w 505254"/>
+              <a:gd name="connsiteY0" fmla="*/ 0 h 1165945"/>
+              <a:gd name="connsiteX1" fmla="*/ 270003 w 505254"/>
+              <a:gd name="connsiteY1" fmla="*/ 368300 h 1165945"/>
+              <a:gd name="connsiteX2" fmla="*/ 219203 w 505254"/>
+              <a:gd name="connsiteY2" fmla="*/ 1139825 h 1165945"/>
+              <a:gd name="connsiteX3" fmla="*/ 3303 w 505254"/>
+              <a:gd name="connsiteY3" fmla="*/ 647700 h 1165945"/>
+              <a:gd name="connsiteX4" fmla="*/ 92203 w 505254"/>
+              <a:gd name="connsiteY4" fmla="*/ 825500 h 1165945"/>
+              <a:gd name="connsiteX5" fmla="*/ 181103 w 505254"/>
+              <a:gd name="connsiteY5" fmla="*/ 1104900 h 1165945"/>
+              <a:gd name="connsiteX6" fmla="*/ 250953 w 505254"/>
+              <a:gd name="connsiteY6" fmla="*/ 1158875 h 1165945"/>
+              <a:gd name="connsiteX7" fmla="*/ 447803 w 505254"/>
+              <a:gd name="connsiteY7" fmla="*/ 800100 h 1165945"/>
+              <a:gd name="connsiteX8" fmla="*/ 498603 w 505254"/>
+              <a:gd name="connsiteY8" fmla="*/ 685800 h 1165945"/>
+              <a:gd name="connsiteX0" fmla="*/ 323328 w 507779"/>
+              <a:gd name="connsiteY0" fmla="*/ 0 h 1203139"/>
+              <a:gd name="connsiteX1" fmla="*/ 272528 w 507779"/>
+              <a:gd name="connsiteY1" fmla="*/ 368300 h 1203139"/>
+              <a:gd name="connsiteX2" fmla="*/ 275703 w 507779"/>
+              <a:gd name="connsiteY2" fmla="*/ 1177925 h 1203139"/>
+              <a:gd name="connsiteX3" fmla="*/ 5828 w 507779"/>
+              <a:gd name="connsiteY3" fmla="*/ 647700 h 1203139"/>
+              <a:gd name="connsiteX4" fmla="*/ 94728 w 507779"/>
+              <a:gd name="connsiteY4" fmla="*/ 825500 h 1203139"/>
+              <a:gd name="connsiteX5" fmla="*/ 183628 w 507779"/>
+              <a:gd name="connsiteY5" fmla="*/ 1104900 h 1203139"/>
+              <a:gd name="connsiteX6" fmla="*/ 253478 w 507779"/>
+              <a:gd name="connsiteY6" fmla="*/ 1158875 h 1203139"/>
+              <a:gd name="connsiteX7" fmla="*/ 450328 w 507779"/>
+              <a:gd name="connsiteY7" fmla="*/ 800100 h 1203139"/>
+              <a:gd name="connsiteX8" fmla="*/ 501128 w 507779"/>
+              <a:gd name="connsiteY8" fmla="*/ 685800 h 1203139"/>
+              <a:gd name="connsiteX0" fmla="*/ 320147 w 504598"/>
+              <a:gd name="connsiteY0" fmla="*/ 0 h 1162848"/>
+              <a:gd name="connsiteX1" fmla="*/ 269347 w 504598"/>
+              <a:gd name="connsiteY1" fmla="*/ 368300 h 1162848"/>
+              <a:gd name="connsiteX2" fmla="*/ 202672 w 504598"/>
+              <a:gd name="connsiteY2" fmla="*/ 1136650 h 1162848"/>
+              <a:gd name="connsiteX3" fmla="*/ 2647 w 504598"/>
+              <a:gd name="connsiteY3" fmla="*/ 647700 h 1162848"/>
+              <a:gd name="connsiteX4" fmla="*/ 91547 w 504598"/>
+              <a:gd name="connsiteY4" fmla="*/ 825500 h 1162848"/>
+              <a:gd name="connsiteX5" fmla="*/ 180447 w 504598"/>
+              <a:gd name="connsiteY5" fmla="*/ 1104900 h 1162848"/>
+              <a:gd name="connsiteX6" fmla="*/ 250297 w 504598"/>
+              <a:gd name="connsiteY6" fmla="*/ 1158875 h 1162848"/>
+              <a:gd name="connsiteX7" fmla="*/ 447147 w 504598"/>
+              <a:gd name="connsiteY7" fmla="*/ 800100 h 1162848"/>
+              <a:gd name="connsiteX8" fmla="*/ 497947 w 504598"/>
+              <a:gd name="connsiteY8" fmla="*/ 685800 h 1162848"/>
             </a:gdLst>
             <a:ahLst/>
             <a:cxnLst>
@@ -6237,60 +6383,52 @@
               <a:cxn ang="0">
                 <a:pos x="connsiteX8" y="connsiteY8"/>
               </a:cxn>
-              <a:cxn ang="0">
-                <a:pos x="connsiteX9" y="connsiteY9"/>
-              </a:cxn>
             </a:cxnLst>
             <a:rect l="l" t="t" r="r" b="b"/>
             <a:pathLst>
-              <a:path w="502689" h="1371600">
+              <a:path w="504598" h="1162848">
                 <a:moveTo>
-                  <a:pt x="320071" y="0"/>
+                  <a:pt x="320147" y="0"/>
                 </a:moveTo>
                 <a:cubicBezTo>
-                  <a:pt x="303138" y="122767"/>
-                  <a:pt x="278315" y="244701"/>
-                  <a:pt x="269271" y="368300"/>
-                </a:cubicBezTo>
-                <a:cubicBezTo>
-                  <a:pt x="224676" y="977763"/>
-                  <a:pt x="239449" y="715166"/>
-                  <a:pt x="218471" y="1155700"/>
-                </a:cubicBezTo>
-                <a:cubicBezTo>
-                  <a:pt x="130859" y="980475"/>
-                  <a:pt x="60923" y="851932"/>
-                  <a:pt x="2571" y="647700"/>
-                </a:cubicBezTo>
-                <a:cubicBezTo>
-                  <a:pt x="-15633" y="583987"/>
-                  <a:pt x="67971" y="763545"/>
-                  <a:pt x="91471" y="825500"/>
-                </a:cubicBezTo>
-                <a:cubicBezTo>
-                  <a:pt x="128785" y="923873"/>
-                  <a:pt x="127074" y="1016072"/>
-                  <a:pt x="180371" y="1104900"/>
-                </a:cubicBezTo>
-                <a:cubicBezTo>
-                  <a:pt x="189612" y="1120301"/>
-                  <a:pt x="205771" y="1130300"/>
-                  <a:pt x="218471" y="1143000"/>
-                </a:cubicBezTo>
-                <a:cubicBezTo>
-                  <a:pt x="333645" y="1004791"/>
-                  <a:pt x="312826" y="1037003"/>
-                  <a:pt x="447071" y="800100"/>
-                </a:cubicBezTo>
-                <a:cubicBezTo>
-                  <a:pt x="467626" y="763826"/>
-                  <a:pt x="518468" y="649549"/>
-                  <a:pt x="497871" y="685800"/>
-                </a:cubicBezTo>
-                <a:cubicBezTo>
-                  <a:pt x="93689" y="1397160"/>
-                  <a:pt x="311192" y="1177279"/>
-                  <a:pt x="116871" y="1371600"/>
+                  <a:pt x="303214" y="122767"/>
+                  <a:pt x="288926" y="178858"/>
+                  <a:pt x="269347" y="368300"/>
+                </a:cubicBezTo>
+                <a:cubicBezTo>
+                  <a:pt x="249768" y="557742"/>
+                  <a:pt x="290284" y="1311875"/>
+                  <a:pt x="202672" y="1136650"/>
+                </a:cubicBezTo>
+                <a:cubicBezTo>
+                  <a:pt x="115060" y="961425"/>
+                  <a:pt x="21168" y="699558"/>
+                  <a:pt x="2647" y="647700"/>
+                </a:cubicBezTo>
+                <a:cubicBezTo>
+                  <a:pt x="-15874" y="595842"/>
+                  <a:pt x="68047" y="763545"/>
+                  <a:pt x="91547" y="825500"/>
+                </a:cubicBezTo>
+                <a:cubicBezTo>
+                  <a:pt x="128861" y="923873"/>
+                  <a:pt x="153989" y="1049338"/>
+                  <a:pt x="180447" y="1104900"/>
+                </a:cubicBezTo>
+                <a:cubicBezTo>
+                  <a:pt x="206905" y="1160462"/>
+                  <a:pt x="237597" y="1146175"/>
+                  <a:pt x="250297" y="1158875"/>
+                </a:cubicBezTo>
+                <a:cubicBezTo>
+                  <a:pt x="365471" y="1020666"/>
+                  <a:pt x="405872" y="878946"/>
+                  <a:pt x="447147" y="800100"/>
+                </a:cubicBezTo>
+                <a:cubicBezTo>
+                  <a:pt x="488422" y="721254"/>
+                  <a:pt x="518544" y="649549"/>
+                  <a:pt x="497947" y="685800"/>
                 </a:cubicBezTo>
               </a:path>
             </a:pathLst>
@@ -6341,8 +6479,8 @@
         </p:nvSpPr>
         <p:spPr>
           <a:xfrm>
-            <a:off x="8962085" y="4025900"/>
-            <a:ext cx="476017" cy="1143000"/>
+            <a:off x="9004644" y="3998437"/>
+            <a:ext cx="361682" cy="1069415"/>
           </a:xfrm>
           <a:custGeom>
             <a:avLst/>
@@ -7283,101 +7421,6 @@
           <a:chExt cx="0" cy="0"/>
         </a:xfrm>
       </p:grpSpPr>
-      <p:sp>
-        <p:nvSpPr>
-          <p:cNvPr id="2" name="Título 1">
-            <a:extLst>
-              <a:ext uri="{FF2B5EF4-FFF2-40B4-BE49-F238E27FC236}">
-                <a16:creationId xmlns:a16="http://schemas.microsoft.com/office/drawing/2014/main" id="{5542DC75-D4A3-19E9-89A3-CBE6652769FF}"/>
-              </a:ext>
-            </a:extLst>
-          </p:cNvPr>
-          <p:cNvSpPr>
-            <a:spLocks noGrp="1"/>
-          </p:cNvSpPr>
-          <p:nvPr>
-            <p:ph type="title"/>
-          </p:nvPr>
-        </p:nvSpPr>
-        <p:spPr>
-          <a:xfrm>
-            <a:off x="129860" y="365125"/>
-            <a:ext cx="6866419" cy="1325563"/>
-          </a:xfrm>
-        </p:spPr>
-        <p:txBody>
-          <a:bodyPr/>
-          <a:lstStyle/>
-          <a:p>
-            <a:r>
-              <a:rPr lang="es-AR" b="1" dirty="0" err="1">
-                <a:latin typeface="Consolas" panose="020B0609020204030204" pitchFamily="49" charset="0"/>
-                <a:cs typeface="Cascadia Code SemiBold" panose="020B0609020000020004" pitchFamily="49" charset="0"/>
-              </a:rPr>
-              <a:t>For</a:t>
-            </a:r>
-            <a:r>
-              <a:rPr lang="es-AR" b="1" dirty="0">
-                <a:latin typeface="Consolas" panose="020B0609020204030204" pitchFamily="49" charset="0"/>
-                <a:cs typeface="Cascadia Code SemiBold" panose="020B0609020000020004" pitchFamily="49" charset="0"/>
-              </a:rPr>
-              <a:t> i in </a:t>
-            </a:r>
-            <a:r>
-              <a:rPr lang="es-AR" b="1" dirty="0" err="1">
-                <a:latin typeface="Consolas" panose="020B0609020204030204" pitchFamily="49" charset="0"/>
-                <a:cs typeface="Cascadia Code SemiBold" panose="020B0609020000020004" pitchFamily="49" charset="0"/>
-              </a:rPr>
-              <a:t>range</a:t>
-            </a:r>
-            <a:r>
-              <a:rPr lang="es-AR" b="1" dirty="0">
-                <a:latin typeface="Consolas" panose="020B0609020204030204" pitchFamily="49" charset="0"/>
-                <a:cs typeface="Cascadia Code SemiBold" panose="020B0609020000020004" pitchFamily="49" charset="0"/>
-              </a:rPr>
-              <a:t>(_, _)</a:t>
-            </a:r>
-            <a:br>
-              <a:rPr lang="es-AR" dirty="0"/>
-            </a:br>
-            <a:r>
-              <a:rPr lang="es-AR" i="1" dirty="0">
-                <a:solidFill>
-                  <a:schemeClr val="bg2">
-                    <a:lumMod val="50000"/>
-                  </a:schemeClr>
-                </a:solidFill>
-              </a:rPr>
-              <a:t>(</a:t>
-            </a:r>
-            <a:r>
-              <a:rPr lang="es-AR" i="1" dirty="0" err="1">
-                <a:solidFill>
-                  <a:schemeClr val="bg2">
-                    <a:lumMod val="50000"/>
-                  </a:schemeClr>
-                </a:solidFill>
-              </a:rPr>
-              <a:t>loop</a:t>
-            </a:r>
-            <a:r>
-              <a:rPr lang="es-AR" i="1" dirty="0">
-                <a:solidFill>
-                  <a:schemeClr val="bg2">
-                    <a:lumMod val="50000"/>
-                  </a:schemeClr>
-                </a:solidFill>
-              </a:rPr>
-              <a:t>)</a:t>
-            </a:r>
-            <a:r>
-              <a:rPr lang="es-AR" dirty="0"/>
-              <a:t> </a:t>
-            </a:r>
-            <a:endParaRPr lang="en-US" dirty="0"/>
-          </a:p>
-        </p:txBody>
-      </p:sp>
       <p:pic>
         <p:nvPicPr>
           <p:cNvPr id="3" name="Imagen 2">
@@ -7428,7 +7471,7 @@
         </p:nvSpPr>
         <p:spPr>
           <a:xfrm>
-            <a:off x="7695075" y="5034795"/>
+            <a:off x="7833625" y="5131780"/>
             <a:ext cx="847164" cy="369332"/>
           </a:xfrm>
           <a:prstGeom prst="rect">
@@ -7463,7 +7506,7 @@
         </p:nvSpPr>
         <p:spPr>
           <a:xfrm>
-            <a:off x="7695075" y="5256864"/>
+            <a:off x="7847480" y="5381559"/>
             <a:ext cx="2743200" cy="958383"/>
           </a:xfrm>
           <a:prstGeom prst="ellipse">
@@ -7513,8 +7556,8 @@
         </p:nvSpPr>
         <p:spPr>
           <a:xfrm>
-            <a:off x="8139449" y="5551389"/>
-            <a:ext cx="1932803" cy="369332"/>
+            <a:off x="8456473" y="5567373"/>
+            <a:ext cx="1525213" cy="584775"/>
           </a:xfrm>
           <a:prstGeom prst="rect">
             <a:avLst/>
@@ -7528,16 +7571,8 @@
           <a:lstStyle/>
           <a:p>
             <a:r>
-              <a:rPr lang="en-US" dirty="0"/>
-              <a:t>print(</a:t>
-            </a:r>
-            <a:r>
-              <a:rPr lang="en-US" dirty="0" err="1"/>
-              <a:t>full_names</a:t>
-            </a:r>
-            <a:r>
-              <a:rPr lang="en-US" dirty="0"/>
-              <a:t>)</a:t>
+              <a:rPr lang="en-US" sz="3200" dirty="0"/>
+              <a:t>print(…)</a:t>
             </a:r>
           </a:p>
         </p:txBody>
@@ -8413,8 +8448,8 @@
         </p:nvSpPr>
         <p:spPr>
           <a:xfrm>
-            <a:off x="319303" y="1826482"/>
-            <a:ext cx="891890" cy="2110778"/>
+            <a:off x="391405" y="1900135"/>
+            <a:ext cx="747686" cy="1769502"/>
           </a:xfrm>
           <a:custGeom>
             <a:avLst/>
@@ -8685,10 +8720,3382 @@
           </a:p>
         </p:txBody>
       </p:sp>
+      <p:sp>
+        <p:nvSpPr>
+          <p:cNvPr id="24" name="Título 1">
+            <a:extLst>
+              <a:ext uri="{FF2B5EF4-FFF2-40B4-BE49-F238E27FC236}">
+                <a16:creationId xmlns:a16="http://schemas.microsoft.com/office/drawing/2014/main" id="{7162D1FD-68BE-A8B8-CF24-3A1805D1B802}"/>
+              </a:ext>
+            </a:extLst>
+          </p:cNvPr>
+          <p:cNvSpPr txBox="1">
+            <a:spLocks/>
+          </p:cNvSpPr>
+          <p:nvPr/>
+        </p:nvSpPr>
+        <p:spPr>
+          <a:xfrm>
+            <a:off x="129860" y="365125"/>
+            <a:ext cx="6853430" cy="1174941"/>
+          </a:xfrm>
+          <a:prstGeom prst="rect">
+            <a:avLst/>
+          </a:prstGeom>
+        </p:spPr>
+        <p:txBody>
+          <a:bodyPr vert="horz" lIns="91440" tIns="45720" rIns="91440" bIns="45720" rtlCol="0" anchor="ctr">
+            <a:normAutofit/>
+          </a:bodyPr>
+          <a:lstStyle>
+            <a:lvl1pPr algn="l" defTabSz="914400" rtl="0" eaLnBrk="1" latinLnBrk="0" hangingPunct="1">
+              <a:lnSpc>
+                <a:spcPct val="90000"/>
+              </a:lnSpc>
+              <a:spcBef>
+                <a:spcPct val="0"/>
+              </a:spcBef>
+              <a:buNone/>
+              <a:defRPr sz="4400" kern="1200">
+                <a:solidFill>
+                  <a:schemeClr val="tx1"/>
+                </a:solidFill>
+                <a:latin typeface="+mj-lt"/>
+                <a:ea typeface="+mj-ea"/>
+                <a:cs typeface="+mj-cs"/>
+              </a:defRPr>
+            </a:lvl1pPr>
+          </a:lstStyle>
+          <a:p>
+            <a:r>
+              <a:rPr lang="es-AR" sz="2800" b="1" dirty="0" err="1">
+                <a:latin typeface="Consolas" panose="020B0609020204030204" pitchFamily="49" charset="0"/>
+                <a:cs typeface="Cascadia Code SemiBold" panose="020B0609020000020004" pitchFamily="49" charset="0"/>
+              </a:rPr>
+              <a:t>For</a:t>
+            </a:r>
+            <a:r>
+              <a:rPr lang="es-AR" sz="2800" b="1" dirty="0">
+                <a:latin typeface="Consolas" panose="020B0609020204030204" pitchFamily="49" charset="0"/>
+                <a:cs typeface="Cascadia Code SemiBold" panose="020B0609020000020004" pitchFamily="49" charset="0"/>
+              </a:rPr>
+              <a:t> ____ in </a:t>
+            </a:r>
+            <a:r>
+              <a:rPr lang="es-AR" sz="2800" b="1" dirty="0" err="1">
+                <a:latin typeface="Consolas" panose="020B0609020204030204" pitchFamily="49" charset="0"/>
+                <a:cs typeface="Cascadia Code SemiBold" panose="020B0609020000020004" pitchFamily="49" charset="0"/>
+              </a:rPr>
+              <a:t>range</a:t>
+            </a:r>
+            <a:r>
+              <a:rPr lang="es-AR" sz="2800" b="1" dirty="0">
+                <a:latin typeface="Consolas" panose="020B0609020204030204" pitchFamily="49" charset="0"/>
+                <a:cs typeface="Cascadia Code SemiBold" panose="020B0609020000020004" pitchFamily="49" charset="0"/>
+              </a:rPr>
+              <a:t>(a, b, c)</a:t>
+            </a:r>
+            <a:br>
+              <a:rPr lang="es-AR" sz="3600" dirty="0"/>
+            </a:br>
+            <a:r>
+              <a:rPr lang="es-AR" sz="2800" i="1" dirty="0">
+                <a:solidFill>
+                  <a:schemeClr val="bg2">
+                    <a:lumMod val="50000"/>
+                  </a:schemeClr>
+                </a:solidFill>
+              </a:rPr>
+              <a:t>(</a:t>
+            </a:r>
+            <a:r>
+              <a:rPr lang="es-AR" sz="2800" i="1" dirty="0" err="1">
+                <a:solidFill>
+                  <a:schemeClr val="bg2">
+                    <a:lumMod val="50000"/>
+                  </a:schemeClr>
+                </a:solidFill>
+              </a:rPr>
+              <a:t>loop</a:t>
+            </a:r>
+            <a:r>
+              <a:rPr lang="es-AR" sz="2800" i="1" dirty="0">
+                <a:solidFill>
+                  <a:schemeClr val="bg2">
+                    <a:lumMod val="50000"/>
+                  </a:schemeClr>
+                </a:solidFill>
+              </a:rPr>
+              <a:t>)</a:t>
+            </a:r>
+            <a:r>
+              <a:rPr lang="es-AR" sz="2800" dirty="0"/>
+              <a:t> </a:t>
+            </a:r>
+            <a:endParaRPr lang="en-US" sz="3600" dirty="0"/>
+          </a:p>
+        </p:txBody>
+      </p:sp>
+      <p:pic>
+        <p:nvPicPr>
+          <p:cNvPr id="26" name="Imagen 25">
+            <a:extLst>
+              <a:ext uri="{FF2B5EF4-FFF2-40B4-BE49-F238E27FC236}">
+                <a16:creationId xmlns:a16="http://schemas.microsoft.com/office/drawing/2014/main" id="{DAB91392-120A-3DB9-B0C7-99D55FFDE5C3}"/>
+              </a:ext>
+            </a:extLst>
+          </p:cNvPr>
+          <p:cNvPicPr>
+            <a:picLocks noChangeAspect="1"/>
+          </p:cNvPicPr>
+          <p:nvPr/>
+        </p:nvPicPr>
+        <p:blipFill>
+          <a:blip r:embed="rId3"/>
+          <a:stretch>
+            <a:fillRect/>
+          </a:stretch>
+        </p:blipFill>
+        <p:spPr>
+          <a:xfrm>
+            <a:off x="1" y="5062281"/>
+            <a:ext cx="7523018" cy="1816408"/>
+          </a:xfrm>
+          <a:prstGeom prst="rect">
+            <a:avLst/>
+          </a:prstGeom>
+        </p:spPr>
+      </p:pic>
+      <p:cxnSp>
+        <p:nvCxnSpPr>
+          <p:cNvPr id="28" name="Conector recto 27">
+            <a:extLst>
+              <a:ext uri="{FF2B5EF4-FFF2-40B4-BE49-F238E27FC236}">
+                <a16:creationId xmlns:a16="http://schemas.microsoft.com/office/drawing/2014/main" id="{39E68C85-3412-0753-49E3-ED03DD4213B0}"/>
+              </a:ext>
+            </a:extLst>
+          </p:cNvPr>
+          <p:cNvCxnSpPr>
+            <a:cxnSpLocks/>
+          </p:cNvCxnSpPr>
+          <p:nvPr/>
+        </p:nvCxnSpPr>
+        <p:spPr>
+          <a:xfrm>
+            <a:off x="9310255" y="1540066"/>
+            <a:ext cx="0" cy="1078443"/>
+          </a:xfrm>
+          <a:prstGeom prst="line">
+            <a:avLst/>
+          </a:prstGeom>
+          <a:ln w="38100">
+            <a:solidFill>
+              <a:srgbClr val="8A008A"/>
+            </a:solidFill>
+          </a:ln>
+        </p:spPr>
+        <p:style>
+          <a:lnRef idx="1">
+            <a:schemeClr val="accent1"/>
+          </a:lnRef>
+          <a:fillRef idx="0">
+            <a:schemeClr val="accent1"/>
+          </a:fillRef>
+          <a:effectRef idx="0">
+            <a:schemeClr val="accent1"/>
+          </a:effectRef>
+          <a:fontRef idx="minor">
+            <a:schemeClr val="tx1"/>
+          </a:fontRef>
+        </p:style>
+      </p:cxnSp>
+      <p:cxnSp>
+        <p:nvCxnSpPr>
+          <p:cNvPr id="31" name="Conector recto 30">
+            <a:extLst>
+              <a:ext uri="{FF2B5EF4-FFF2-40B4-BE49-F238E27FC236}">
+                <a16:creationId xmlns:a16="http://schemas.microsoft.com/office/drawing/2014/main" id="{E81A9928-1A8E-5C1A-AADA-3735FC16D1C5}"/>
+              </a:ext>
+            </a:extLst>
+          </p:cNvPr>
+          <p:cNvCxnSpPr>
+            <a:cxnSpLocks/>
+          </p:cNvCxnSpPr>
+          <p:nvPr/>
+        </p:nvCxnSpPr>
+        <p:spPr>
+          <a:xfrm flipV="1">
+            <a:off x="9309100" y="2393515"/>
+            <a:ext cx="177800" cy="241735"/>
+          </a:xfrm>
+          <a:prstGeom prst="line">
+            <a:avLst/>
+          </a:prstGeom>
+          <a:ln w="38100">
+            <a:solidFill>
+              <a:srgbClr val="8A008A"/>
+            </a:solidFill>
+          </a:ln>
+        </p:spPr>
+        <p:style>
+          <a:lnRef idx="1">
+            <a:schemeClr val="accent1"/>
+          </a:lnRef>
+          <a:fillRef idx="0">
+            <a:schemeClr val="accent1"/>
+          </a:fillRef>
+          <a:effectRef idx="0">
+            <a:schemeClr val="accent1"/>
+          </a:effectRef>
+          <a:fontRef idx="minor">
+            <a:schemeClr val="tx1"/>
+          </a:fontRef>
+        </p:style>
+      </p:cxnSp>
+      <p:cxnSp>
+        <p:nvCxnSpPr>
+          <p:cNvPr id="34" name="Conector recto 33">
+            <a:extLst>
+              <a:ext uri="{FF2B5EF4-FFF2-40B4-BE49-F238E27FC236}">
+                <a16:creationId xmlns:a16="http://schemas.microsoft.com/office/drawing/2014/main" id="{4C311DBF-B13B-08D9-3FD5-B05630472405}"/>
+              </a:ext>
+            </a:extLst>
+          </p:cNvPr>
+          <p:cNvCxnSpPr/>
+          <p:nvPr/>
+        </p:nvCxnSpPr>
+        <p:spPr>
+          <a:xfrm flipH="1" flipV="1">
+            <a:off x="9169400" y="2393515"/>
+            <a:ext cx="139700" cy="241735"/>
+          </a:xfrm>
+          <a:prstGeom prst="line">
+            <a:avLst/>
+          </a:prstGeom>
+          <a:ln w="38100">
+            <a:solidFill>
+              <a:srgbClr val="8A008A"/>
+            </a:solidFill>
+          </a:ln>
+        </p:spPr>
+        <p:style>
+          <a:lnRef idx="1">
+            <a:schemeClr val="accent1"/>
+          </a:lnRef>
+          <a:fillRef idx="0">
+            <a:schemeClr val="accent1"/>
+          </a:fillRef>
+          <a:effectRef idx="0">
+            <a:schemeClr val="accent1"/>
+          </a:effectRef>
+          <a:fontRef idx="minor">
+            <a:schemeClr val="tx1"/>
+          </a:fontRef>
+        </p:style>
+      </p:cxnSp>
+      <p:cxnSp>
+        <p:nvCxnSpPr>
+          <p:cNvPr id="35" name="Conector recto 34">
+            <a:extLst>
+              <a:ext uri="{FF2B5EF4-FFF2-40B4-BE49-F238E27FC236}">
+                <a16:creationId xmlns:a16="http://schemas.microsoft.com/office/drawing/2014/main" id="{31BD9E74-4DC9-84EB-5503-562B3D10FABE}"/>
+              </a:ext>
+            </a:extLst>
+          </p:cNvPr>
+          <p:cNvCxnSpPr>
+            <a:cxnSpLocks/>
+          </p:cNvCxnSpPr>
+          <p:nvPr/>
+        </p:nvCxnSpPr>
+        <p:spPr>
+          <a:xfrm>
+            <a:off x="9326735" y="4044844"/>
+            <a:ext cx="0" cy="1078443"/>
+          </a:xfrm>
+          <a:prstGeom prst="line">
+            <a:avLst/>
+          </a:prstGeom>
+          <a:ln w="38100">
+            <a:solidFill>
+              <a:srgbClr val="8A008A"/>
+            </a:solidFill>
+          </a:ln>
+        </p:spPr>
+        <p:style>
+          <a:lnRef idx="1">
+            <a:schemeClr val="accent1"/>
+          </a:lnRef>
+          <a:fillRef idx="0">
+            <a:schemeClr val="accent1"/>
+          </a:fillRef>
+          <a:effectRef idx="0">
+            <a:schemeClr val="accent1"/>
+          </a:effectRef>
+          <a:fontRef idx="minor">
+            <a:schemeClr val="tx1"/>
+          </a:fontRef>
+        </p:style>
+      </p:cxnSp>
+      <p:cxnSp>
+        <p:nvCxnSpPr>
+          <p:cNvPr id="36" name="Conector recto 35">
+            <a:extLst>
+              <a:ext uri="{FF2B5EF4-FFF2-40B4-BE49-F238E27FC236}">
+                <a16:creationId xmlns:a16="http://schemas.microsoft.com/office/drawing/2014/main" id="{3AC0AAC5-02B0-05E3-2724-D490676A99EE}"/>
+              </a:ext>
+            </a:extLst>
+          </p:cNvPr>
+          <p:cNvCxnSpPr>
+            <a:cxnSpLocks/>
+          </p:cNvCxnSpPr>
+          <p:nvPr/>
+        </p:nvCxnSpPr>
+        <p:spPr>
+          <a:xfrm flipV="1">
+            <a:off x="9325580" y="4898293"/>
+            <a:ext cx="177800" cy="241735"/>
+          </a:xfrm>
+          <a:prstGeom prst="line">
+            <a:avLst/>
+          </a:prstGeom>
+          <a:ln w="38100">
+            <a:solidFill>
+              <a:srgbClr val="8A008A"/>
+            </a:solidFill>
+          </a:ln>
+        </p:spPr>
+        <p:style>
+          <a:lnRef idx="1">
+            <a:schemeClr val="accent1"/>
+          </a:lnRef>
+          <a:fillRef idx="0">
+            <a:schemeClr val="accent1"/>
+          </a:fillRef>
+          <a:effectRef idx="0">
+            <a:schemeClr val="accent1"/>
+          </a:effectRef>
+          <a:fontRef idx="minor">
+            <a:schemeClr val="tx1"/>
+          </a:fontRef>
+        </p:style>
+      </p:cxnSp>
+      <p:cxnSp>
+        <p:nvCxnSpPr>
+          <p:cNvPr id="37" name="Conector recto 36">
+            <a:extLst>
+              <a:ext uri="{FF2B5EF4-FFF2-40B4-BE49-F238E27FC236}">
+                <a16:creationId xmlns:a16="http://schemas.microsoft.com/office/drawing/2014/main" id="{D9A6FE44-D130-C909-253F-C1FE05521D2A}"/>
+              </a:ext>
+            </a:extLst>
+          </p:cNvPr>
+          <p:cNvCxnSpPr>
+            <a:cxnSpLocks/>
+          </p:cNvCxnSpPr>
+          <p:nvPr/>
+        </p:nvCxnSpPr>
+        <p:spPr>
+          <a:xfrm flipH="1" flipV="1">
+            <a:off x="9185880" y="4898293"/>
+            <a:ext cx="139700" cy="241735"/>
+          </a:xfrm>
+          <a:prstGeom prst="line">
+            <a:avLst/>
+          </a:prstGeom>
+          <a:ln w="38100">
+            <a:solidFill>
+              <a:srgbClr val="8A008A"/>
+            </a:solidFill>
+          </a:ln>
+        </p:spPr>
+        <p:style>
+          <a:lnRef idx="1">
+            <a:schemeClr val="accent1"/>
+          </a:lnRef>
+          <a:fillRef idx="0">
+            <a:schemeClr val="accent1"/>
+          </a:fillRef>
+          <a:effectRef idx="0">
+            <a:schemeClr val="accent1"/>
+          </a:effectRef>
+          <a:fontRef idx="minor">
+            <a:schemeClr val="tx1"/>
+          </a:fontRef>
+        </p:style>
+      </p:cxnSp>
     </p:spTree>
     <p:extLst>
       <p:ext uri="{BB962C8B-B14F-4D97-AF65-F5344CB8AC3E}">
         <p14:creationId xmlns:p14="http://schemas.microsoft.com/office/powerpoint/2010/main" val="4133559477"/>
+      </p:ext>
+    </p:extLst>
+  </p:cSld>
+  <p:clrMapOvr>
+    <a:masterClrMapping/>
+  </p:clrMapOvr>
+</p:sld>
+</file>
+
+<file path=ppt/slides/slide14.xml><?xml version="1.0" encoding="utf-8"?>
+<p:sld xmlns:a="http://schemas.openxmlformats.org/drawingml/2006/main" xmlns:r="http://schemas.openxmlformats.org/officeDocument/2006/relationships" xmlns:p="http://schemas.openxmlformats.org/presentationml/2006/main" show="0">
+  <p:cSld>
+    <p:spTree>
+      <p:nvGrpSpPr>
+        <p:cNvPr id="1" name="">
+          <a:extLst>
+            <a:ext uri="{FF2B5EF4-FFF2-40B4-BE49-F238E27FC236}">
+              <a16:creationId xmlns:a16="http://schemas.microsoft.com/office/drawing/2014/main" id="{4C2A367E-A12F-CB13-5841-B612F3F96543}"/>
+            </a:ext>
+          </a:extLst>
+        </p:cNvPr>
+        <p:cNvGrpSpPr/>
+        <p:nvPr/>
+      </p:nvGrpSpPr>
+      <p:grpSpPr>
+        <a:xfrm>
+          <a:off x="0" y="0"/>
+          <a:ext cx="0" cy="0"/>
+          <a:chOff x="0" y="0"/>
+          <a:chExt cx="0" cy="0"/>
+        </a:xfrm>
+      </p:grpSpPr>
+      <p:pic>
+        <p:nvPicPr>
+          <p:cNvPr id="3" name="Imagen 2">
+            <a:extLst>
+              <a:ext uri="{FF2B5EF4-FFF2-40B4-BE49-F238E27FC236}">
+                <a16:creationId xmlns:a16="http://schemas.microsoft.com/office/drawing/2014/main" id="{F4E925A0-6C9B-394B-959C-406057E22A74}"/>
+              </a:ext>
+            </a:extLst>
+          </p:cNvPr>
+          <p:cNvPicPr>
+            <a:picLocks noChangeAspect="1"/>
+          </p:cNvPicPr>
+          <p:nvPr/>
+        </p:nvPicPr>
+        <p:blipFill>
+          <a:blip r:embed="rId2">
+            <a:extLst>
+              <a:ext uri="{28A0092B-C50C-407E-A947-70E740481C1C}">
+                <a14:useLocalDpi xmlns:a14="http://schemas.microsoft.com/office/drawing/2010/main" val="0"/>
+              </a:ext>
+            </a:extLst>
+          </a:blip>
+          <a:stretch>
+            <a:fillRect/>
+          </a:stretch>
+        </p:blipFill>
+        <p:spPr>
+          <a:xfrm>
+            <a:off x="10765173" y="3428999"/>
+            <a:ext cx="1177254" cy="2261919"/>
+          </a:xfrm>
+          <a:prstGeom prst="rect">
+            <a:avLst/>
+          </a:prstGeom>
+        </p:spPr>
+      </p:pic>
+      <p:sp>
+        <p:nvSpPr>
+          <p:cNvPr id="7" name="CuadroTexto 6">
+            <a:extLst>
+              <a:ext uri="{FF2B5EF4-FFF2-40B4-BE49-F238E27FC236}">
+                <a16:creationId xmlns:a16="http://schemas.microsoft.com/office/drawing/2014/main" id="{94EE21C6-DB00-C272-C966-34178B67DA8B}"/>
+              </a:ext>
+            </a:extLst>
+          </p:cNvPr>
+          <p:cNvSpPr txBox="1"/>
+          <p:nvPr/>
+        </p:nvSpPr>
+        <p:spPr>
+          <a:xfrm>
+            <a:off x="7833625" y="5131780"/>
+            <a:ext cx="847164" cy="369332"/>
+          </a:xfrm>
+          <a:prstGeom prst="rect">
+            <a:avLst/>
+          </a:prstGeom>
+          <a:noFill/>
+        </p:spPr>
+        <p:txBody>
+          <a:bodyPr wrap="square" rtlCol="0">
+            <a:spAutoFit/>
+          </a:bodyPr>
+          <a:lstStyle/>
+          <a:p>
+            <a:r>
+              <a:rPr lang="en-US" dirty="0"/>
+              <a:t>Ln 5</a:t>
+            </a:r>
+          </a:p>
+        </p:txBody>
+      </p:sp>
+      <p:sp>
+        <p:nvSpPr>
+          <p:cNvPr id="8" name="Elipse 7">
+            <a:extLst>
+              <a:ext uri="{FF2B5EF4-FFF2-40B4-BE49-F238E27FC236}">
+                <a16:creationId xmlns:a16="http://schemas.microsoft.com/office/drawing/2014/main" id="{0391FA29-CB76-5E91-BF02-1C4771B47B15}"/>
+              </a:ext>
+            </a:extLst>
+          </p:cNvPr>
+          <p:cNvSpPr/>
+          <p:nvPr/>
+        </p:nvSpPr>
+        <p:spPr>
+          <a:xfrm>
+            <a:off x="7847480" y="5381559"/>
+            <a:ext cx="2743200" cy="958383"/>
+          </a:xfrm>
+          <a:prstGeom prst="ellipse">
+            <a:avLst/>
+          </a:prstGeom>
+          <a:solidFill>
+            <a:srgbClr val="CAD7EE"/>
+          </a:solidFill>
+          <a:ln w="38100"/>
+        </p:spPr>
+        <p:style>
+          <a:lnRef idx="2">
+            <a:schemeClr val="accent1">
+              <a:shade val="15000"/>
+            </a:schemeClr>
+          </a:lnRef>
+          <a:fillRef idx="1">
+            <a:schemeClr val="accent1"/>
+          </a:fillRef>
+          <a:effectRef idx="0">
+            <a:schemeClr val="accent1"/>
+          </a:effectRef>
+          <a:fontRef idx="minor">
+            <a:schemeClr val="lt1"/>
+          </a:fontRef>
+        </p:style>
+        <p:txBody>
+          <a:bodyPr rtlCol="0" anchor="ctr"/>
+          <a:lstStyle/>
+          <a:p>
+            <a:pPr algn="ctr"/>
+            <a:endParaRPr lang="en-US"/>
+          </a:p>
+        </p:txBody>
+      </p:sp>
+      <p:sp>
+        <p:nvSpPr>
+          <p:cNvPr id="9" name="CuadroTexto 8">
+            <a:extLst>
+              <a:ext uri="{FF2B5EF4-FFF2-40B4-BE49-F238E27FC236}">
+                <a16:creationId xmlns:a16="http://schemas.microsoft.com/office/drawing/2014/main" id="{B2E9B319-2B86-3B19-2B63-07E90CCAA6C1}"/>
+              </a:ext>
+            </a:extLst>
+          </p:cNvPr>
+          <p:cNvSpPr txBox="1"/>
+          <p:nvPr/>
+        </p:nvSpPr>
+        <p:spPr>
+          <a:xfrm>
+            <a:off x="8456473" y="5567373"/>
+            <a:ext cx="1525213" cy="584775"/>
+          </a:xfrm>
+          <a:prstGeom prst="rect">
+            <a:avLst/>
+          </a:prstGeom>
+          <a:noFill/>
+        </p:spPr>
+        <p:txBody>
+          <a:bodyPr wrap="square" rtlCol="0">
+            <a:spAutoFit/>
+          </a:bodyPr>
+          <a:lstStyle/>
+          <a:p>
+            <a:r>
+              <a:rPr lang="en-US" sz="3200" dirty="0"/>
+              <a:t>print(…)</a:t>
+            </a:r>
+          </a:p>
+        </p:txBody>
+      </p:sp>
+      <p:grpSp>
+        <p:nvGrpSpPr>
+          <p:cNvPr id="17" name="Grupo 16">
+            <a:extLst>
+              <a:ext uri="{FF2B5EF4-FFF2-40B4-BE49-F238E27FC236}">
+                <a16:creationId xmlns:a16="http://schemas.microsoft.com/office/drawing/2014/main" id="{657CA576-B1C6-A9F5-8F5C-F4CFC07BF398}"/>
+              </a:ext>
+            </a:extLst>
+          </p:cNvPr>
+          <p:cNvGrpSpPr/>
+          <p:nvPr/>
+        </p:nvGrpSpPr>
+        <p:grpSpPr>
+          <a:xfrm>
+            <a:off x="6996279" y="38921"/>
+            <a:ext cx="5298410" cy="1254083"/>
+            <a:chOff x="7661457" y="695741"/>
+            <a:chExt cx="4543293" cy="1254083"/>
+          </a:xfrm>
+        </p:grpSpPr>
+        <p:sp>
+          <p:nvSpPr>
+            <p:cNvPr id="5" name="Elipse 4">
+              <a:extLst>
+                <a:ext uri="{FF2B5EF4-FFF2-40B4-BE49-F238E27FC236}">
+                  <a16:creationId xmlns:a16="http://schemas.microsoft.com/office/drawing/2014/main" id="{805BAE73-7B0A-0431-C71A-E991BFE686C2}"/>
+                </a:ext>
+              </a:extLst>
+            </p:cNvPr>
+            <p:cNvSpPr/>
+            <p:nvPr/>
+          </p:nvSpPr>
+          <p:spPr>
+            <a:xfrm>
+              <a:off x="7661457" y="991441"/>
+              <a:ext cx="3984558" cy="958383"/>
+            </a:xfrm>
+            <a:prstGeom prst="ellipse">
+              <a:avLst/>
+            </a:prstGeom>
+            <a:solidFill>
+              <a:srgbClr val="CAD7EE"/>
+            </a:solidFill>
+            <a:ln w="38100"/>
+          </p:spPr>
+          <p:style>
+            <a:lnRef idx="2">
+              <a:schemeClr val="accent1">
+                <a:shade val="15000"/>
+              </a:schemeClr>
+            </a:lnRef>
+            <a:fillRef idx="1">
+              <a:schemeClr val="accent1"/>
+            </a:fillRef>
+            <a:effectRef idx="0">
+              <a:schemeClr val="accent1"/>
+            </a:effectRef>
+            <a:fontRef idx="minor">
+              <a:schemeClr val="lt1"/>
+            </a:fontRef>
+          </p:style>
+          <p:txBody>
+            <a:bodyPr rtlCol="0" anchor="ctr"/>
+            <a:lstStyle/>
+            <a:p>
+              <a:pPr algn="ctr"/>
+              <a:endParaRPr lang="en-US"/>
+            </a:p>
+          </p:txBody>
+        </p:sp>
+        <p:sp>
+          <p:nvSpPr>
+            <p:cNvPr id="6" name="CuadroTexto 5">
+              <a:extLst>
+                <a:ext uri="{FF2B5EF4-FFF2-40B4-BE49-F238E27FC236}">
+                  <a16:creationId xmlns:a16="http://schemas.microsoft.com/office/drawing/2014/main" id="{49170F35-471B-B43E-C98D-D728E13440A3}"/>
+                </a:ext>
+              </a:extLst>
+            </p:cNvPr>
+            <p:cNvSpPr txBox="1"/>
+            <p:nvPr/>
+          </p:nvSpPr>
+          <p:spPr>
+            <a:xfrm>
+              <a:off x="7758234" y="1276957"/>
+              <a:ext cx="4446516" cy="369332"/>
+            </a:xfrm>
+            <a:prstGeom prst="rect">
+              <a:avLst/>
+            </a:prstGeom>
+            <a:noFill/>
+          </p:spPr>
+          <p:txBody>
+            <a:bodyPr wrap="square" rtlCol="0">
+              <a:spAutoFit/>
+            </a:bodyPr>
+            <a:lstStyle/>
+            <a:p>
+              <a:r>
+                <a:rPr lang="en-US" dirty="0"/>
+                <a:t>names = [“Lionel </a:t>
+              </a:r>
+              <a:r>
+                <a:rPr lang="es-AR" dirty="0"/>
+                <a:t>”</a:t>
+              </a:r>
+              <a:r>
+                <a:rPr lang="en-US" dirty="0"/>
+                <a:t>, “Juli</a:t>
+              </a:r>
+              <a:r>
+                <a:rPr lang="es-AR" dirty="0" err="1"/>
+                <a:t>án</a:t>
+              </a:r>
+              <a:r>
+                <a:rPr lang="es-AR" dirty="0"/>
+                <a:t> ”, “Ángel ”, “</a:t>
+              </a:r>
+              <a:r>
+                <a:rPr lang="es-AR" dirty="0" err="1"/>
+                <a:t>Dibu</a:t>
+              </a:r>
+              <a:r>
+                <a:rPr lang="es-AR" dirty="0"/>
+                <a:t> “</a:t>
+              </a:r>
+              <a:r>
+                <a:rPr lang="en-US" dirty="0"/>
+                <a:t>]</a:t>
+              </a:r>
+            </a:p>
+          </p:txBody>
+        </p:sp>
+        <p:sp>
+          <p:nvSpPr>
+            <p:cNvPr id="10" name="CuadroTexto 9">
+              <a:extLst>
+                <a:ext uri="{FF2B5EF4-FFF2-40B4-BE49-F238E27FC236}">
+                  <a16:creationId xmlns:a16="http://schemas.microsoft.com/office/drawing/2014/main" id="{FDCD0343-65EE-0C26-9CC9-8424980F81A8}"/>
+                </a:ext>
+              </a:extLst>
+            </p:cNvPr>
+            <p:cNvSpPr txBox="1"/>
+            <p:nvPr/>
+          </p:nvSpPr>
+          <p:spPr>
+            <a:xfrm>
+              <a:off x="7896781" y="695741"/>
+              <a:ext cx="847164" cy="369332"/>
+            </a:xfrm>
+            <a:prstGeom prst="rect">
+              <a:avLst/>
+            </a:prstGeom>
+            <a:noFill/>
+          </p:spPr>
+          <p:txBody>
+            <a:bodyPr wrap="square" rtlCol="0">
+              <a:spAutoFit/>
+            </a:bodyPr>
+            <a:lstStyle/>
+            <a:p>
+              <a:r>
+                <a:rPr lang="en-US" dirty="0"/>
+                <a:t>Ln 1</a:t>
+              </a:r>
+            </a:p>
+          </p:txBody>
+        </p:sp>
+      </p:grpSp>
+      <p:grpSp>
+        <p:nvGrpSpPr>
+          <p:cNvPr id="11" name="Grupo 10">
+            <a:extLst>
+              <a:ext uri="{FF2B5EF4-FFF2-40B4-BE49-F238E27FC236}">
+                <a16:creationId xmlns:a16="http://schemas.microsoft.com/office/drawing/2014/main" id="{4E57EC02-10EA-AE81-AB27-4A2D87343F21}"/>
+              </a:ext>
+            </a:extLst>
+          </p:cNvPr>
+          <p:cNvGrpSpPr/>
+          <p:nvPr/>
+        </p:nvGrpSpPr>
+        <p:grpSpPr>
+          <a:xfrm rot="1017173">
+            <a:off x="5372715" y="2382051"/>
+            <a:ext cx="2337358" cy="2087943"/>
+            <a:chOff x="4312494" y="1392221"/>
+            <a:chExt cx="2564824" cy="2291137"/>
+          </a:xfrm>
+        </p:grpSpPr>
+        <p:sp>
+          <p:nvSpPr>
+            <p:cNvPr id="12" name="Forma libre: forma 11">
+              <a:extLst>
+                <a:ext uri="{FF2B5EF4-FFF2-40B4-BE49-F238E27FC236}">
+                  <a16:creationId xmlns:a16="http://schemas.microsoft.com/office/drawing/2014/main" id="{0A43655E-4B84-B703-F076-D809D02D1097}"/>
+                </a:ext>
+              </a:extLst>
+            </p:cNvPr>
+            <p:cNvSpPr/>
+            <p:nvPr/>
+          </p:nvSpPr>
+          <p:spPr>
+            <a:xfrm>
+              <a:off x="4312494" y="1532583"/>
+              <a:ext cx="2564824" cy="2150775"/>
+            </a:xfrm>
+            <a:custGeom>
+              <a:avLst/>
+              <a:gdLst>
+                <a:gd name="connsiteX0" fmla="*/ 2564824 w 2564824"/>
+                <a:gd name="connsiteY0" fmla="*/ 631068 h 2150775"/>
+                <a:gd name="connsiteX1" fmla="*/ 2126943 w 2564824"/>
+                <a:gd name="connsiteY1" fmla="*/ 1661378 h 2150775"/>
+                <a:gd name="connsiteX2" fmla="*/ 1882244 w 2564824"/>
+                <a:gd name="connsiteY2" fmla="*/ 1841682 h 2150775"/>
+                <a:gd name="connsiteX3" fmla="*/ 1624667 w 2564824"/>
+                <a:gd name="connsiteY3" fmla="*/ 1957592 h 2150775"/>
+                <a:gd name="connsiteX4" fmla="*/ 787540 w 2564824"/>
+                <a:gd name="connsiteY4" fmla="*/ 2150775 h 2150775"/>
+                <a:gd name="connsiteX5" fmla="*/ 607236 w 2564824"/>
+                <a:gd name="connsiteY5" fmla="*/ 2137896 h 2150775"/>
+                <a:gd name="connsiteX6" fmla="*/ 414052 w 2564824"/>
+                <a:gd name="connsiteY6" fmla="*/ 2021986 h 2150775"/>
+                <a:gd name="connsiteX7" fmla="*/ 27686 w 2564824"/>
+                <a:gd name="connsiteY7" fmla="*/ 1390921 h 2150775"/>
+                <a:gd name="connsiteX8" fmla="*/ 53444 w 2564824"/>
+                <a:gd name="connsiteY8" fmla="*/ 901524 h 2150775"/>
+                <a:gd name="connsiteX9" fmla="*/ 594357 w 2564824"/>
+                <a:gd name="connsiteY9" fmla="*/ 437885 h 2150775"/>
+                <a:gd name="connsiteX10" fmla="*/ 736024 w 2564824"/>
+                <a:gd name="connsiteY10" fmla="*/ 347732 h 2150775"/>
+                <a:gd name="connsiteX11" fmla="*/ 877692 w 2564824"/>
+                <a:gd name="connsiteY11" fmla="*/ 270459 h 2150775"/>
+                <a:gd name="connsiteX12" fmla="*/ 1238300 w 2564824"/>
+                <a:gd name="connsiteY12" fmla="*/ 128792 h 2150775"/>
+                <a:gd name="connsiteX13" fmla="*/ 1367089 w 2564824"/>
+                <a:gd name="connsiteY13" fmla="*/ 25761 h 2150775"/>
+                <a:gd name="connsiteX14" fmla="*/ 1444362 w 2564824"/>
+                <a:gd name="connsiteY14" fmla="*/ 12882 h 2150775"/>
+                <a:gd name="connsiteX15" fmla="*/ 1663303 w 2564824"/>
+                <a:gd name="connsiteY15" fmla="*/ 3 h 2150775"/>
+              </a:gdLst>
+              <a:ahLst/>
+              <a:cxnLst>
+                <a:cxn ang="0">
+                  <a:pos x="connsiteX0" y="connsiteY0"/>
+                </a:cxn>
+                <a:cxn ang="0">
+                  <a:pos x="connsiteX1" y="connsiteY1"/>
+                </a:cxn>
+                <a:cxn ang="0">
+                  <a:pos x="connsiteX2" y="connsiteY2"/>
+                </a:cxn>
+                <a:cxn ang="0">
+                  <a:pos x="connsiteX3" y="connsiteY3"/>
+                </a:cxn>
+                <a:cxn ang="0">
+                  <a:pos x="connsiteX4" y="connsiteY4"/>
+                </a:cxn>
+                <a:cxn ang="0">
+                  <a:pos x="connsiteX5" y="connsiteY5"/>
+                </a:cxn>
+                <a:cxn ang="0">
+                  <a:pos x="connsiteX6" y="connsiteY6"/>
+                </a:cxn>
+                <a:cxn ang="0">
+                  <a:pos x="connsiteX7" y="connsiteY7"/>
+                </a:cxn>
+                <a:cxn ang="0">
+                  <a:pos x="connsiteX8" y="connsiteY8"/>
+                </a:cxn>
+                <a:cxn ang="0">
+                  <a:pos x="connsiteX9" y="connsiteY9"/>
+                </a:cxn>
+                <a:cxn ang="0">
+                  <a:pos x="connsiteX10" y="connsiteY10"/>
+                </a:cxn>
+                <a:cxn ang="0">
+                  <a:pos x="connsiteX11" y="connsiteY11"/>
+                </a:cxn>
+                <a:cxn ang="0">
+                  <a:pos x="connsiteX12" y="connsiteY12"/>
+                </a:cxn>
+                <a:cxn ang="0">
+                  <a:pos x="connsiteX13" y="connsiteY13"/>
+                </a:cxn>
+                <a:cxn ang="0">
+                  <a:pos x="connsiteX14" y="connsiteY14"/>
+                </a:cxn>
+                <a:cxn ang="0">
+                  <a:pos x="connsiteX15" y="connsiteY15"/>
+                </a:cxn>
+              </a:cxnLst>
+              <a:rect l="l" t="t" r="r" b="b"/>
+              <a:pathLst>
+                <a:path w="2564824" h="2150775">
+                  <a:moveTo>
+                    <a:pt x="2564824" y="631068"/>
+                  </a:moveTo>
+                  <a:cubicBezTo>
+                    <a:pt x="2417431" y="1114191"/>
+                    <a:pt x="2443202" y="1345119"/>
+                    <a:pt x="2126943" y="1661378"/>
+                  </a:cubicBezTo>
+                  <a:cubicBezTo>
+                    <a:pt x="2055301" y="1733020"/>
+                    <a:pt x="1969515" y="1790214"/>
+                    <a:pt x="1882244" y="1841682"/>
+                  </a:cubicBezTo>
+                  <a:cubicBezTo>
+                    <a:pt x="1801145" y="1889510"/>
+                    <a:pt x="1715276" y="1932008"/>
+                    <a:pt x="1624667" y="1957592"/>
+                  </a:cubicBezTo>
+                  <a:cubicBezTo>
+                    <a:pt x="1349066" y="2035409"/>
+                    <a:pt x="787540" y="2150775"/>
+                    <a:pt x="787540" y="2150775"/>
+                  </a:cubicBezTo>
+                  <a:cubicBezTo>
+                    <a:pt x="727439" y="2146482"/>
+                    <a:pt x="664199" y="2157538"/>
+                    <a:pt x="607236" y="2137896"/>
+                  </a:cubicBezTo>
+                  <a:cubicBezTo>
+                    <a:pt x="536242" y="2113415"/>
+                    <a:pt x="466378" y="2075851"/>
+                    <a:pt x="414052" y="2021986"/>
+                  </a:cubicBezTo>
+                  <a:cubicBezTo>
+                    <a:pt x="203552" y="1805295"/>
+                    <a:pt x="150799" y="1648339"/>
+                    <a:pt x="27686" y="1390921"/>
+                  </a:cubicBezTo>
+                  <a:cubicBezTo>
+                    <a:pt x="11956" y="1257210"/>
+                    <a:pt x="-37734" y="1023895"/>
+                    <a:pt x="53444" y="901524"/>
+                  </a:cubicBezTo>
+                  <a:cubicBezTo>
+                    <a:pt x="77699" y="868972"/>
+                    <a:pt x="433922" y="547657"/>
+                    <a:pt x="594357" y="437885"/>
+                  </a:cubicBezTo>
+                  <a:cubicBezTo>
+                    <a:pt x="640552" y="406278"/>
+                    <a:pt x="687835" y="376207"/>
+                    <a:pt x="736024" y="347732"/>
+                  </a:cubicBezTo>
+                  <a:cubicBezTo>
+                    <a:pt x="782334" y="320367"/>
+                    <a:pt x="828382" y="291953"/>
+                    <a:pt x="877692" y="270459"/>
+                  </a:cubicBezTo>
+                  <a:cubicBezTo>
+                    <a:pt x="996079" y="218854"/>
+                    <a:pt x="1238300" y="128792"/>
+                    <a:pt x="1238300" y="128792"/>
+                  </a:cubicBezTo>
+                  <a:cubicBezTo>
+                    <a:pt x="1281230" y="94448"/>
+                    <a:pt x="1319173" y="52714"/>
+                    <a:pt x="1367089" y="25761"/>
+                  </a:cubicBezTo>
+                  <a:cubicBezTo>
+                    <a:pt x="1389848" y="12959"/>
+                    <a:pt x="1418367" y="15358"/>
+                    <a:pt x="1444362" y="12882"/>
+                  </a:cubicBezTo>
+                  <a:cubicBezTo>
+                    <a:pt x="1585587" y="-568"/>
+                    <a:pt x="1581060" y="3"/>
+                    <a:pt x="1663303" y="3"/>
+                  </a:cubicBezTo>
+                </a:path>
+              </a:pathLst>
+            </a:custGeom>
+            <a:noFill/>
+            <a:ln w="57150">
+              <a:solidFill>
+                <a:srgbClr val="791179"/>
+              </a:solidFill>
+            </a:ln>
+          </p:spPr>
+          <p:style>
+            <a:lnRef idx="2">
+              <a:schemeClr val="accent1">
+                <a:shade val="15000"/>
+              </a:schemeClr>
+            </a:lnRef>
+            <a:fillRef idx="1">
+              <a:schemeClr val="accent1"/>
+            </a:fillRef>
+            <a:effectRef idx="0">
+              <a:schemeClr val="accent1"/>
+            </a:effectRef>
+            <a:fontRef idx="minor">
+              <a:schemeClr val="lt1"/>
+            </a:fontRef>
+          </p:style>
+          <p:txBody>
+            <a:bodyPr rtlCol="0" anchor="ctr"/>
+            <a:lstStyle/>
+            <a:p>
+              <a:pPr algn="ctr"/>
+              <a:endParaRPr lang="en-US">
+                <a:solidFill>
+                  <a:srgbClr val="791179"/>
+                </a:solidFill>
+              </a:endParaRPr>
+            </a:p>
+          </p:txBody>
+        </p:sp>
+        <p:sp>
+          <p:nvSpPr>
+            <p:cNvPr id="13" name="Forma libre: forma 12">
+              <a:extLst>
+                <a:ext uri="{FF2B5EF4-FFF2-40B4-BE49-F238E27FC236}">
+                  <a16:creationId xmlns:a16="http://schemas.microsoft.com/office/drawing/2014/main" id="{05C4AE3E-C66C-FF03-45F1-920FADF3B70C}"/>
+                </a:ext>
+              </a:extLst>
+            </p:cNvPr>
+            <p:cNvSpPr/>
+            <p:nvPr/>
+          </p:nvSpPr>
+          <p:spPr>
+            <a:xfrm rot="1067707">
+              <a:off x="5579942" y="1392221"/>
+              <a:ext cx="416126" cy="371948"/>
+            </a:xfrm>
+            <a:custGeom>
+              <a:avLst/>
+              <a:gdLst>
+                <a:gd name="connsiteX0" fmla="*/ 0 w 188119"/>
+                <a:gd name="connsiteY0" fmla="*/ 0 h 211932"/>
+                <a:gd name="connsiteX1" fmla="*/ 109537 w 188119"/>
+                <a:gd name="connsiteY1" fmla="*/ 26194 h 211932"/>
+                <a:gd name="connsiteX2" fmla="*/ 133350 w 188119"/>
+                <a:gd name="connsiteY2" fmla="*/ 38100 h 211932"/>
+                <a:gd name="connsiteX3" fmla="*/ 159544 w 188119"/>
+                <a:gd name="connsiteY3" fmla="*/ 50007 h 211932"/>
+                <a:gd name="connsiteX4" fmla="*/ 180975 w 188119"/>
+                <a:gd name="connsiteY4" fmla="*/ 54769 h 211932"/>
+                <a:gd name="connsiteX5" fmla="*/ 188119 w 188119"/>
+                <a:gd name="connsiteY5" fmla="*/ 57150 h 211932"/>
+                <a:gd name="connsiteX6" fmla="*/ 140494 w 188119"/>
+                <a:gd name="connsiteY6" fmla="*/ 121444 h 211932"/>
+                <a:gd name="connsiteX7" fmla="*/ 123825 w 188119"/>
+                <a:gd name="connsiteY7" fmla="*/ 140494 h 211932"/>
+                <a:gd name="connsiteX8" fmla="*/ 102394 w 188119"/>
+                <a:gd name="connsiteY8" fmla="*/ 150019 h 211932"/>
+                <a:gd name="connsiteX9" fmla="*/ 80962 w 188119"/>
+                <a:gd name="connsiteY9" fmla="*/ 173832 h 211932"/>
+                <a:gd name="connsiteX10" fmla="*/ 73819 w 188119"/>
+                <a:gd name="connsiteY10" fmla="*/ 180975 h 211932"/>
+                <a:gd name="connsiteX11" fmla="*/ 69056 w 188119"/>
+                <a:gd name="connsiteY11" fmla="*/ 190500 h 211932"/>
+                <a:gd name="connsiteX12" fmla="*/ 61912 w 188119"/>
+                <a:gd name="connsiteY12" fmla="*/ 202407 h 211932"/>
+                <a:gd name="connsiteX13" fmla="*/ 52387 w 188119"/>
+                <a:gd name="connsiteY13" fmla="*/ 211932 h 211932"/>
+              </a:gdLst>
+              <a:ahLst/>
+              <a:cxnLst>
+                <a:cxn ang="0">
+                  <a:pos x="connsiteX0" y="connsiteY0"/>
+                </a:cxn>
+                <a:cxn ang="0">
+                  <a:pos x="connsiteX1" y="connsiteY1"/>
+                </a:cxn>
+                <a:cxn ang="0">
+                  <a:pos x="connsiteX2" y="connsiteY2"/>
+                </a:cxn>
+                <a:cxn ang="0">
+                  <a:pos x="connsiteX3" y="connsiteY3"/>
+                </a:cxn>
+                <a:cxn ang="0">
+                  <a:pos x="connsiteX4" y="connsiteY4"/>
+                </a:cxn>
+                <a:cxn ang="0">
+                  <a:pos x="connsiteX5" y="connsiteY5"/>
+                </a:cxn>
+                <a:cxn ang="0">
+                  <a:pos x="connsiteX6" y="connsiteY6"/>
+                </a:cxn>
+                <a:cxn ang="0">
+                  <a:pos x="connsiteX7" y="connsiteY7"/>
+                </a:cxn>
+                <a:cxn ang="0">
+                  <a:pos x="connsiteX8" y="connsiteY8"/>
+                </a:cxn>
+                <a:cxn ang="0">
+                  <a:pos x="connsiteX9" y="connsiteY9"/>
+                </a:cxn>
+                <a:cxn ang="0">
+                  <a:pos x="connsiteX10" y="connsiteY10"/>
+                </a:cxn>
+                <a:cxn ang="0">
+                  <a:pos x="connsiteX11" y="connsiteY11"/>
+                </a:cxn>
+                <a:cxn ang="0">
+                  <a:pos x="connsiteX12" y="connsiteY12"/>
+                </a:cxn>
+                <a:cxn ang="0">
+                  <a:pos x="connsiteX13" y="connsiteY13"/>
+                </a:cxn>
+              </a:cxnLst>
+              <a:rect l="l" t="t" r="r" b="b"/>
+              <a:pathLst>
+                <a:path w="188119" h="211932">
+                  <a:moveTo>
+                    <a:pt x="0" y="0"/>
+                  </a:moveTo>
+                  <a:cubicBezTo>
+                    <a:pt x="59974" y="11996"/>
+                    <a:pt x="54255" y="9184"/>
+                    <a:pt x="109537" y="26194"/>
+                  </a:cubicBezTo>
+                  <a:cubicBezTo>
+                    <a:pt x="125437" y="31086"/>
+                    <a:pt x="118108" y="30479"/>
+                    <a:pt x="133350" y="38100"/>
+                  </a:cubicBezTo>
+                  <a:cubicBezTo>
+                    <a:pt x="141929" y="42389"/>
+                    <a:pt x="150639" y="46445"/>
+                    <a:pt x="159544" y="50007"/>
+                  </a:cubicBezTo>
+                  <a:cubicBezTo>
+                    <a:pt x="163616" y="51636"/>
+                    <a:pt x="177459" y="53890"/>
+                    <a:pt x="180975" y="54769"/>
+                  </a:cubicBezTo>
+                  <a:cubicBezTo>
+                    <a:pt x="183410" y="55378"/>
+                    <a:pt x="185738" y="56356"/>
+                    <a:pt x="188119" y="57150"/>
+                  </a:cubicBezTo>
+                  <a:cubicBezTo>
+                    <a:pt x="187294" y="58275"/>
+                    <a:pt x="144649" y="116696"/>
+                    <a:pt x="140494" y="121444"/>
+                  </a:cubicBezTo>
+                  <a:cubicBezTo>
+                    <a:pt x="134938" y="127794"/>
+                    <a:pt x="130575" y="135431"/>
+                    <a:pt x="123825" y="140494"/>
+                  </a:cubicBezTo>
+                  <a:cubicBezTo>
+                    <a:pt x="117571" y="145184"/>
+                    <a:pt x="109538" y="146844"/>
+                    <a:pt x="102394" y="150019"/>
+                  </a:cubicBezTo>
+                  <a:cubicBezTo>
+                    <a:pt x="76108" y="176303"/>
+                    <a:pt x="103760" y="147776"/>
+                    <a:pt x="80962" y="173832"/>
+                  </a:cubicBezTo>
+                  <a:cubicBezTo>
+                    <a:pt x="78745" y="176366"/>
+                    <a:pt x="75776" y="178235"/>
+                    <a:pt x="73819" y="180975"/>
+                  </a:cubicBezTo>
+                  <a:cubicBezTo>
+                    <a:pt x="71756" y="183864"/>
+                    <a:pt x="70780" y="187397"/>
+                    <a:pt x="69056" y="190500"/>
+                  </a:cubicBezTo>
+                  <a:cubicBezTo>
+                    <a:pt x="66808" y="194546"/>
+                    <a:pt x="64689" y="198704"/>
+                    <a:pt x="61912" y="202407"/>
+                  </a:cubicBezTo>
+                  <a:cubicBezTo>
+                    <a:pt x="59218" y="205999"/>
+                    <a:pt x="55562" y="208757"/>
+                    <a:pt x="52387" y="211932"/>
+                  </a:cubicBezTo>
+                </a:path>
+              </a:pathLst>
+            </a:custGeom>
+            <a:noFill/>
+            <a:ln w="57150">
+              <a:solidFill>
+                <a:srgbClr val="8A008A"/>
+              </a:solidFill>
+            </a:ln>
+          </p:spPr>
+          <p:style>
+            <a:lnRef idx="2">
+              <a:schemeClr val="accent1">
+                <a:shade val="15000"/>
+              </a:schemeClr>
+            </a:lnRef>
+            <a:fillRef idx="1">
+              <a:schemeClr val="accent1"/>
+            </a:fillRef>
+            <a:effectRef idx="0">
+              <a:schemeClr val="accent1"/>
+            </a:effectRef>
+            <a:fontRef idx="minor">
+              <a:schemeClr val="lt1"/>
+            </a:fontRef>
+          </p:style>
+          <p:txBody>
+            <a:bodyPr rtlCol="0" anchor="ctr"/>
+            <a:lstStyle/>
+            <a:p>
+              <a:pPr algn="ctr"/>
+              <a:endParaRPr lang="en-US">
+                <a:solidFill>
+                  <a:srgbClr val="791179"/>
+                </a:solidFill>
+              </a:endParaRPr>
+            </a:p>
+          </p:txBody>
+        </p:sp>
+      </p:grpSp>
+      <p:sp>
+        <p:nvSpPr>
+          <p:cNvPr id="14" name="CuadroTexto 13">
+            <a:extLst>
+              <a:ext uri="{FF2B5EF4-FFF2-40B4-BE49-F238E27FC236}">
+                <a16:creationId xmlns:a16="http://schemas.microsoft.com/office/drawing/2014/main" id="{D250F5E4-8123-2B1F-14F1-766EB1F2702E}"/>
+              </a:ext>
+            </a:extLst>
+          </p:cNvPr>
+          <p:cNvSpPr txBox="1"/>
+          <p:nvPr/>
+        </p:nvSpPr>
+        <p:spPr>
+          <a:xfrm>
+            <a:off x="6983290" y="4105348"/>
+            <a:ext cx="361682" cy="769441"/>
+          </a:xfrm>
+          <a:prstGeom prst="rect">
+            <a:avLst/>
+          </a:prstGeom>
+          <a:noFill/>
+        </p:spPr>
+        <p:txBody>
+          <a:bodyPr wrap="square" rtlCol="0">
+            <a:spAutoFit/>
+          </a:bodyPr>
+          <a:lstStyle/>
+          <a:p>
+            <a:r>
+              <a:rPr lang="en-US" sz="4400" b="1" dirty="0">
+                <a:solidFill>
+                  <a:srgbClr val="00B050"/>
+                </a:solidFill>
+              </a:rPr>
+              <a:t>T</a:t>
+            </a:r>
+          </a:p>
+        </p:txBody>
+      </p:sp>
+      <p:sp>
+        <p:nvSpPr>
+          <p:cNvPr id="15" name="CuadroTexto 14">
+            <a:extLst>
+              <a:ext uri="{FF2B5EF4-FFF2-40B4-BE49-F238E27FC236}">
+                <a16:creationId xmlns:a16="http://schemas.microsoft.com/office/drawing/2014/main" id="{ABAD1CCF-9465-773F-4FD5-E8E35311347A}"/>
+              </a:ext>
+            </a:extLst>
+          </p:cNvPr>
+          <p:cNvSpPr txBox="1"/>
+          <p:nvPr/>
+        </p:nvSpPr>
+        <p:spPr>
+          <a:xfrm>
+            <a:off x="11199788" y="3877657"/>
+            <a:ext cx="583841" cy="769441"/>
+          </a:xfrm>
+          <a:prstGeom prst="rect">
+            <a:avLst/>
+          </a:prstGeom>
+          <a:noFill/>
+        </p:spPr>
+        <p:txBody>
+          <a:bodyPr wrap="square" rtlCol="0">
+            <a:spAutoFit/>
+          </a:bodyPr>
+          <a:lstStyle/>
+          <a:p>
+            <a:r>
+              <a:rPr lang="en-US" sz="4400" b="1" dirty="0">
+                <a:solidFill>
+                  <a:srgbClr val="FF0000"/>
+                </a:solidFill>
+              </a:rPr>
+              <a:t>F</a:t>
+            </a:r>
+          </a:p>
+        </p:txBody>
+      </p:sp>
+      <p:grpSp>
+        <p:nvGrpSpPr>
+          <p:cNvPr id="18" name="Grupo 17">
+            <a:extLst>
+              <a:ext uri="{FF2B5EF4-FFF2-40B4-BE49-F238E27FC236}">
+                <a16:creationId xmlns:a16="http://schemas.microsoft.com/office/drawing/2014/main" id="{474495B0-F067-D9FA-6172-91B76D3F8A91}"/>
+              </a:ext>
+            </a:extLst>
+          </p:cNvPr>
+          <p:cNvGrpSpPr/>
+          <p:nvPr/>
+        </p:nvGrpSpPr>
+        <p:grpSpPr>
+          <a:xfrm>
+            <a:off x="6983290" y="2512539"/>
+            <a:ext cx="4791515" cy="1254083"/>
+            <a:chOff x="7661457" y="695741"/>
+            <a:chExt cx="4112709" cy="1254083"/>
+          </a:xfrm>
+        </p:grpSpPr>
+        <p:sp>
+          <p:nvSpPr>
+            <p:cNvPr id="19" name="Elipse 18">
+              <a:extLst>
+                <a:ext uri="{FF2B5EF4-FFF2-40B4-BE49-F238E27FC236}">
+                  <a16:creationId xmlns:a16="http://schemas.microsoft.com/office/drawing/2014/main" id="{DD2D3AA8-94CD-3D57-BA46-44AF58ACF415}"/>
+                </a:ext>
+              </a:extLst>
+            </p:cNvPr>
+            <p:cNvSpPr/>
+            <p:nvPr/>
+          </p:nvSpPr>
+          <p:spPr>
+            <a:xfrm>
+              <a:off x="7661457" y="991441"/>
+              <a:ext cx="3984558" cy="958383"/>
+            </a:xfrm>
+            <a:prstGeom prst="ellipse">
+              <a:avLst/>
+            </a:prstGeom>
+            <a:solidFill>
+              <a:srgbClr val="CAD7EE"/>
+            </a:solidFill>
+            <a:ln w="38100"/>
+          </p:spPr>
+          <p:style>
+            <a:lnRef idx="2">
+              <a:schemeClr val="accent1">
+                <a:shade val="15000"/>
+              </a:schemeClr>
+            </a:lnRef>
+            <a:fillRef idx="1">
+              <a:schemeClr val="accent1"/>
+            </a:fillRef>
+            <a:effectRef idx="0">
+              <a:schemeClr val="accent1"/>
+            </a:effectRef>
+            <a:fontRef idx="minor">
+              <a:schemeClr val="lt1"/>
+            </a:fontRef>
+          </p:style>
+          <p:txBody>
+            <a:bodyPr rtlCol="0" anchor="ctr"/>
+            <a:lstStyle/>
+            <a:p>
+              <a:pPr algn="ctr"/>
+              <a:endParaRPr lang="en-US"/>
+            </a:p>
+          </p:txBody>
+        </p:sp>
+        <p:sp>
+          <p:nvSpPr>
+            <p:cNvPr id="20" name="CuadroTexto 19">
+              <a:extLst>
+                <a:ext uri="{FF2B5EF4-FFF2-40B4-BE49-F238E27FC236}">
+                  <a16:creationId xmlns:a16="http://schemas.microsoft.com/office/drawing/2014/main" id="{537AF89A-1446-B4FB-CA2B-7FC450A0DEB8}"/>
+                </a:ext>
+              </a:extLst>
+            </p:cNvPr>
+            <p:cNvSpPr txBox="1"/>
+            <p:nvPr/>
+          </p:nvSpPr>
+          <p:spPr>
+            <a:xfrm>
+              <a:off x="7772002" y="1276957"/>
+              <a:ext cx="4002164" cy="369332"/>
+            </a:xfrm>
+            <a:prstGeom prst="rect">
+              <a:avLst/>
+            </a:prstGeom>
+            <a:noFill/>
+          </p:spPr>
+          <p:txBody>
+            <a:bodyPr wrap="square" rtlCol="0">
+              <a:spAutoFit/>
+            </a:bodyPr>
+            <a:lstStyle/>
+            <a:p>
+              <a:r>
+                <a:rPr lang="en-US" dirty="0"/>
+                <a:t>surnames = [“Messi”, “Juli</a:t>
+              </a:r>
+              <a:r>
+                <a:rPr lang="es-AR" dirty="0" err="1"/>
+                <a:t>án</a:t>
+              </a:r>
+              <a:r>
+                <a:rPr lang="es-AR" dirty="0"/>
+                <a:t>”, “Ángel”, “</a:t>
+              </a:r>
+              <a:r>
+                <a:rPr lang="es-AR" dirty="0" err="1"/>
+                <a:t>Dibu</a:t>
+              </a:r>
+              <a:r>
+                <a:rPr lang="es-AR" dirty="0"/>
+                <a:t>”</a:t>
+              </a:r>
+              <a:r>
+                <a:rPr lang="en-US" dirty="0"/>
+                <a:t>]</a:t>
+              </a:r>
+            </a:p>
+          </p:txBody>
+        </p:sp>
+        <p:sp>
+          <p:nvSpPr>
+            <p:cNvPr id="21" name="CuadroTexto 20">
+              <a:extLst>
+                <a:ext uri="{FF2B5EF4-FFF2-40B4-BE49-F238E27FC236}">
+                  <a16:creationId xmlns:a16="http://schemas.microsoft.com/office/drawing/2014/main" id="{7B1BF814-4E68-4A75-5D21-919E2E7338E9}"/>
+                </a:ext>
+              </a:extLst>
+            </p:cNvPr>
+            <p:cNvSpPr txBox="1"/>
+            <p:nvPr/>
+          </p:nvSpPr>
+          <p:spPr>
+            <a:xfrm>
+              <a:off x="7896781" y="695741"/>
+              <a:ext cx="847164" cy="369332"/>
+            </a:xfrm>
+            <a:prstGeom prst="rect">
+              <a:avLst/>
+            </a:prstGeom>
+            <a:noFill/>
+          </p:spPr>
+          <p:txBody>
+            <a:bodyPr wrap="square" rtlCol="0">
+              <a:spAutoFit/>
+            </a:bodyPr>
+            <a:lstStyle/>
+            <a:p>
+              <a:r>
+                <a:rPr lang="en-US" dirty="0"/>
+                <a:t>Ln 2</a:t>
+              </a:r>
+            </a:p>
+          </p:txBody>
+        </p:sp>
+      </p:grpSp>
+      <p:sp>
+        <p:nvSpPr>
+          <p:cNvPr id="16" name="Forma libre: forma 15">
+            <a:extLst>
+              <a:ext uri="{FF2B5EF4-FFF2-40B4-BE49-F238E27FC236}">
+                <a16:creationId xmlns:a16="http://schemas.microsoft.com/office/drawing/2014/main" id="{66470DD3-D181-470D-6D8C-4FCB5EF0BC7E}"/>
+              </a:ext>
+            </a:extLst>
+          </p:cNvPr>
+          <p:cNvSpPr/>
+          <p:nvPr/>
+        </p:nvSpPr>
+        <p:spPr>
+          <a:xfrm>
+            <a:off x="391405" y="1900135"/>
+            <a:ext cx="747686" cy="1769502"/>
+          </a:xfrm>
+          <a:custGeom>
+            <a:avLst/>
+            <a:gdLst>
+              <a:gd name="connsiteX0" fmla="*/ 1268696 w 1907325"/>
+              <a:gd name="connsiteY0" fmla="*/ 0 h 4513942"/>
+              <a:gd name="connsiteX1" fmla="*/ 1544467 w 1907325"/>
+              <a:gd name="connsiteY1" fmla="*/ 348342 h 4513942"/>
+              <a:gd name="connsiteX2" fmla="*/ 1762181 w 1907325"/>
+              <a:gd name="connsiteY2" fmla="*/ 914400 h 4513942"/>
+              <a:gd name="connsiteX3" fmla="*/ 1776696 w 1907325"/>
+              <a:gd name="connsiteY3" fmla="*/ 1524000 h 4513942"/>
+              <a:gd name="connsiteX4" fmla="*/ 1500924 w 1907325"/>
+              <a:gd name="connsiteY4" fmla="*/ 2206171 h 4513942"/>
+              <a:gd name="connsiteX5" fmla="*/ 1297724 w 1907325"/>
+              <a:gd name="connsiteY5" fmla="*/ 2496457 h 4513942"/>
+              <a:gd name="connsiteX6" fmla="*/ 572010 w 1907325"/>
+              <a:gd name="connsiteY6" fmla="*/ 2772228 h 4513942"/>
+              <a:gd name="connsiteX7" fmla="*/ 281724 w 1907325"/>
+              <a:gd name="connsiteY7" fmla="*/ 2714171 h 4513942"/>
+              <a:gd name="connsiteX8" fmla="*/ 5953 w 1907325"/>
+              <a:gd name="connsiteY8" fmla="*/ 2119085 h 4513942"/>
+              <a:gd name="connsiteX9" fmla="*/ 20467 w 1907325"/>
+              <a:gd name="connsiteY9" fmla="*/ 1640114 h 4513942"/>
+              <a:gd name="connsiteX10" fmla="*/ 194638 w 1907325"/>
+              <a:gd name="connsiteY10" fmla="*/ 1364342 h 4513942"/>
+              <a:gd name="connsiteX11" fmla="*/ 891324 w 1907325"/>
+              <a:gd name="connsiteY11" fmla="*/ 1088571 h 4513942"/>
+              <a:gd name="connsiteX12" fmla="*/ 1181610 w 1907325"/>
+              <a:gd name="connsiteY12" fmla="*/ 1059542 h 4513942"/>
+              <a:gd name="connsiteX13" fmla="*/ 1370296 w 1907325"/>
+              <a:gd name="connsiteY13" fmla="*/ 1103085 h 4513942"/>
+              <a:gd name="connsiteX14" fmla="*/ 1646067 w 1907325"/>
+              <a:gd name="connsiteY14" fmla="*/ 1320800 h 4513942"/>
+              <a:gd name="connsiteX15" fmla="*/ 1747667 w 1907325"/>
+              <a:gd name="connsiteY15" fmla="*/ 1640114 h 4513942"/>
+              <a:gd name="connsiteX16" fmla="*/ 1892810 w 1907325"/>
+              <a:gd name="connsiteY16" fmla="*/ 2249714 h 4513942"/>
+              <a:gd name="connsiteX17" fmla="*/ 1805724 w 1907325"/>
+              <a:gd name="connsiteY17" fmla="*/ 3135085 h 4513942"/>
+              <a:gd name="connsiteX18" fmla="*/ 1660581 w 1907325"/>
+              <a:gd name="connsiteY18" fmla="*/ 3614057 h 4513942"/>
+              <a:gd name="connsiteX19" fmla="*/ 1399324 w 1907325"/>
+              <a:gd name="connsiteY19" fmla="*/ 3947885 h 4513942"/>
+              <a:gd name="connsiteX20" fmla="*/ 1283210 w 1907325"/>
+              <a:gd name="connsiteY20" fmla="*/ 4122057 h 4513942"/>
+              <a:gd name="connsiteX21" fmla="*/ 1196124 w 1907325"/>
+              <a:gd name="connsiteY21" fmla="*/ 4397828 h 4513942"/>
+              <a:gd name="connsiteX22" fmla="*/ 1152581 w 1907325"/>
+              <a:gd name="connsiteY22" fmla="*/ 4513942 h 4513942"/>
+            </a:gdLst>
+            <a:ahLst/>
+            <a:cxnLst>
+              <a:cxn ang="0">
+                <a:pos x="connsiteX0" y="connsiteY0"/>
+              </a:cxn>
+              <a:cxn ang="0">
+                <a:pos x="connsiteX1" y="connsiteY1"/>
+              </a:cxn>
+              <a:cxn ang="0">
+                <a:pos x="connsiteX2" y="connsiteY2"/>
+              </a:cxn>
+              <a:cxn ang="0">
+                <a:pos x="connsiteX3" y="connsiteY3"/>
+              </a:cxn>
+              <a:cxn ang="0">
+                <a:pos x="connsiteX4" y="connsiteY4"/>
+              </a:cxn>
+              <a:cxn ang="0">
+                <a:pos x="connsiteX5" y="connsiteY5"/>
+              </a:cxn>
+              <a:cxn ang="0">
+                <a:pos x="connsiteX6" y="connsiteY6"/>
+              </a:cxn>
+              <a:cxn ang="0">
+                <a:pos x="connsiteX7" y="connsiteY7"/>
+              </a:cxn>
+              <a:cxn ang="0">
+                <a:pos x="connsiteX8" y="connsiteY8"/>
+              </a:cxn>
+              <a:cxn ang="0">
+                <a:pos x="connsiteX9" y="connsiteY9"/>
+              </a:cxn>
+              <a:cxn ang="0">
+                <a:pos x="connsiteX10" y="connsiteY10"/>
+              </a:cxn>
+              <a:cxn ang="0">
+                <a:pos x="connsiteX11" y="connsiteY11"/>
+              </a:cxn>
+              <a:cxn ang="0">
+                <a:pos x="connsiteX12" y="connsiteY12"/>
+              </a:cxn>
+              <a:cxn ang="0">
+                <a:pos x="connsiteX13" y="connsiteY13"/>
+              </a:cxn>
+              <a:cxn ang="0">
+                <a:pos x="connsiteX14" y="connsiteY14"/>
+              </a:cxn>
+              <a:cxn ang="0">
+                <a:pos x="connsiteX15" y="connsiteY15"/>
+              </a:cxn>
+              <a:cxn ang="0">
+                <a:pos x="connsiteX16" y="connsiteY16"/>
+              </a:cxn>
+              <a:cxn ang="0">
+                <a:pos x="connsiteX17" y="connsiteY17"/>
+              </a:cxn>
+              <a:cxn ang="0">
+                <a:pos x="connsiteX18" y="connsiteY18"/>
+              </a:cxn>
+              <a:cxn ang="0">
+                <a:pos x="connsiteX19" y="connsiteY19"/>
+              </a:cxn>
+              <a:cxn ang="0">
+                <a:pos x="connsiteX20" y="connsiteY20"/>
+              </a:cxn>
+              <a:cxn ang="0">
+                <a:pos x="connsiteX21" y="connsiteY21"/>
+              </a:cxn>
+              <a:cxn ang="0">
+                <a:pos x="connsiteX22" y="connsiteY22"/>
+              </a:cxn>
+            </a:cxnLst>
+            <a:rect l="l" t="t" r="r" b="b"/>
+            <a:pathLst>
+              <a:path w="1907325" h="4513942">
+                <a:moveTo>
+                  <a:pt x="1268696" y="0"/>
+                </a:moveTo>
+                <a:cubicBezTo>
+                  <a:pt x="1442773" y="124340"/>
+                  <a:pt x="1389854" y="67227"/>
+                  <a:pt x="1544467" y="348342"/>
+                </a:cubicBezTo>
+                <a:cubicBezTo>
+                  <a:pt x="1699367" y="629979"/>
+                  <a:pt x="1682866" y="628863"/>
+                  <a:pt x="1762181" y="914400"/>
+                </a:cubicBezTo>
+                <a:cubicBezTo>
+                  <a:pt x="1776471" y="1078734"/>
+                  <a:pt x="1815799" y="1351947"/>
+                  <a:pt x="1776696" y="1524000"/>
+                </a:cubicBezTo>
+                <a:cubicBezTo>
+                  <a:pt x="1747705" y="1651561"/>
+                  <a:pt x="1570804" y="2083882"/>
+                  <a:pt x="1500924" y="2206171"/>
+                </a:cubicBezTo>
+                <a:cubicBezTo>
+                  <a:pt x="1442324" y="2308722"/>
+                  <a:pt x="1384895" y="2416758"/>
+                  <a:pt x="1297724" y="2496457"/>
+                </a:cubicBezTo>
+                <a:cubicBezTo>
+                  <a:pt x="1086760" y="2689339"/>
+                  <a:pt x="836364" y="2708418"/>
+                  <a:pt x="572010" y="2772228"/>
+                </a:cubicBezTo>
+                <a:cubicBezTo>
+                  <a:pt x="475248" y="2752876"/>
+                  <a:pt x="368793" y="2760608"/>
+                  <a:pt x="281724" y="2714171"/>
+                </a:cubicBezTo>
+                <a:cubicBezTo>
+                  <a:pt x="101836" y="2618231"/>
+                  <a:pt x="43703" y="2240724"/>
+                  <a:pt x="5953" y="2119085"/>
+                </a:cubicBezTo>
+                <a:cubicBezTo>
+                  <a:pt x="10791" y="1959428"/>
+                  <a:pt x="-18273" y="1795075"/>
+                  <a:pt x="20467" y="1640114"/>
+                </a:cubicBezTo>
+                <a:cubicBezTo>
+                  <a:pt x="46836" y="1534637"/>
+                  <a:pt x="119120" y="1442557"/>
+                  <a:pt x="194638" y="1364342"/>
+                </a:cubicBezTo>
+                <a:cubicBezTo>
+                  <a:pt x="353037" y="1200286"/>
+                  <a:pt x="709339" y="1127068"/>
+                  <a:pt x="891324" y="1088571"/>
+                </a:cubicBezTo>
+                <a:cubicBezTo>
+                  <a:pt x="986463" y="1068445"/>
+                  <a:pt x="1084848" y="1069218"/>
+                  <a:pt x="1181610" y="1059542"/>
+                </a:cubicBezTo>
+                <a:cubicBezTo>
+                  <a:pt x="1244505" y="1074056"/>
+                  <a:pt x="1310554" y="1078645"/>
+                  <a:pt x="1370296" y="1103085"/>
+                </a:cubicBezTo>
+                <a:cubicBezTo>
+                  <a:pt x="1458125" y="1139015"/>
+                  <a:pt x="1582620" y="1263698"/>
+                  <a:pt x="1646067" y="1320800"/>
+                </a:cubicBezTo>
+                <a:cubicBezTo>
+                  <a:pt x="1679934" y="1427238"/>
+                  <a:pt x="1718992" y="1532161"/>
+                  <a:pt x="1747667" y="1640114"/>
+                </a:cubicBezTo>
+                <a:cubicBezTo>
+                  <a:pt x="1801291" y="1841994"/>
+                  <a:pt x="1892810" y="2249714"/>
+                  <a:pt x="1892810" y="2249714"/>
+                </a:cubicBezTo>
+                <a:cubicBezTo>
+                  <a:pt x="1912101" y="2693420"/>
+                  <a:pt x="1933113" y="2603050"/>
+                  <a:pt x="1805724" y="3135085"/>
+                </a:cubicBezTo>
+                <a:cubicBezTo>
+                  <a:pt x="1766878" y="3297326"/>
+                  <a:pt x="1735188" y="3464843"/>
+                  <a:pt x="1660581" y="3614057"/>
+                </a:cubicBezTo>
+                <a:cubicBezTo>
+                  <a:pt x="1597389" y="3740441"/>
+                  <a:pt x="1483586" y="3834456"/>
+                  <a:pt x="1399324" y="3947885"/>
+                </a:cubicBezTo>
+                <a:cubicBezTo>
+                  <a:pt x="1357715" y="4003897"/>
+                  <a:pt x="1321915" y="4064000"/>
+                  <a:pt x="1283210" y="4122057"/>
+                </a:cubicBezTo>
+                <a:cubicBezTo>
+                  <a:pt x="1254181" y="4213981"/>
+                  <a:pt x="1226608" y="4306377"/>
+                  <a:pt x="1196124" y="4397828"/>
+                </a:cubicBezTo>
+                <a:cubicBezTo>
+                  <a:pt x="1183052" y="4437043"/>
+                  <a:pt x="1152581" y="4513942"/>
+                  <a:pt x="1152581" y="4513942"/>
+                </a:cubicBezTo>
+              </a:path>
+            </a:pathLst>
+          </a:custGeom>
+          <a:noFill/>
+          <a:ln w="76200"/>
+        </p:spPr>
+        <p:style>
+          <a:lnRef idx="2">
+            <a:schemeClr val="accent1">
+              <a:shade val="15000"/>
+            </a:schemeClr>
+          </a:lnRef>
+          <a:fillRef idx="1">
+            <a:schemeClr val="accent1"/>
+          </a:fillRef>
+          <a:effectRef idx="0">
+            <a:schemeClr val="accent1"/>
+          </a:effectRef>
+          <a:fontRef idx="minor">
+            <a:schemeClr val="lt1"/>
+          </a:fontRef>
+        </p:style>
+        <p:txBody>
+          <a:bodyPr rtlCol="0" anchor="ctr"/>
+          <a:lstStyle/>
+          <a:p>
+            <a:pPr algn="ctr"/>
+            <a:endParaRPr lang="en-US"/>
+          </a:p>
+        </p:txBody>
+      </p:sp>
+      <p:sp>
+        <p:nvSpPr>
+          <p:cNvPr id="24" name="Título 1">
+            <a:extLst>
+              <a:ext uri="{FF2B5EF4-FFF2-40B4-BE49-F238E27FC236}">
+                <a16:creationId xmlns:a16="http://schemas.microsoft.com/office/drawing/2014/main" id="{B984BF73-AD8E-0E80-2353-3C1CB3C4777F}"/>
+              </a:ext>
+            </a:extLst>
+          </p:cNvPr>
+          <p:cNvSpPr txBox="1">
+            <a:spLocks/>
+          </p:cNvSpPr>
+          <p:nvPr/>
+        </p:nvSpPr>
+        <p:spPr>
+          <a:xfrm>
+            <a:off x="129860" y="365125"/>
+            <a:ext cx="6853430" cy="1174941"/>
+          </a:xfrm>
+          <a:prstGeom prst="rect">
+            <a:avLst/>
+          </a:prstGeom>
+        </p:spPr>
+        <p:txBody>
+          <a:bodyPr vert="horz" lIns="91440" tIns="45720" rIns="91440" bIns="45720" rtlCol="0" anchor="ctr">
+            <a:normAutofit/>
+          </a:bodyPr>
+          <a:lstStyle>
+            <a:lvl1pPr algn="l" defTabSz="914400" rtl="0" eaLnBrk="1" latinLnBrk="0" hangingPunct="1">
+              <a:lnSpc>
+                <a:spcPct val="90000"/>
+              </a:lnSpc>
+              <a:spcBef>
+                <a:spcPct val="0"/>
+              </a:spcBef>
+              <a:buNone/>
+              <a:defRPr sz="4400" kern="1200">
+                <a:solidFill>
+                  <a:schemeClr val="tx1"/>
+                </a:solidFill>
+                <a:latin typeface="+mj-lt"/>
+                <a:ea typeface="+mj-ea"/>
+                <a:cs typeface="+mj-cs"/>
+              </a:defRPr>
+            </a:lvl1pPr>
+          </a:lstStyle>
+          <a:p>
+            <a:r>
+              <a:rPr lang="es-AR" sz="2800" b="1" dirty="0" err="1">
+                <a:latin typeface="Consolas" panose="020B0609020204030204" pitchFamily="49" charset="0"/>
+                <a:cs typeface="Cascadia Code SemiBold" panose="020B0609020000020004" pitchFamily="49" charset="0"/>
+              </a:rPr>
+              <a:t>For</a:t>
+            </a:r>
+            <a:r>
+              <a:rPr lang="es-AR" sz="2800" b="1" dirty="0">
+                <a:latin typeface="Consolas" panose="020B0609020204030204" pitchFamily="49" charset="0"/>
+                <a:cs typeface="Cascadia Code SemiBold" panose="020B0609020000020004" pitchFamily="49" charset="0"/>
+              </a:rPr>
+              <a:t> ____ in </a:t>
+            </a:r>
+            <a:r>
+              <a:rPr lang="es-AR" sz="2800" b="1" dirty="0" err="1">
+                <a:latin typeface="Consolas" panose="020B0609020204030204" pitchFamily="49" charset="0"/>
+                <a:cs typeface="Cascadia Code SemiBold" panose="020B0609020000020004" pitchFamily="49" charset="0"/>
+              </a:rPr>
+              <a:t>range</a:t>
+            </a:r>
+            <a:r>
+              <a:rPr lang="es-AR" sz="2800" b="1" dirty="0">
+                <a:latin typeface="Consolas" panose="020B0609020204030204" pitchFamily="49" charset="0"/>
+                <a:cs typeface="Cascadia Code SemiBold" panose="020B0609020000020004" pitchFamily="49" charset="0"/>
+              </a:rPr>
+              <a:t>(a, b, c)</a:t>
+            </a:r>
+            <a:br>
+              <a:rPr lang="es-AR" sz="3600" dirty="0"/>
+            </a:br>
+            <a:r>
+              <a:rPr lang="es-AR" sz="2800" i="1" dirty="0">
+                <a:solidFill>
+                  <a:schemeClr val="bg2">
+                    <a:lumMod val="50000"/>
+                  </a:schemeClr>
+                </a:solidFill>
+              </a:rPr>
+              <a:t>(</a:t>
+            </a:r>
+            <a:r>
+              <a:rPr lang="es-AR" sz="2800" i="1" dirty="0" err="1">
+                <a:solidFill>
+                  <a:schemeClr val="bg2">
+                    <a:lumMod val="50000"/>
+                  </a:schemeClr>
+                </a:solidFill>
+              </a:rPr>
+              <a:t>loop</a:t>
+            </a:r>
+            <a:r>
+              <a:rPr lang="es-AR" sz="2800" i="1" dirty="0">
+                <a:solidFill>
+                  <a:schemeClr val="bg2">
+                    <a:lumMod val="50000"/>
+                  </a:schemeClr>
+                </a:solidFill>
+              </a:rPr>
+              <a:t>)</a:t>
+            </a:r>
+            <a:r>
+              <a:rPr lang="es-AR" sz="2800" dirty="0"/>
+              <a:t> </a:t>
+            </a:r>
+            <a:endParaRPr lang="en-US" sz="3600" dirty="0"/>
+          </a:p>
+        </p:txBody>
+      </p:sp>
+      <p:pic>
+        <p:nvPicPr>
+          <p:cNvPr id="26" name="Imagen 25">
+            <a:extLst>
+              <a:ext uri="{FF2B5EF4-FFF2-40B4-BE49-F238E27FC236}">
+                <a16:creationId xmlns:a16="http://schemas.microsoft.com/office/drawing/2014/main" id="{DB0CA3D0-6B5D-3B54-A4A3-B2C31721F638}"/>
+              </a:ext>
+            </a:extLst>
+          </p:cNvPr>
+          <p:cNvPicPr>
+            <a:picLocks noChangeAspect="1"/>
+          </p:cNvPicPr>
+          <p:nvPr/>
+        </p:nvPicPr>
+        <p:blipFill>
+          <a:blip r:embed="rId3"/>
+          <a:stretch>
+            <a:fillRect/>
+          </a:stretch>
+        </p:blipFill>
+        <p:spPr>
+          <a:xfrm>
+            <a:off x="1" y="5062281"/>
+            <a:ext cx="7523018" cy="1816408"/>
+          </a:xfrm>
+          <a:prstGeom prst="rect">
+            <a:avLst/>
+          </a:prstGeom>
+        </p:spPr>
+      </p:pic>
+    </p:spTree>
+    <p:extLst>
+      <p:ext uri="{BB962C8B-B14F-4D97-AF65-F5344CB8AC3E}">
+        <p14:creationId xmlns:p14="http://schemas.microsoft.com/office/powerpoint/2010/main" val="3011188339"/>
+      </p:ext>
+    </p:extLst>
+  </p:cSld>
+  <p:clrMapOvr>
+    <a:masterClrMapping/>
+  </p:clrMapOvr>
+</p:sld>
+</file>
+
+<file path=ppt/slides/slide15.xml><?xml version="1.0" encoding="utf-8"?>
+<p:sld xmlns:a="http://schemas.openxmlformats.org/drawingml/2006/main" xmlns:r="http://schemas.openxmlformats.org/officeDocument/2006/relationships" xmlns:p="http://schemas.openxmlformats.org/presentationml/2006/main">
+  <p:cSld>
+    <p:spTree>
+      <p:nvGrpSpPr>
+        <p:cNvPr id="1" name="">
+          <a:extLst>
+            <a:ext uri="{FF2B5EF4-FFF2-40B4-BE49-F238E27FC236}">
+              <a16:creationId xmlns:a16="http://schemas.microsoft.com/office/drawing/2014/main" id="{40047CB8-2FCE-D304-D3B1-8832133E8DC4}"/>
+            </a:ext>
+          </a:extLst>
+        </p:cNvPr>
+        <p:cNvGrpSpPr/>
+        <p:nvPr/>
+      </p:nvGrpSpPr>
+      <p:grpSpPr>
+        <a:xfrm>
+          <a:off x="0" y="0"/>
+          <a:ext cx="0" cy="0"/>
+          <a:chOff x="0" y="0"/>
+          <a:chExt cx="0" cy="0"/>
+        </a:xfrm>
+      </p:grpSpPr>
+      <p:pic>
+        <p:nvPicPr>
+          <p:cNvPr id="3" name="Imagen 2">
+            <a:extLst>
+              <a:ext uri="{FF2B5EF4-FFF2-40B4-BE49-F238E27FC236}">
+                <a16:creationId xmlns:a16="http://schemas.microsoft.com/office/drawing/2014/main" id="{A29BD975-DDD8-D3B1-1CA8-466FF1DDB27B}"/>
+              </a:ext>
+            </a:extLst>
+          </p:cNvPr>
+          <p:cNvPicPr>
+            <a:picLocks noChangeAspect="1"/>
+          </p:cNvPicPr>
+          <p:nvPr/>
+        </p:nvPicPr>
+        <p:blipFill>
+          <a:blip r:embed="rId2">
+            <a:extLst>
+              <a:ext uri="{28A0092B-C50C-407E-A947-70E740481C1C}">
+                <a14:useLocalDpi xmlns:a14="http://schemas.microsoft.com/office/drawing/2010/main" val="0"/>
+              </a:ext>
+            </a:extLst>
+          </a:blip>
+          <a:stretch>
+            <a:fillRect/>
+          </a:stretch>
+        </p:blipFill>
+        <p:spPr>
+          <a:xfrm>
+            <a:off x="10765173" y="3428999"/>
+            <a:ext cx="1177254" cy="2261919"/>
+          </a:xfrm>
+          <a:prstGeom prst="rect">
+            <a:avLst/>
+          </a:prstGeom>
+        </p:spPr>
+      </p:pic>
+      <p:sp>
+        <p:nvSpPr>
+          <p:cNvPr id="7" name="CuadroTexto 6">
+            <a:extLst>
+              <a:ext uri="{FF2B5EF4-FFF2-40B4-BE49-F238E27FC236}">
+                <a16:creationId xmlns:a16="http://schemas.microsoft.com/office/drawing/2014/main" id="{728B5E94-874E-064E-AB69-3A52D843F35C}"/>
+              </a:ext>
+            </a:extLst>
+          </p:cNvPr>
+          <p:cNvSpPr txBox="1"/>
+          <p:nvPr/>
+        </p:nvSpPr>
+        <p:spPr>
+          <a:xfrm>
+            <a:off x="7833625" y="5131780"/>
+            <a:ext cx="847164" cy="369332"/>
+          </a:xfrm>
+          <a:prstGeom prst="rect">
+            <a:avLst/>
+          </a:prstGeom>
+          <a:noFill/>
+        </p:spPr>
+        <p:txBody>
+          <a:bodyPr wrap="square" rtlCol="0">
+            <a:spAutoFit/>
+          </a:bodyPr>
+          <a:lstStyle/>
+          <a:p>
+            <a:r>
+              <a:rPr lang="en-US" dirty="0"/>
+              <a:t>Ln 5</a:t>
+            </a:r>
+          </a:p>
+        </p:txBody>
+      </p:sp>
+      <p:sp>
+        <p:nvSpPr>
+          <p:cNvPr id="8" name="Elipse 7">
+            <a:extLst>
+              <a:ext uri="{FF2B5EF4-FFF2-40B4-BE49-F238E27FC236}">
+                <a16:creationId xmlns:a16="http://schemas.microsoft.com/office/drawing/2014/main" id="{34A5845B-4FFF-DD35-5186-FCD19290BA59}"/>
+              </a:ext>
+            </a:extLst>
+          </p:cNvPr>
+          <p:cNvSpPr/>
+          <p:nvPr/>
+        </p:nvSpPr>
+        <p:spPr>
+          <a:xfrm>
+            <a:off x="7847480" y="5381559"/>
+            <a:ext cx="2743200" cy="958383"/>
+          </a:xfrm>
+          <a:prstGeom prst="ellipse">
+            <a:avLst/>
+          </a:prstGeom>
+          <a:solidFill>
+            <a:srgbClr val="CAD7EE"/>
+          </a:solidFill>
+          <a:ln w="38100"/>
+        </p:spPr>
+        <p:style>
+          <a:lnRef idx="2">
+            <a:schemeClr val="accent1">
+              <a:shade val="15000"/>
+            </a:schemeClr>
+          </a:lnRef>
+          <a:fillRef idx="1">
+            <a:schemeClr val="accent1"/>
+          </a:fillRef>
+          <a:effectRef idx="0">
+            <a:schemeClr val="accent1"/>
+          </a:effectRef>
+          <a:fontRef idx="minor">
+            <a:schemeClr val="lt1"/>
+          </a:fontRef>
+        </p:style>
+        <p:txBody>
+          <a:bodyPr rtlCol="0" anchor="ctr"/>
+          <a:lstStyle/>
+          <a:p>
+            <a:pPr algn="ctr"/>
+            <a:endParaRPr lang="en-US"/>
+          </a:p>
+        </p:txBody>
+      </p:sp>
+      <p:sp>
+        <p:nvSpPr>
+          <p:cNvPr id="9" name="CuadroTexto 8">
+            <a:extLst>
+              <a:ext uri="{FF2B5EF4-FFF2-40B4-BE49-F238E27FC236}">
+                <a16:creationId xmlns:a16="http://schemas.microsoft.com/office/drawing/2014/main" id="{CFC26BA3-C3CA-B091-AAB3-6D8AA3587D6D}"/>
+              </a:ext>
+            </a:extLst>
+          </p:cNvPr>
+          <p:cNvSpPr txBox="1"/>
+          <p:nvPr/>
+        </p:nvSpPr>
+        <p:spPr>
+          <a:xfrm>
+            <a:off x="8300251" y="5696331"/>
+            <a:ext cx="1932803" cy="369332"/>
+          </a:xfrm>
+          <a:prstGeom prst="rect">
+            <a:avLst/>
+          </a:prstGeom>
+          <a:noFill/>
+        </p:spPr>
+        <p:txBody>
+          <a:bodyPr wrap="square" rtlCol="0">
+            <a:spAutoFit/>
+          </a:bodyPr>
+          <a:lstStyle/>
+          <a:p>
+            <a:r>
+              <a:rPr lang="en-US" dirty="0"/>
+              <a:t>print(</a:t>
+            </a:r>
+            <a:r>
+              <a:rPr lang="en-US" dirty="0" err="1"/>
+              <a:t>full_names</a:t>
+            </a:r>
+            <a:r>
+              <a:rPr lang="en-US" dirty="0"/>
+              <a:t>)</a:t>
+            </a:r>
+          </a:p>
+        </p:txBody>
+      </p:sp>
+      <p:grpSp>
+        <p:nvGrpSpPr>
+          <p:cNvPr id="17" name="Grupo 16">
+            <a:extLst>
+              <a:ext uri="{FF2B5EF4-FFF2-40B4-BE49-F238E27FC236}">
+                <a16:creationId xmlns:a16="http://schemas.microsoft.com/office/drawing/2014/main" id="{0A1434E0-0881-537D-D76C-B324CD57B20E}"/>
+              </a:ext>
+            </a:extLst>
+          </p:cNvPr>
+          <p:cNvGrpSpPr/>
+          <p:nvPr/>
+        </p:nvGrpSpPr>
+        <p:grpSpPr>
+          <a:xfrm>
+            <a:off x="6996279" y="38921"/>
+            <a:ext cx="5298410" cy="1254083"/>
+            <a:chOff x="7661457" y="695741"/>
+            <a:chExt cx="4543293" cy="1254083"/>
+          </a:xfrm>
+        </p:grpSpPr>
+        <p:sp>
+          <p:nvSpPr>
+            <p:cNvPr id="5" name="Elipse 4">
+              <a:extLst>
+                <a:ext uri="{FF2B5EF4-FFF2-40B4-BE49-F238E27FC236}">
+                  <a16:creationId xmlns:a16="http://schemas.microsoft.com/office/drawing/2014/main" id="{07388794-D05D-EC88-A530-788F75BD3FF0}"/>
+                </a:ext>
+              </a:extLst>
+            </p:cNvPr>
+            <p:cNvSpPr/>
+            <p:nvPr/>
+          </p:nvSpPr>
+          <p:spPr>
+            <a:xfrm>
+              <a:off x="7661457" y="991441"/>
+              <a:ext cx="3984558" cy="958383"/>
+            </a:xfrm>
+            <a:prstGeom prst="ellipse">
+              <a:avLst/>
+            </a:prstGeom>
+            <a:solidFill>
+              <a:srgbClr val="CAD7EE"/>
+            </a:solidFill>
+            <a:ln w="38100"/>
+          </p:spPr>
+          <p:style>
+            <a:lnRef idx="2">
+              <a:schemeClr val="accent1">
+                <a:shade val="15000"/>
+              </a:schemeClr>
+            </a:lnRef>
+            <a:fillRef idx="1">
+              <a:schemeClr val="accent1"/>
+            </a:fillRef>
+            <a:effectRef idx="0">
+              <a:schemeClr val="accent1"/>
+            </a:effectRef>
+            <a:fontRef idx="minor">
+              <a:schemeClr val="lt1"/>
+            </a:fontRef>
+          </p:style>
+          <p:txBody>
+            <a:bodyPr rtlCol="0" anchor="ctr"/>
+            <a:lstStyle/>
+            <a:p>
+              <a:pPr algn="ctr"/>
+              <a:endParaRPr lang="en-US"/>
+            </a:p>
+          </p:txBody>
+        </p:sp>
+        <p:sp>
+          <p:nvSpPr>
+            <p:cNvPr id="6" name="CuadroTexto 5">
+              <a:extLst>
+                <a:ext uri="{FF2B5EF4-FFF2-40B4-BE49-F238E27FC236}">
+                  <a16:creationId xmlns:a16="http://schemas.microsoft.com/office/drawing/2014/main" id="{43B21825-7CE2-9F77-0224-C9EB4B7F702A}"/>
+                </a:ext>
+              </a:extLst>
+            </p:cNvPr>
+            <p:cNvSpPr txBox="1"/>
+            <p:nvPr/>
+          </p:nvSpPr>
+          <p:spPr>
+            <a:xfrm>
+              <a:off x="7758234" y="1276957"/>
+              <a:ext cx="4446516" cy="369332"/>
+            </a:xfrm>
+            <a:prstGeom prst="rect">
+              <a:avLst/>
+            </a:prstGeom>
+            <a:noFill/>
+          </p:spPr>
+          <p:txBody>
+            <a:bodyPr wrap="square" rtlCol="0">
+              <a:spAutoFit/>
+            </a:bodyPr>
+            <a:lstStyle/>
+            <a:p>
+              <a:r>
+                <a:rPr lang="en-US" dirty="0"/>
+                <a:t>names = [“Lionel </a:t>
+              </a:r>
+              <a:r>
+                <a:rPr lang="es-AR" dirty="0"/>
+                <a:t>”</a:t>
+              </a:r>
+              <a:r>
+                <a:rPr lang="en-US" dirty="0"/>
+                <a:t>, “Juli</a:t>
+              </a:r>
+              <a:r>
+                <a:rPr lang="es-AR" dirty="0" err="1"/>
+                <a:t>án</a:t>
+              </a:r>
+              <a:r>
+                <a:rPr lang="es-AR" dirty="0"/>
+                <a:t> ”, “Ángel ”, “</a:t>
+              </a:r>
+              <a:r>
+                <a:rPr lang="es-AR" dirty="0" err="1"/>
+                <a:t>Dibu</a:t>
+              </a:r>
+              <a:r>
+                <a:rPr lang="es-AR" dirty="0"/>
+                <a:t> “</a:t>
+              </a:r>
+              <a:r>
+                <a:rPr lang="en-US" dirty="0"/>
+                <a:t>]</a:t>
+              </a:r>
+            </a:p>
+          </p:txBody>
+        </p:sp>
+        <p:sp>
+          <p:nvSpPr>
+            <p:cNvPr id="10" name="CuadroTexto 9">
+              <a:extLst>
+                <a:ext uri="{FF2B5EF4-FFF2-40B4-BE49-F238E27FC236}">
+                  <a16:creationId xmlns:a16="http://schemas.microsoft.com/office/drawing/2014/main" id="{8CD47565-79B0-2457-B79E-22976570CC87}"/>
+                </a:ext>
+              </a:extLst>
+            </p:cNvPr>
+            <p:cNvSpPr txBox="1"/>
+            <p:nvPr/>
+          </p:nvSpPr>
+          <p:spPr>
+            <a:xfrm>
+              <a:off x="7896781" y="695741"/>
+              <a:ext cx="847164" cy="369332"/>
+            </a:xfrm>
+            <a:prstGeom prst="rect">
+              <a:avLst/>
+            </a:prstGeom>
+            <a:noFill/>
+          </p:spPr>
+          <p:txBody>
+            <a:bodyPr wrap="square" rtlCol="0">
+              <a:spAutoFit/>
+            </a:bodyPr>
+            <a:lstStyle/>
+            <a:p>
+              <a:r>
+                <a:rPr lang="en-US" dirty="0"/>
+                <a:t>Ln 1</a:t>
+              </a:r>
+            </a:p>
+          </p:txBody>
+        </p:sp>
+      </p:grpSp>
+      <p:grpSp>
+        <p:nvGrpSpPr>
+          <p:cNvPr id="11" name="Grupo 10">
+            <a:extLst>
+              <a:ext uri="{FF2B5EF4-FFF2-40B4-BE49-F238E27FC236}">
+                <a16:creationId xmlns:a16="http://schemas.microsoft.com/office/drawing/2014/main" id="{1D758D61-0C18-5316-958C-BACF026FC99F}"/>
+              </a:ext>
+            </a:extLst>
+          </p:cNvPr>
+          <p:cNvGrpSpPr/>
+          <p:nvPr/>
+        </p:nvGrpSpPr>
+        <p:grpSpPr>
+          <a:xfrm rot="1017173">
+            <a:off x="5372715" y="2382051"/>
+            <a:ext cx="2337358" cy="2087943"/>
+            <a:chOff x="4312494" y="1392221"/>
+            <a:chExt cx="2564824" cy="2291137"/>
+          </a:xfrm>
+        </p:grpSpPr>
+        <p:sp>
+          <p:nvSpPr>
+            <p:cNvPr id="12" name="Forma libre: forma 11">
+              <a:extLst>
+                <a:ext uri="{FF2B5EF4-FFF2-40B4-BE49-F238E27FC236}">
+                  <a16:creationId xmlns:a16="http://schemas.microsoft.com/office/drawing/2014/main" id="{038A6112-84CA-AEAF-CECD-22083B33C939}"/>
+                </a:ext>
+              </a:extLst>
+            </p:cNvPr>
+            <p:cNvSpPr/>
+            <p:nvPr/>
+          </p:nvSpPr>
+          <p:spPr>
+            <a:xfrm>
+              <a:off x="4312494" y="1532583"/>
+              <a:ext cx="2564824" cy="2150775"/>
+            </a:xfrm>
+            <a:custGeom>
+              <a:avLst/>
+              <a:gdLst>
+                <a:gd name="connsiteX0" fmla="*/ 2564824 w 2564824"/>
+                <a:gd name="connsiteY0" fmla="*/ 631068 h 2150775"/>
+                <a:gd name="connsiteX1" fmla="*/ 2126943 w 2564824"/>
+                <a:gd name="connsiteY1" fmla="*/ 1661378 h 2150775"/>
+                <a:gd name="connsiteX2" fmla="*/ 1882244 w 2564824"/>
+                <a:gd name="connsiteY2" fmla="*/ 1841682 h 2150775"/>
+                <a:gd name="connsiteX3" fmla="*/ 1624667 w 2564824"/>
+                <a:gd name="connsiteY3" fmla="*/ 1957592 h 2150775"/>
+                <a:gd name="connsiteX4" fmla="*/ 787540 w 2564824"/>
+                <a:gd name="connsiteY4" fmla="*/ 2150775 h 2150775"/>
+                <a:gd name="connsiteX5" fmla="*/ 607236 w 2564824"/>
+                <a:gd name="connsiteY5" fmla="*/ 2137896 h 2150775"/>
+                <a:gd name="connsiteX6" fmla="*/ 414052 w 2564824"/>
+                <a:gd name="connsiteY6" fmla="*/ 2021986 h 2150775"/>
+                <a:gd name="connsiteX7" fmla="*/ 27686 w 2564824"/>
+                <a:gd name="connsiteY7" fmla="*/ 1390921 h 2150775"/>
+                <a:gd name="connsiteX8" fmla="*/ 53444 w 2564824"/>
+                <a:gd name="connsiteY8" fmla="*/ 901524 h 2150775"/>
+                <a:gd name="connsiteX9" fmla="*/ 594357 w 2564824"/>
+                <a:gd name="connsiteY9" fmla="*/ 437885 h 2150775"/>
+                <a:gd name="connsiteX10" fmla="*/ 736024 w 2564824"/>
+                <a:gd name="connsiteY10" fmla="*/ 347732 h 2150775"/>
+                <a:gd name="connsiteX11" fmla="*/ 877692 w 2564824"/>
+                <a:gd name="connsiteY11" fmla="*/ 270459 h 2150775"/>
+                <a:gd name="connsiteX12" fmla="*/ 1238300 w 2564824"/>
+                <a:gd name="connsiteY12" fmla="*/ 128792 h 2150775"/>
+                <a:gd name="connsiteX13" fmla="*/ 1367089 w 2564824"/>
+                <a:gd name="connsiteY13" fmla="*/ 25761 h 2150775"/>
+                <a:gd name="connsiteX14" fmla="*/ 1444362 w 2564824"/>
+                <a:gd name="connsiteY14" fmla="*/ 12882 h 2150775"/>
+                <a:gd name="connsiteX15" fmla="*/ 1663303 w 2564824"/>
+                <a:gd name="connsiteY15" fmla="*/ 3 h 2150775"/>
+              </a:gdLst>
+              <a:ahLst/>
+              <a:cxnLst>
+                <a:cxn ang="0">
+                  <a:pos x="connsiteX0" y="connsiteY0"/>
+                </a:cxn>
+                <a:cxn ang="0">
+                  <a:pos x="connsiteX1" y="connsiteY1"/>
+                </a:cxn>
+                <a:cxn ang="0">
+                  <a:pos x="connsiteX2" y="connsiteY2"/>
+                </a:cxn>
+                <a:cxn ang="0">
+                  <a:pos x="connsiteX3" y="connsiteY3"/>
+                </a:cxn>
+                <a:cxn ang="0">
+                  <a:pos x="connsiteX4" y="connsiteY4"/>
+                </a:cxn>
+                <a:cxn ang="0">
+                  <a:pos x="connsiteX5" y="connsiteY5"/>
+                </a:cxn>
+                <a:cxn ang="0">
+                  <a:pos x="connsiteX6" y="connsiteY6"/>
+                </a:cxn>
+                <a:cxn ang="0">
+                  <a:pos x="connsiteX7" y="connsiteY7"/>
+                </a:cxn>
+                <a:cxn ang="0">
+                  <a:pos x="connsiteX8" y="connsiteY8"/>
+                </a:cxn>
+                <a:cxn ang="0">
+                  <a:pos x="connsiteX9" y="connsiteY9"/>
+                </a:cxn>
+                <a:cxn ang="0">
+                  <a:pos x="connsiteX10" y="connsiteY10"/>
+                </a:cxn>
+                <a:cxn ang="0">
+                  <a:pos x="connsiteX11" y="connsiteY11"/>
+                </a:cxn>
+                <a:cxn ang="0">
+                  <a:pos x="connsiteX12" y="connsiteY12"/>
+                </a:cxn>
+                <a:cxn ang="0">
+                  <a:pos x="connsiteX13" y="connsiteY13"/>
+                </a:cxn>
+                <a:cxn ang="0">
+                  <a:pos x="connsiteX14" y="connsiteY14"/>
+                </a:cxn>
+                <a:cxn ang="0">
+                  <a:pos x="connsiteX15" y="connsiteY15"/>
+                </a:cxn>
+              </a:cxnLst>
+              <a:rect l="l" t="t" r="r" b="b"/>
+              <a:pathLst>
+                <a:path w="2564824" h="2150775">
+                  <a:moveTo>
+                    <a:pt x="2564824" y="631068"/>
+                  </a:moveTo>
+                  <a:cubicBezTo>
+                    <a:pt x="2417431" y="1114191"/>
+                    <a:pt x="2443202" y="1345119"/>
+                    <a:pt x="2126943" y="1661378"/>
+                  </a:cubicBezTo>
+                  <a:cubicBezTo>
+                    <a:pt x="2055301" y="1733020"/>
+                    <a:pt x="1969515" y="1790214"/>
+                    <a:pt x="1882244" y="1841682"/>
+                  </a:cubicBezTo>
+                  <a:cubicBezTo>
+                    <a:pt x="1801145" y="1889510"/>
+                    <a:pt x="1715276" y="1932008"/>
+                    <a:pt x="1624667" y="1957592"/>
+                  </a:cubicBezTo>
+                  <a:cubicBezTo>
+                    <a:pt x="1349066" y="2035409"/>
+                    <a:pt x="787540" y="2150775"/>
+                    <a:pt x="787540" y="2150775"/>
+                  </a:cubicBezTo>
+                  <a:cubicBezTo>
+                    <a:pt x="727439" y="2146482"/>
+                    <a:pt x="664199" y="2157538"/>
+                    <a:pt x="607236" y="2137896"/>
+                  </a:cubicBezTo>
+                  <a:cubicBezTo>
+                    <a:pt x="536242" y="2113415"/>
+                    <a:pt x="466378" y="2075851"/>
+                    <a:pt x="414052" y="2021986"/>
+                  </a:cubicBezTo>
+                  <a:cubicBezTo>
+                    <a:pt x="203552" y="1805295"/>
+                    <a:pt x="150799" y="1648339"/>
+                    <a:pt x="27686" y="1390921"/>
+                  </a:cubicBezTo>
+                  <a:cubicBezTo>
+                    <a:pt x="11956" y="1257210"/>
+                    <a:pt x="-37734" y="1023895"/>
+                    <a:pt x="53444" y="901524"/>
+                  </a:cubicBezTo>
+                  <a:cubicBezTo>
+                    <a:pt x="77699" y="868972"/>
+                    <a:pt x="433922" y="547657"/>
+                    <a:pt x="594357" y="437885"/>
+                  </a:cubicBezTo>
+                  <a:cubicBezTo>
+                    <a:pt x="640552" y="406278"/>
+                    <a:pt x="687835" y="376207"/>
+                    <a:pt x="736024" y="347732"/>
+                  </a:cubicBezTo>
+                  <a:cubicBezTo>
+                    <a:pt x="782334" y="320367"/>
+                    <a:pt x="828382" y="291953"/>
+                    <a:pt x="877692" y="270459"/>
+                  </a:cubicBezTo>
+                  <a:cubicBezTo>
+                    <a:pt x="996079" y="218854"/>
+                    <a:pt x="1238300" y="128792"/>
+                    <a:pt x="1238300" y="128792"/>
+                  </a:cubicBezTo>
+                  <a:cubicBezTo>
+                    <a:pt x="1281230" y="94448"/>
+                    <a:pt x="1319173" y="52714"/>
+                    <a:pt x="1367089" y="25761"/>
+                  </a:cubicBezTo>
+                  <a:cubicBezTo>
+                    <a:pt x="1389848" y="12959"/>
+                    <a:pt x="1418367" y="15358"/>
+                    <a:pt x="1444362" y="12882"/>
+                  </a:cubicBezTo>
+                  <a:cubicBezTo>
+                    <a:pt x="1585587" y="-568"/>
+                    <a:pt x="1581060" y="3"/>
+                    <a:pt x="1663303" y="3"/>
+                  </a:cubicBezTo>
+                </a:path>
+              </a:pathLst>
+            </a:custGeom>
+            <a:noFill/>
+            <a:ln w="57150">
+              <a:solidFill>
+                <a:srgbClr val="791179"/>
+              </a:solidFill>
+            </a:ln>
+          </p:spPr>
+          <p:style>
+            <a:lnRef idx="2">
+              <a:schemeClr val="accent1">
+                <a:shade val="15000"/>
+              </a:schemeClr>
+            </a:lnRef>
+            <a:fillRef idx="1">
+              <a:schemeClr val="accent1"/>
+            </a:fillRef>
+            <a:effectRef idx="0">
+              <a:schemeClr val="accent1"/>
+            </a:effectRef>
+            <a:fontRef idx="minor">
+              <a:schemeClr val="lt1"/>
+            </a:fontRef>
+          </p:style>
+          <p:txBody>
+            <a:bodyPr rtlCol="0" anchor="ctr"/>
+            <a:lstStyle/>
+            <a:p>
+              <a:pPr algn="ctr"/>
+              <a:endParaRPr lang="en-US">
+                <a:solidFill>
+                  <a:srgbClr val="791179"/>
+                </a:solidFill>
+              </a:endParaRPr>
+            </a:p>
+          </p:txBody>
+        </p:sp>
+        <p:sp>
+          <p:nvSpPr>
+            <p:cNvPr id="13" name="Forma libre: forma 12">
+              <a:extLst>
+                <a:ext uri="{FF2B5EF4-FFF2-40B4-BE49-F238E27FC236}">
+                  <a16:creationId xmlns:a16="http://schemas.microsoft.com/office/drawing/2014/main" id="{831B4AD4-B02D-BBAB-685A-0E0C37B7A3BB}"/>
+                </a:ext>
+              </a:extLst>
+            </p:cNvPr>
+            <p:cNvSpPr/>
+            <p:nvPr/>
+          </p:nvSpPr>
+          <p:spPr>
+            <a:xfrm rot="1067707">
+              <a:off x="5579942" y="1392221"/>
+              <a:ext cx="416126" cy="371948"/>
+            </a:xfrm>
+            <a:custGeom>
+              <a:avLst/>
+              <a:gdLst>
+                <a:gd name="connsiteX0" fmla="*/ 0 w 188119"/>
+                <a:gd name="connsiteY0" fmla="*/ 0 h 211932"/>
+                <a:gd name="connsiteX1" fmla="*/ 109537 w 188119"/>
+                <a:gd name="connsiteY1" fmla="*/ 26194 h 211932"/>
+                <a:gd name="connsiteX2" fmla="*/ 133350 w 188119"/>
+                <a:gd name="connsiteY2" fmla="*/ 38100 h 211932"/>
+                <a:gd name="connsiteX3" fmla="*/ 159544 w 188119"/>
+                <a:gd name="connsiteY3" fmla="*/ 50007 h 211932"/>
+                <a:gd name="connsiteX4" fmla="*/ 180975 w 188119"/>
+                <a:gd name="connsiteY4" fmla="*/ 54769 h 211932"/>
+                <a:gd name="connsiteX5" fmla="*/ 188119 w 188119"/>
+                <a:gd name="connsiteY5" fmla="*/ 57150 h 211932"/>
+                <a:gd name="connsiteX6" fmla="*/ 140494 w 188119"/>
+                <a:gd name="connsiteY6" fmla="*/ 121444 h 211932"/>
+                <a:gd name="connsiteX7" fmla="*/ 123825 w 188119"/>
+                <a:gd name="connsiteY7" fmla="*/ 140494 h 211932"/>
+                <a:gd name="connsiteX8" fmla="*/ 102394 w 188119"/>
+                <a:gd name="connsiteY8" fmla="*/ 150019 h 211932"/>
+                <a:gd name="connsiteX9" fmla="*/ 80962 w 188119"/>
+                <a:gd name="connsiteY9" fmla="*/ 173832 h 211932"/>
+                <a:gd name="connsiteX10" fmla="*/ 73819 w 188119"/>
+                <a:gd name="connsiteY10" fmla="*/ 180975 h 211932"/>
+                <a:gd name="connsiteX11" fmla="*/ 69056 w 188119"/>
+                <a:gd name="connsiteY11" fmla="*/ 190500 h 211932"/>
+                <a:gd name="connsiteX12" fmla="*/ 61912 w 188119"/>
+                <a:gd name="connsiteY12" fmla="*/ 202407 h 211932"/>
+                <a:gd name="connsiteX13" fmla="*/ 52387 w 188119"/>
+                <a:gd name="connsiteY13" fmla="*/ 211932 h 211932"/>
+              </a:gdLst>
+              <a:ahLst/>
+              <a:cxnLst>
+                <a:cxn ang="0">
+                  <a:pos x="connsiteX0" y="connsiteY0"/>
+                </a:cxn>
+                <a:cxn ang="0">
+                  <a:pos x="connsiteX1" y="connsiteY1"/>
+                </a:cxn>
+                <a:cxn ang="0">
+                  <a:pos x="connsiteX2" y="connsiteY2"/>
+                </a:cxn>
+                <a:cxn ang="0">
+                  <a:pos x="connsiteX3" y="connsiteY3"/>
+                </a:cxn>
+                <a:cxn ang="0">
+                  <a:pos x="connsiteX4" y="connsiteY4"/>
+                </a:cxn>
+                <a:cxn ang="0">
+                  <a:pos x="connsiteX5" y="connsiteY5"/>
+                </a:cxn>
+                <a:cxn ang="0">
+                  <a:pos x="connsiteX6" y="connsiteY6"/>
+                </a:cxn>
+                <a:cxn ang="0">
+                  <a:pos x="connsiteX7" y="connsiteY7"/>
+                </a:cxn>
+                <a:cxn ang="0">
+                  <a:pos x="connsiteX8" y="connsiteY8"/>
+                </a:cxn>
+                <a:cxn ang="0">
+                  <a:pos x="connsiteX9" y="connsiteY9"/>
+                </a:cxn>
+                <a:cxn ang="0">
+                  <a:pos x="connsiteX10" y="connsiteY10"/>
+                </a:cxn>
+                <a:cxn ang="0">
+                  <a:pos x="connsiteX11" y="connsiteY11"/>
+                </a:cxn>
+                <a:cxn ang="0">
+                  <a:pos x="connsiteX12" y="connsiteY12"/>
+                </a:cxn>
+                <a:cxn ang="0">
+                  <a:pos x="connsiteX13" y="connsiteY13"/>
+                </a:cxn>
+              </a:cxnLst>
+              <a:rect l="l" t="t" r="r" b="b"/>
+              <a:pathLst>
+                <a:path w="188119" h="211932">
+                  <a:moveTo>
+                    <a:pt x="0" y="0"/>
+                  </a:moveTo>
+                  <a:cubicBezTo>
+                    <a:pt x="59974" y="11996"/>
+                    <a:pt x="54255" y="9184"/>
+                    <a:pt x="109537" y="26194"/>
+                  </a:cubicBezTo>
+                  <a:cubicBezTo>
+                    <a:pt x="125437" y="31086"/>
+                    <a:pt x="118108" y="30479"/>
+                    <a:pt x="133350" y="38100"/>
+                  </a:cubicBezTo>
+                  <a:cubicBezTo>
+                    <a:pt x="141929" y="42389"/>
+                    <a:pt x="150639" y="46445"/>
+                    <a:pt x="159544" y="50007"/>
+                  </a:cubicBezTo>
+                  <a:cubicBezTo>
+                    <a:pt x="163616" y="51636"/>
+                    <a:pt x="177459" y="53890"/>
+                    <a:pt x="180975" y="54769"/>
+                  </a:cubicBezTo>
+                  <a:cubicBezTo>
+                    <a:pt x="183410" y="55378"/>
+                    <a:pt x="185738" y="56356"/>
+                    <a:pt x="188119" y="57150"/>
+                  </a:cubicBezTo>
+                  <a:cubicBezTo>
+                    <a:pt x="187294" y="58275"/>
+                    <a:pt x="144649" y="116696"/>
+                    <a:pt x="140494" y="121444"/>
+                  </a:cubicBezTo>
+                  <a:cubicBezTo>
+                    <a:pt x="134938" y="127794"/>
+                    <a:pt x="130575" y="135431"/>
+                    <a:pt x="123825" y="140494"/>
+                  </a:cubicBezTo>
+                  <a:cubicBezTo>
+                    <a:pt x="117571" y="145184"/>
+                    <a:pt x="109538" y="146844"/>
+                    <a:pt x="102394" y="150019"/>
+                  </a:cubicBezTo>
+                  <a:cubicBezTo>
+                    <a:pt x="76108" y="176303"/>
+                    <a:pt x="103760" y="147776"/>
+                    <a:pt x="80962" y="173832"/>
+                  </a:cubicBezTo>
+                  <a:cubicBezTo>
+                    <a:pt x="78745" y="176366"/>
+                    <a:pt x="75776" y="178235"/>
+                    <a:pt x="73819" y="180975"/>
+                  </a:cubicBezTo>
+                  <a:cubicBezTo>
+                    <a:pt x="71756" y="183864"/>
+                    <a:pt x="70780" y="187397"/>
+                    <a:pt x="69056" y="190500"/>
+                  </a:cubicBezTo>
+                  <a:cubicBezTo>
+                    <a:pt x="66808" y="194546"/>
+                    <a:pt x="64689" y="198704"/>
+                    <a:pt x="61912" y="202407"/>
+                  </a:cubicBezTo>
+                  <a:cubicBezTo>
+                    <a:pt x="59218" y="205999"/>
+                    <a:pt x="55562" y="208757"/>
+                    <a:pt x="52387" y="211932"/>
+                  </a:cubicBezTo>
+                </a:path>
+              </a:pathLst>
+            </a:custGeom>
+            <a:noFill/>
+            <a:ln w="57150">
+              <a:solidFill>
+                <a:srgbClr val="8A008A"/>
+              </a:solidFill>
+            </a:ln>
+          </p:spPr>
+          <p:style>
+            <a:lnRef idx="2">
+              <a:schemeClr val="accent1">
+                <a:shade val="15000"/>
+              </a:schemeClr>
+            </a:lnRef>
+            <a:fillRef idx="1">
+              <a:schemeClr val="accent1"/>
+            </a:fillRef>
+            <a:effectRef idx="0">
+              <a:schemeClr val="accent1"/>
+            </a:effectRef>
+            <a:fontRef idx="minor">
+              <a:schemeClr val="lt1"/>
+            </a:fontRef>
+          </p:style>
+          <p:txBody>
+            <a:bodyPr rtlCol="0" anchor="ctr"/>
+            <a:lstStyle/>
+            <a:p>
+              <a:pPr algn="ctr"/>
+              <a:endParaRPr lang="en-US">
+                <a:solidFill>
+                  <a:srgbClr val="791179"/>
+                </a:solidFill>
+              </a:endParaRPr>
+            </a:p>
+          </p:txBody>
+        </p:sp>
+      </p:grpSp>
+      <p:sp>
+        <p:nvSpPr>
+          <p:cNvPr id="14" name="CuadroTexto 13">
+            <a:extLst>
+              <a:ext uri="{FF2B5EF4-FFF2-40B4-BE49-F238E27FC236}">
+                <a16:creationId xmlns:a16="http://schemas.microsoft.com/office/drawing/2014/main" id="{04AE7A53-B1E0-4563-9349-021659839603}"/>
+              </a:ext>
+            </a:extLst>
+          </p:cNvPr>
+          <p:cNvSpPr txBox="1"/>
+          <p:nvPr/>
+        </p:nvSpPr>
+        <p:spPr>
+          <a:xfrm>
+            <a:off x="6983290" y="4105348"/>
+            <a:ext cx="361682" cy="769441"/>
+          </a:xfrm>
+          <a:prstGeom prst="rect">
+            <a:avLst/>
+          </a:prstGeom>
+          <a:noFill/>
+        </p:spPr>
+        <p:txBody>
+          <a:bodyPr wrap="square" rtlCol="0">
+            <a:spAutoFit/>
+          </a:bodyPr>
+          <a:lstStyle/>
+          <a:p>
+            <a:r>
+              <a:rPr lang="en-US" sz="4400" b="1" dirty="0">
+                <a:solidFill>
+                  <a:srgbClr val="00B050"/>
+                </a:solidFill>
+              </a:rPr>
+              <a:t>T</a:t>
+            </a:r>
+          </a:p>
+        </p:txBody>
+      </p:sp>
+      <p:sp>
+        <p:nvSpPr>
+          <p:cNvPr id="15" name="CuadroTexto 14">
+            <a:extLst>
+              <a:ext uri="{FF2B5EF4-FFF2-40B4-BE49-F238E27FC236}">
+                <a16:creationId xmlns:a16="http://schemas.microsoft.com/office/drawing/2014/main" id="{1BB2F5FF-F9E4-6F50-01E1-9D59F374D97D}"/>
+              </a:ext>
+            </a:extLst>
+          </p:cNvPr>
+          <p:cNvSpPr txBox="1"/>
+          <p:nvPr/>
+        </p:nvSpPr>
+        <p:spPr>
+          <a:xfrm>
+            <a:off x="11199788" y="3877657"/>
+            <a:ext cx="583841" cy="769441"/>
+          </a:xfrm>
+          <a:prstGeom prst="rect">
+            <a:avLst/>
+          </a:prstGeom>
+          <a:noFill/>
+        </p:spPr>
+        <p:txBody>
+          <a:bodyPr wrap="square" rtlCol="0">
+            <a:spAutoFit/>
+          </a:bodyPr>
+          <a:lstStyle/>
+          <a:p>
+            <a:r>
+              <a:rPr lang="en-US" sz="4400" b="1" dirty="0">
+                <a:solidFill>
+                  <a:srgbClr val="FF0000"/>
+                </a:solidFill>
+              </a:rPr>
+              <a:t>F</a:t>
+            </a:r>
+          </a:p>
+        </p:txBody>
+      </p:sp>
+      <p:grpSp>
+        <p:nvGrpSpPr>
+          <p:cNvPr id="18" name="Grupo 17">
+            <a:extLst>
+              <a:ext uri="{FF2B5EF4-FFF2-40B4-BE49-F238E27FC236}">
+                <a16:creationId xmlns:a16="http://schemas.microsoft.com/office/drawing/2014/main" id="{03961BC6-C033-D500-B2D4-35182B5AEC5A}"/>
+              </a:ext>
+            </a:extLst>
+          </p:cNvPr>
+          <p:cNvGrpSpPr/>
+          <p:nvPr/>
+        </p:nvGrpSpPr>
+        <p:grpSpPr>
+          <a:xfrm>
+            <a:off x="6983290" y="2512539"/>
+            <a:ext cx="4791515" cy="1254083"/>
+            <a:chOff x="7661457" y="695741"/>
+            <a:chExt cx="4112709" cy="1254083"/>
+          </a:xfrm>
+        </p:grpSpPr>
+        <p:sp>
+          <p:nvSpPr>
+            <p:cNvPr id="19" name="Elipse 18">
+              <a:extLst>
+                <a:ext uri="{FF2B5EF4-FFF2-40B4-BE49-F238E27FC236}">
+                  <a16:creationId xmlns:a16="http://schemas.microsoft.com/office/drawing/2014/main" id="{EBF9D2C2-E97F-BFF3-42B7-76CD45078678}"/>
+                </a:ext>
+              </a:extLst>
+            </p:cNvPr>
+            <p:cNvSpPr/>
+            <p:nvPr/>
+          </p:nvSpPr>
+          <p:spPr>
+            <a:xfrm>
+              <a:off x="7661457" y="991441"/>
+              <a:ext cx="3984558" cy="958383"/>
+            </a:xfrm>
+            <a:prstGeom prst="ellipse">
+              <a:avLst/>
+            </a:prstGeom>
+            <a:solidFill>
+              <a:srgbClr val="CAD7EE"/>
+            </a:solidFill>
+            <a:ln w="38100"/>
+          </p:spPr>
+          <p:style>
+            <a:lnRef idx="2">
+              <a:schemeClr val="accent1">
+                <a:shade val="15000"/>
+              </a:schemeClr>
+            </a:lnRef>
+            <a:fillRef idx="1">
+              <a:schemeClr val="accent1"/>
+            </a:fillRef>
+            <a:effectRef idx="0">
+              <a:schemeClr val="accent1"/>
+            </a:effectRef>
+            <a:fontRef idx="minor">
+              <a:schemeClr val="lt1"/>
+            </a:fontRef>
+          </p:style>
+          <p:txBody>
+            <a:bodyPr rtlCol="0" anchor="ctr"/>
+            <a:lstStyle/>
+            <a:p>
+              <a:pPr algn="ctr"/>
+              <a:endParaRPr lang="en-US"/>
+            </a:p>
+          </p:txBody>
+        </p:sp>
+        <p:sp>
+          <p:nvSpPr>
+            <p:cNvPr id="20" name="CuadroTexto 19">
+              <a:extLst>
+                <a:ext uri="{FF2B5EF4-FFF2-40B4-BE49-F238E27FC236}">
+                  <a16:creationId xmlns:a16="http://schemas.microsoft.com/office/drawing/2014/main" id="{F10A66E0-DD23-9607-DA70-45B4BF424C21}"/>
+                </a:ext>
+              </a:extLst>
+            </p:cNvPr>
+            <p:cNvSpPr txBox="1"/>
+            <p:nvPr/>
+          </p:nvSpPr>
+          <p:spPr>
+            <a:xfrm>
+              <a:off x="7772002" y="1276957"/>
+              <a:ext cx="4002164" cy="369332"/>
+            </a:xfrm>
+            <a:prstGeom prst="rect">
+              <a:avLst/>
+            </a:prstGeom>
+            <a:noFill/>
+          </p:spPr>
+          <p:txBody>
+            <a:bodyPr wrap="square" rtlCol="0">
+              <a:spAutoFit/>
+            </a:bodyPr>
+            <a:lstStyle/>
+            <a:p>
+              <a:r>
+                <a:rPr lang="en-US" dirty="0"/>
+                <a:t>surnames = [“Messi”, “Juli</a:t>
+              </a:r>
+              <a:r>
+                <a:rPr lang="es-AR" dirty="0" err="1"/>
+                <a:t>án</a:t>
+              </a:r>
+              <a:r>
+                <a:rPr lang="es-AR" dirty="0"/>
+                <a:t>”, “Ángel”, “</a:t>
+              </a:r>
+              <a:r>
+                <a:rPr lang="es-AR" dirty="0" err="1"/>
+                <a:t>Dibu</a:t>
+              </a:r>
+              <a:r>
+                <a:rPr lang="es-AR" dirty="0"/>
+                <a:t>”</a:t>
+              </a:r>
+              <a:r>
+                <a:rPr lang="en-US" dirty="0"/>
+                <a:t>]</a:t>
+              </a:r>
+            </a:p>
+          </p:txBody>
+        </p:sp>
+        <p:sp>
+          <p:nvSpPr>
+            <p:cNvPr id="21" name="CuadroTexto 20">
+              <a:extLst>
+                <a:ext uri="{FF2B5EF4-FFF2-40B4-BE49-F238E27FC236}">
+                  <a16:creationId xmlns:a16="http://schemas.microsoft.com/office/drawing/2014/main" id="{B43E2AD1-9584-53E5-A629-AF377D70E7B3}"/>
+                </a:ext>
+              </a:extLst>
+            </p:cNvPr>
+            <p:cNvSpPr txBox="1"/>
+            <p:nvPr/>
+          </p:nvSpPr>
+          <p:spPr>
+            <a:xfrm>
+              <a:off x="7896781" y="695741"/>
+              <a:ext cx="847164" cy="369332"/>
+            </a:xfrm>
+            <a:prstGeom prst="rect">
+              <a:avLst/>
+            </a:prstGeom>
+            <a:noFill/>
+          </p:spPr>
+          <p:txBody>
+            <a:bodyPr wrap="square" rtlCol="0">
+              <a:spAutoFit/>
+            </a:bodyPr>
+            <a:lstStyle/>
+            <a:p>
+              <a:r>
+                <a:rPr lang="en-US" dirty="0"/>
+                <a:t>Ln 2</a:t>
+              </a:r>
+            </a:p>
+          </p:txBody>
+        </p:sp>
+      </p:grpSp>
+      <p:sp>
+        <p:nvSpPr>
+          <p:cNvPr id="16" name="Forma libre: forma 15">
+            <a:extLst>
+              <a:ext uri="{FF2B5EF4-FFF2-40B4-BE49-F238E27FC236}">
+                <a16:creationId xmlns:a16="http://schemas.microsoft.com/office/drawing/2014/main" id="{38E607E6-0C76-6F3A-7B42-BC8CF9661986}"/>
+              </a:ext>
+            </a:extLst>
+          </p:cNvPr>
+          <p:cNvSpPr/>
+          <p:nvPr/>
+        </p:nvSpPr>
+        <p:spPr>
+          <a:xfrm>
+            <a:off x="391405" y="1900135"/>
+            <a:ext cx="747686" cy="1769502"/>
+          </a:xfrm>
+          <a:custGeom>
+            <a:avLst/>
+            <a:gdLst>
+              <a:gd name="connsiteX0" fmla="*/ 1268696 w 1907325"/>
+              <a:gd name="connsiteY0" fmla="*/ 0 h 4513942"/>
+              <a:gd name="connsiteX1" fmla="*/ 1544467 w 1907325"/>
+              <a:gd name="connsiteY1" fmla="*/ 348342 h 4513942"/>
+              <a:gd name="connsiteX2" fmla="*/ 1762181 w 1907325"/>
+              <a:gd name="connsiteY2" fmla="*/ 914400 h 4513942"/>
+              <a:gd name="connsiteX3" fmla="*/ 1776696 w 1907325"/>
+              <a:gd name="connsiteY3" fmla="*/ 1524000 h 4513942"/>
+              <a:gd name="connsiteX4" fmla="*/ 1500924 w 1907325"/>
+              <a:gd name="connsiteY4" fmla="*/ 2206171 h 4513942"/>
+              <a:gd name="connsiteX5" fmla="*/ 1297724 w 1907325"/>
+              <a:gd name="connsiteY5" fmla="*/ 2496457 h 4513942"/>
+              <a:gd name="connsiteX6" fmla="*/ 572010 w 1907325"/>
+              <a:gd name="connsiteY6" fmla="*/ 2772228 h 4513942"/>
+              <a:gd name="connsiteX7" fmla="*/ 281724 w 1907325"/>
+              <a:gd name="connsiteY7" fmla="*/ 2714171 h 4513942"/>
+              <a:gd name="connsiteX8" fmla="*/ 5953 w 1907325"/>
+              <a:gd name="connsiteY8" fmla="*/ 2119085 h 4513942"/>
+              <a:gd name="connsiteX9" fmla="*/ 20467 w 1907325"/>
+              <a:gd name="connsiteY9" fmla="*/ 1640114 h 4513942"/>
+              <a:gd name="connsiteX10" fmla="*/ 194638 w 1907325"/>
+              <a:gd name="connsiteY10" fmla="*/ 1364342 h 4513942"/>
+              <a:gd name="connsiteX11" fmla="*/ 891324 w 1907325"/>
+              <a:gd name="connsiteY11" fmla="*/ 1088571 h 4513942"/>
+              <a:gd name="connsiteX12" fmla="*/ 1181610 w 1907325"/>
+              <a:gd name="connsiteY12" fmla="*/ 1059542 h 4513942"/>
+              <a:gd name="connsiteX13" fmla="*/ 1370296 w 1907325"/>
+              <a:gd name="connsiteY13" fmla="*/ 1103085 h 4513942"/>
+              <a:gd name="connsiteX14" fmla="*/ 1646067 w 1907325"/>
+              <a:gd name="connsiteY14" fmla="*/ 1320800 h 4513942"/>
+              <a:gd name="connsiteX15" fmla="*/ 1747667 w 1907325"/>
+              <a:gd name="connsiteY15" fmla="*/ 1640114 h 4513942"/>
+              <a:gd name="connsiteX16" fmla="*/ 1892810 w 1907325"/>
+              <a:gd name="connsiteY16" fmla="*/ 2249714 h 4513942"/>
+              <a:gd name="connsiteX17" fmla="*/ 1805724 w 1907325"/>
+              <a:gd name="connsiteY17" fmla="*/ 3135085 h 4513942"/>
+              <a:gd name="connsiteX18" fmla="*/ 1660581 w 1907325"/>
+              <a:gd name="connsiteY18" fmla="*/ 3614057 h 4513942"/>
+              <a:gd name="connsiteX19" fmla="*/ 1399324 w 1907325"/>
+              <a:gd name="connsiteY19" fmla="*/ 3947885 h 4513942"/>
+              <a:gd name="connsiteX20" fmla="*/ 1283210 w 1907325"/>
+              <a:gd name="connsiteY20" fmla="*/ 4122057 h 4513942"/>
+              <a:gd name="connsiteX21" fmla="*/ 1196124 w 1907325"/>
+              <a:gd name="connsiteY21" fmla="*/ 4397828 h 4513942"/>
+              <a:gd name="connsiteX22" fmla="*/ 1152581 w 1907325"/>
+              <a:gd name="connsiteY22" fmla="*/ 4513942 h 4513942"/>
+            </a:gdLst>
+            <a:ahLst/>
+            <a:cxnLst>
+              <a:cxn ang="0">
+                <a:pos x="connsiteX0" y="connsiteY0"/>
+              </a:cxn>
+              <a:cxn ang="0">
+                <a:pos x="connsiteX1" y="connsiteY1"/>
+              </a:cxn>
+              <a:cxn ang="0">
+                <a:pos x="connsiteX2" y="connsiteY2"/>
+              </a:cxn>
+              <a:cxn ang="0">
+                <a:pos x="connsiteX3" y="connsiteY3"/>
+              </a:cxn>
+              <a:cxn ang="0">
+                <a:pos x="connsiteX4" y="connsiteY4"/>
+              </a:cxn>
+              <a:cxn ang="0">
+                <a:pos x="connsiteX5" y="connsiteY5"/>
+              </a:cxn>
+              <a:cxn ang="0">
+                <a:pos x="connsiteX6" y="connsiteY6"/>
+              </a:cxn>
+              <a:cxn ang="0">
+                <a:pos x="connsiteX7" y="connsiteY7"/>
+              </a:cxn>
+              <a:cxn ang="0">
+                <a:pos x="connsiteX8" y="connsiteY8"/>
+              </a:cxn>
+              <a:cxn ang="0">
+                <a:pos x="connsiteX9" y="connsiteY9"/>
+              </a:cxn>
+              <a:cxn ang="0">
+                <a:pos x="connsiteX10" y="connsiteY10"/>
+              </a:cxn>
+              <a:cxn ang="0">
+                <a:pos x="connsiteX11" y="connsiteY11"/>
+              </a:cxn>
+              <a:cxn ang="0">
+                <a:pos x="connsiteX12" y="connsiteY12"/>
+              </a:cxn>
+              <a:cxn ang="0">
+                <a:pos x="connsiteX13" y="connsiteY13"/>
+              </a:cxn>
+              <a:cxn ang="0">
+                <a:pos x="connsiteX14" y="connsiteY14"/>
+              </a:cxn>
+              <a:cxn ang="0">
+                <a:pos x="connsiteX15" y="connsiteY15"/>
+              </a:cxn>
+              <a:cxn ang="0">
+                <a:pos x="connsiteX16" y="connsiteY16"/>
+              </a:cxn>
+              <a:cxn ang="0">
+                <a:pos x="connsiteX17" y="connsiteY17"/>
+              </a:cxn>
+              <a:cxn ang="0">
+                <a:pos x="connsiteX18" y="connsiteY18"/>
+              </a:cxn>
+              <a:cxn ang="0">
+                <a:pos x="connsiteX19" y="connsiteY19"/>
+              </a:cxn>
+              <a:cxn ang="0">
+                <a:pos x="connsiteX20" y="connsiteY20"/>
+              </a:cxn>
+              <a:cxn ang="0">
+                <a:pos x="connsiteX21" y="connsiteY21"/>
+              </a:cxn>
+              <a:cxn ang="0">
+                <a:pos x="connsiteX22" y="connsiteY22"/>
+              </a:cxn>
+            </a:cxnLst>
+            <a:rect l="l" t="t" r="r" b="b"/>
+            <a:pathLst>
+              <a:path w="1907325" h="4513942">
+                <a:moveTo>
+                  <a:pt x="1268696" y="0"/>
+                </a:moveTo>
+                <a:cubicBezTo>
+                  <a:pt x="1442773" y="124340"/>
+                  <a:pt x="1389854" y="67227"/>
+                  <a:pt x="1544467" y="348342"/>
+                </a:cubicBezTo>
+                <a:cubicBezTo>
+                  <a:pt x="1699367" y="629979"/>
+                  <a:pt x="1682866" y="628863"/>
+                  <a:pt x="1762181" y="914400"/>
+                </a:cubicBezTo>
+                <a:cubicBezTo>
+                  <a:pt x="1776471" y="1078734"/>
+                  <a:pt x="1815799" y="1351947"/>
+                  <a:pt x="1776696" y="1524000"/>
+                </a:cubicBezTo>
+                <a:cubicBezTo>
+                  <a:pt x="1747705" y="1651561"/>
+                  <a:pt x="1570804" y="2083882"/>
+                  <a:pt x="1500924" y="2206171"/>
+                </a:cubicBezTo>
+                <a:cubicBezTo>
+                  <a:pt x="1442324" y="2308722"/>
+                  <a:pt x="1384895" y="2416758"/>
+                  <a:pt x="1297724" y="2496457"/>
+                </a:cubicBezTo>
+                <a:cubicBezTo>
+                  <a:pt x="1086760" y="2689339"/>
+                  <a:pt x="836364" y="2708418"/>
+                  <a:pt x="572010" y="2772228"/>
+                </a:cubicBezTo>
+                <a:cubicBezTo>
+                  <a:pt x="475248" y="2752876"/>
+                  <a:pt x="368793" y="2760608"/>
+                  <a:pt x="281724" y="2714171"/>
+                </a:cubicBezTo>
+                <a:cubicBezTo>
+                  <a:pt x="101836" y="2618231"/>
+                  <a:pt x="43703" y="2240724"/>
+                  <a:pt x="5953" y="2119085"/>
+                </a:cubicBezTo>
+                <a:cubicBezTo>
+                  <a:pt x="10791" y="1959428"/>
+                  <a:pt x="-18273" y="1795075"/>
+                  <a:pt x="20467" y="1640114"/>
+                </a:cubicBezTo>
+                <a:cubicBezTo>
+                  <a:pt x="46836" y="1534637"/>
+                  <a:pt x="119120" y="1442557"/>
+                  <a:pt x="194638" y="1364342"/>
+                </a:cubicBezTo>
+                <a:cubicBezTo>
+                  <a:pt x="353037" y="1200286"/>
+                  <a:pt x="709339" y="1127068"/>
+                  <a:pt x="891324" y="1088571"/>
+                </a:cubicBezTo>
+                <a:cubicBezTo>
+                  <a:pt x="986463" y="1068445"/>
+                  <a:pt x="1084848" y="1069218"/>
+                  <a:pt x="1181610" y="1059542"/>
+                </a:cubicBezTo>
+                <a:cubicBezTo>
+                  <a:pt x="1244505" y="1074056"/>
+                  <a:pt x="1310554" y="1078645"/>
+                  <a:pt x="1370296" y="1103085"/>
+                </a:cubicBezTo>
+                <a:cubicBezTo>
+                  <a:pt x="1458125" y="1139015"/>
+                  <a:pt x="1582620" y="1263698"/>
+                  <a:pt x="1646067" y="1320800"/>
+                </a:cubicBezTo>
+                <a:cubicBezTo>
+                  <a:pt x="1679934" y="1427238"/>
+                  <a:pt x="1718992" y="1532161"/>
+                  <a:pt x="1747667" y="1640114"/>
+                </a:cubicBezTo>
+                <a:cubicBezTo>
+                  <a:pt x="1801291" y="1841994"/>
+                  <a:pt x="1892810" y="2249714"/>
+                  <a:pt x="1892810" y="2249714"/>
+                </a:cubicBezTo>
+                <a:cubicBezTo>
+                  <a:pt x="1912101" y="2693420"/>
+                  <a:pt x="1933113" y="2603050"/>
+                  <a:pt x="1805724" y="3135085"/>
+                </a:cubicBezTo>
+                <a:cubicBezTo>
+                  <a:pt x="1766878" y="3297326"/>
+                  <a:pt x="1735188" y="3464843"/>
+                  <a:pt x="1660581" y="3614057"/>
+                </a:cubicBezTo>
+                <a:cubicBezTo>
+                  <a:pt x="1597389" y="3740441"/>
+                  <a:pt x="1483586" y="3834456"/>
+                  <a:pt x="1399324" y="3947885"/>
+                </a:cubicBezTo>
+                <a:cubicBezTo>
+                  <a:pt x="1357715" y="4003897"/>
+                  <a:pt x="1321915" y="4064000"/>
+                  <a:pt x="1283210" y="4122057"/>
+                </a:cubicBezTo>
+                <a:cubicBezTo>
+                  <a:pt x="1254181" y="4213981"/>
+                  <a:pt x="1226608" y="4306377"/>
+                  <a:pt x="1196124" y="4397828"/>
+                </a:cubicBezTo>
+                <a:cubicBezTo>
+                  <a:pt x="1183052" y="4437043"/>
+                  <a:pt x="1152581" y="4513942"/>
+                  <a:pt x="1152581" y="4513942"/>
+                </a:cubicBezTo>
+              </a:path>
+            </a:pathLst>
+          </a:custGeom>
+          <a:noFill/>
+          <a:ln w="76200"/>
+        </p:spPr>
+        <p:style>
+          <a:lnRef idx="2">
+            <a:schemeClr val="accent1">
+              <a:shade val="15000"/>
+            </a:schemeClr>
+          </a:lnRef>
+          <a:fillRef idx="1">
+            <a:schemeClr val="accent1"/>
+          </a:fillRef>
+          <a:effectRef idx="0">
+            <a:schemeClr val="accent1"/>
+          </a:effectRef>
+          <a:fontRef idx="minor">
+            <a:schemeClr val="lt1"/>
+          </a:fontRef>
+        </p:style>
+        <p:txBody>
+          <a:bodyPr rtlCol="0" anchor="ctr"/>
+          <a:lstStyle/>
+          <a:p>
+            <a:pPr algn="ctr"/>
+            <a:endParaRPr lang="en-US"/>
+          </a:p>
+        </p:txBody>
+      </p:sp>
+      <p:sp>
+        <p:nvSpPr>
+          <p:cNvPr id="24" name="Título 1">
+            <a:extLst>
+              <a:ext uri="{FF2B5EF4-FFF2-40B4-BE49-F238E27FC236}">
+                <a16:creationId xmlns:a16="http://schemas.microsoft.com/office/drawing/2014/main" id="{33C17B9E-9B9F-F39B-4C2D-6356E6F19C1A}"/>
+              </a:ext>
+            </a:extLst>
+          </p:cNvPr>
+          <p:cNvSpPr txBox="1">
+            <a:spLocks/>
+          </p:cNvSpPr>
+          <p:nvPr/>
+        </p:nvSpPr>
+        <p:spPr>
+          <a:xfrm>
+            <a:off x="129860" y="365125"/>
+            <a:ext cx="6853430" cy="1174941"/>
+          </a:xfrm>
+          <a:prstGeom prst="rect">
+            <a:avLst/>
+          </a:prstGeom>
+        </p:spPr>
+        <p:txBody>
+          <a:bodyPr vert="horz" lIns="91440" tIns="45720" rIns="91440" bIns="45720" rtlCol="0" anchor="ctr">
+            <a:normAutofit/>
+          </a:bodyPr>
+          <a:lstStyle>
+            <a:lvl1pPr algn="l" defTabSz="914400" rtl="0" eaLnBrk="1" latinLnBrk="0" hangingPunct="1">
+              <a:lnSpc>
+                <a:spcPct val="90000"/>
+              </a:lnSpc>
+              <a:spcBef>
+                <a:spcPct val="0"/>
+              </a:spcBef>
+              <a:buNone/>
+              <a:defRPr sz="4400" kern="1200">
+                <a:solidFill>
+                  <a:schemeClr val="tx1"/>
+                </a:solidFill>
+                <a:latin typeface="+mj-lt"/>
+                <a:ea typeface="+mj-ea"/>
+                <a:cs typeface="+mj-cs"/>
+              </a:defRPr>
+            </a:lvl1pPr>
+          </a:lstStyle>
+          <a:p>
+            <a:r>
+              <a:rPr lang="es-AR" sz="2800" b="1" dirty="0" err="1">
+                <a:latin typeface="Consolas" panose="020B0609020204030204" pitchFamily="49" charset="0"/>
+                <a:cs typeface="Cascadia Code SemiBold" panose="020B0609020000020004" pitchFamily="49" charset="0"/>
+              </a:rPr>
+              <a:t>For</a:t>
+            </a:r>
+            <a:r>
+              <a:rPr lang="es-AR" sz="2800" b="1" dirty="0">
+                <a:latin typeface="Consolas" panose="020B0609020204030204" pitchFamily="49" charset="0"/>
+                <a:cs typeface="Cascadia Code SemiBold" panose="020B0609020000020004" pitchFamily="49" charset="0"/>
+              </a:rPr>
+              <a:t> ____ in </a:t>
+            </a:r>
+            <a:r>
+              <a:rPr lang="es-AR" sz="2800" b="1" dirty="0" err="1">
+                <a:latin typeface="Consolas" panose="020B0609020204030204" pitchFamily="49" charset="0"/>
+                <a:cs typeface="Cascadia Code SemiBold" panose="020B0609020000020004" pitchFamily="49" charset="0"/>
+              </a:rPr>
+              <a:t>range</a:t>
+            </a:r>
+            <a:r>
+              <a:rPr lang="es-AR" sz="2800" b="1" dirty="0">
+                <a:latin typeface="Consolas" panose="020B0609020204030204" pitchFamily="49" charset="0"/>
+                <a:cs typeface="Cascadia Code SemiBold" panose="020B0609020000020004" pitchFamily="49" charset="0"/>
+              </a:rPr>
+              <a:t>(a, b, c)</a:t>
+            </a:r>
+            <a:br>
+              <a:rPr lang="es-AR" sz="3600" dirty="0"/>
+            </a:br>
+            <a:r>
+              <a:rPr lang="es-AR" sz="2800" i="1" dirty="0">
+                <a:solidFill>
+                  <a:schemeClr val="bg2">
+                    <a:lumMod val="50000"/>
+                  </a:schemeClr>
+                </a:solidFill>
+              </a:rPr>
+              <a:t>(</a:t>
+            </a:r>
+            <a:r>
+              <a:rPr lang="es-AR" sz="2800" i="1" dirty="0" err="1">
+                <a:solidFill>
+                  <a:schemeClr val="bg2">
+                    <a:lumMod val="50000"/>
+                  </a:schemeClr>
+                </a:solidFill>
+              </a:rPr>
+              <a:t>loop</a:t>
+            </a:r>
+            <a:r>
+              <a:rPr lang="es-AR" sz="2800" i="1" dirty="0">
+                <a:solidFill>
+                  <a:schemeClr val="bg2">
+                    <a:lumMod val="50000"/>
+                  </a:schemeClr>
+                </a:solidFill>
+              </a:rPr>
+              <a:t>)</a:t>
+            </a:r>
+            <a:r>
+              <a:rPr lang="es-AR" sz="2800" dirty="0"/>
+              <a:t> </a:t>
+            </a:r>
+            <a:endParaRPr lang="en-US" sz="3600" dirty="0"/>
+          </a:p>
+        </p:txBody>
+      </p:sp>
+      <p:pic>
+        <p:nvPicPr>
+          <p:cNvPr id="4" name="Imagen 3">
+            <a:extLst>
+              <a:ext uri="{FF2B5EF4-FFF2-40B4-BE49-F238E27FC236}">
+                <a16:creationId xmlns:a16="http://schemas.microsoft.com/office/drawing/2014/main" id="{C62399E7-661C-851F-0274-DE435BF9C3A1}"/>
+              </a:ext>
+            </a:extLst>
+          </p:cNvPr>
+          <p:cNvPicPr>
+            <a:picLocks noChangeAspect="1"/>
+          </p:cNvPicPr>
+          <p:nvPr/>
+        </p:nvPicPr>
+        <p:blipFill>
+          <a:blip r:embed="rId3"/>
+          <a:stretch>
+            <a:fillRect/>
+          </a:stretch>
+        </p:blipFill>
+        <p:spPr>
+          <a:xfrm>
+            <a:off x="0" y="5044703"/>
+            <a:ext cx="7109141" cy="1799621"/>
+          </a:xfrm>
+          <a:prstGeom prst="rect">
+            <a:avLst/>
+          </a:prstGeom>
+        </p:spPr>
+      </p:pic>
+    </p:spTree>
+    <p:extLst>
+      <p:ext uri="{BB962C8B-B14F-4D97-AF65-F5344CB8AC3E}">
+        <p14:creationId xmlns:p14="http://schemas.microsoft.com/office/powerpoint/2010/main" val="2107084744"/>
       </p:ext>
     </p:extLst>
   </p:cSld>
@@ -11674,36 +15081,6 @@
           </a:prstGeom>
         </p:spPr>
       </p:pic>
-      <p:pic>
-        <p:nvPicPr>
-          <p:cNvPr id="7" name="Imagen 6">
-            <a:extLst>
-              <a:ext uri="{FF2B5EF4-FFF2-40B4-BE49-F238E27FC236}">
-                <a16:creationId xmlns:a16="http://schemas.microsoft.com/office/drawing/2014/main" id="{CA472234-5CF7-A9D7-788C-BB6300035578}"/>
-              </a:ext>
-            </a:extLst>
-          </p:cNvPr>
-          <p:cNvPicPr>
-            <a:picLocks noChangeAspect="1"/>
-          </p:cNvPicPr>
-          <p:nvPr/>
-        </p:nvPicPr>
-        <p:blipFill>
-          <a:blip r:embed="rId3"/>
-          <a:stretch>
-            <a:fillRect/>
-          </a:stretch>
-        </p:blipFill>
-        <p:spPr>
-          <a:xfrm>
-            <a:off x="6460053" y="1359568"/>
-            <a:ext cx="5385596" cy="3537286"/>
-          </a:xfrm>
-          <a:prstGeom prst="rect">
-            <a:avLst/>
-          </a:prstGeom>
-        </p:spPr>
-      </p:pic>
       <p:sp>
         <p:nvSpPr>
           <p:cNvPr id="6" name="Título 1">
@@ -11781,6 +15158,36 @@
           </a:p>
         </p:txBody>
       </p:sp>
+      <p:pic>
+        <p:nvPicPr>
+          <p:cNvPr id="3" name="Imagen 2">
+            <a:extLst>
+              <a:ext uri="{FF2B5EF4-FFF2-40B4-BE49-F238E27FC236}">
+                <a16:creationId xmlns:a16="http://schemas.microsoft.com/office/drawing/2014/main" id="{37BD7524-3761-73AB-960B-47BB6E3EE4B9}"/>
+              </a:ext>
+            </a:extLst>
+          </p:cNvPr>
+          <p:cNvPicPr>
+            <a:picLocks noChangeAspect="1"/>
+          </p:cNvPicPr>
+          <p:nvPr/>
+        </p:nvPicPr>
+        <p:blipFill>
+          <a:blip r:embed="rId3"/>
+          <a:stretch>
+            <a:fillRect/>
+          </a:stretch>
+        </p:blipFill>
+        <p:spPr>
+          <a:xfrm>
+            <a:off x="6637693" y="1359568"/>
+            <a:ext cx="5030315" cy="3304171"/>
+          </a:xfrm>
+          <a:prstGeom prst="rect">
+            <a:avLst/>
+          </a:prstGeom>
+        </p:spPr>
+      </p:pic>
     </p:spTree>
     <p:extLst>
       <p:ext uri="{BB962C8B-B14F-4D97-AF65-F5344CB8AC3E}">

</xml_diff>

<commit_message>
finished power points on loops (for and while).
</commit_message>
<xml_diff>
--- a/Python/CONTROL FLOW STRUCTURES (lessons #7 - )/PowerPoints & PDFs/Lesson +#7 - Making decisions (CFGs) v2.pptx
+++ b/Python/CONTROL FLOW STRUCTURES (lessons #7 - )/PowerPoints & PDFs/Lesson +#7 - Making decisions (CFGs) v2.pptx
@@ -16,10 +16,12 @@
     <p:sldId id="265" r:id="rId10"/>
     <p:sldId id="266" r:id="rId11"/>
     <p:sldId id="270" r:id="rId12"/>
-    <p:sldId id="274" r:id="rId13"/>
-    <p:sldId id="271" r:id="rId14"/>
-    <p:sldId id="276" r:id="rId15"/>
-    <p:sldId id="275" r:id="rId16"/>
+    <p:sldId id="278" r:id="rId13"/>
+    <p:sldId id="274" r:id="rId14"/>
+    <p:sldId id="271" r:id="rId15"/>
+    <p:sldId id="276" r:id="rId16"/>
+    <p:sldId id="275" r:id="rId17"/>
+    <p:sldId id="277" r:id="rId18"/>
   </p:sldIdLst>
   <p:sldSz cx="12192000" cy="6858000"/>
   <p:notesSz cx="6858000" cy="9144000"/>
@@ -3676,8 +3678,8 @@
         </p:blipFill>
         <p:spPr>
           <a:xfrm>
-            <a:off x="10468761" y="1771531"/>
-            <a:ext cx="1177254" cy="3632596"/>
+            <a:off x="10468761" y="3617487"/>
+            <a:ext cx="1177254" cy="1786640"/>
           </a:xfrm>
           <a:prstGeom prst="rect">
             <a:avLst/>
@@ -3985,7 +3987,7 @@
         </p:nvSpPr>
         <p:spPr>
           <a:xfrm>
-            <a:off x="7896781" y="695741"/>
+            <a:off x="7780320" y="708943"/>
             <a:ext cx="847164" cy="369332"/>
           </a:xfrm>
           <a:prstGeom prst="rect">
@@ -4020,7 +4022,7 @@
         </p:nvSpPr>
         <p:spPr>
           <a:xfrm>
-            <a:off x="6983290" y="2662913"/>
+            <a:off x="7366219" y="3889814"/>
             <a:ext cx="361682" cy="769441"/>
           </a:xfrm>
           <a:prstGeom prst="rect">
@@ -4059,7 +4061,7 @@
         </p:nvSpPr>
         <p:spPr>
           <a:xfrm>
-            <a:off x="10903574" y="2553521"/>
+            <a:off x="10353542" y="3736718"/>
             <a:ext cx="583841" cy="769441"/>
           </a:xfrm>
           <a:prstGeom prst="rect">
@@ -4080,49 +4082,6 @@
                 </a:solidFill>
               </a:rPr>
               <a:t>F</a:t>
-            </a:r>
-          </a:p>
-        </p:txBody>
-      </p:sp>
-      <p:sp>
-        <p:nvSpPr>
-          <p:cNvPr id="15" name="CuadroTexto 14">
-            <a:extLst>
-              <a:ext uri="{FF2B5EF4-FFF2-40B4-BE49-F238E27FC236}">
-                <a16:creationId xmlns:a16="http://schemas.microsoft.com/office/drawing/2014/main" id="{4B4F8199-CCFA-42D1-8ED2-649051600151}"/>
-              </a:ext>
-            </a:extLst>
-          </p:cNvPr>
-          <p:cNvSpPr txBox="1"/>
-          <p:nvPr/>
-        </p:nvSpPr>
-        <p:spPr>
-          <a:xfrm>
-            <a:off x="7693154" y="2262593"/>
-            <a:ext cx="2943068" cy="369332"/>
-          </a:xfrm>
-          <a:prstGeom prst="rect">
-            <a:avLst/>
-          </a:prstGeom>
-          <a:noFill/>
-        </p:spPr>
-        <p:txBody>
-          <a:bodyPr wrap="square" rtlCol="0">
-            <a:spAutoFit/>
-          </a:bodyPr>
-          <a:lstStyle/>
-          <a:p>
-            <a:r>
-              <a:rPr lang="en-US" dirty="0"/>
-              <a:t>is </a:t>
-            </a:r>
-            <a:r>
-              <a:rPr lang="en-US" dirty="0" err="1"/>
-              <a:t>kettle_temperature</a:t>
-            </a:r>
-            <a:r>
-              <a:rPr lang="en-US" dirty="0"/>
-              <a:t> &lt; 100?</a:t>
             </a:r>
           </a:p>
         </p:txBody>
@@ -4413,36 +4372,6 @@
           </a:p>
         </p:txBody>
       </p:sp>
-      <p:pic>
-        <p:nvPicPr>
-          <p:cNvPr id="21" name="Imagen 20">
-            <a:extLst>
-              <a:ext uri="{FF2B5EF4-FFF2-40B4-BE49-F238E27FC236}">
-                <a16:creationId xmlns:a16="http://schemas.microsoft.com/office/drawing/2014/main" id="{DD59D213-C35C-8917-D92F-99544163F523}"/>
-              </a:ext>
-            </a:extLst>
-          </p:cNvPr>
-          <p:cNvPicPr>
-            <a:picLocks noChangeAspect="1"/>
-          </p:cNvPicPr>
-          <p:nvPr/>
-        </p:nvPicPr>
-        <p:blipFill>
-          <a:blip r:embed="rId3"/>
-          <a:stretch>
-            <a:fillRect/>
-          </a:stretch>
-        </p:blipFill>
-        <p:spPr>
-          <a:xfrm>
-            <a:off x="-14381" y="5034794"/>
-            <a:ext cx="7407730" cy="1823205"/>
-          </a:xfrm>
-          <a:prstGeom prst="rect">
-            <a:avLst/>
-          </a:prstGeom>
-        </p:spPr>
-      </p:pic>
       <p:sp>
         <p:nvSpPr>
           <p:cNvPr id="25" name="Elipse 24">
@@ -4457,7 +4386,7 @@
         </p:nvSpPr>
         <p:spPr>
           <a:xfrm>
-            <a:off x="2266682" y="1684359"/>
+            <a:off x="1764850" y="3410623"/>
             <a:ext cx="4716608" cy="958383"/>
           </a:xfrm>
           <a:prstGeom prst="ellipse">
@@ -4507,7 +4436,7 @@
         </p:nvSpPr>
         <p:spPr>
           <a:xfrm>
-            <a:off x="2521355" y="1978884"/>
+            <a:off x="2019523" y="3705148"/>
             <a:ext cx="4523388" cy="369332"/>
           </a:xfrm>
           <a:prstGeom prst="rect">
@@ -4554,7 +4483,7 @@
         </p:nvSpPr>
         <p:spPr>
           <a:xfrm>
-            <a:off x="2665781" y="1450924"/>
+            <a:off x="2163949" y="3177188"/>
             <a:ext cx="847164" cy="369332"/>
           </a:xfrm>
           <a:prstGeom prst="rect">
@@ -4570,7 +4499,7 @@
           <a:p>
             <a:r>
               <a:rPr lang="en-US" dirty="0"/>
-              <a:t>Ln 3</a:t>
+              <a:t>Ln 4</a:t>
             </a:r>
           </a:p>
         </p:txBody>
@@ -4589,7 +4518,7 @@
         </p:nvSpPr>
         <p:spPr>
           <a:xfrm>
-            <a:off x="5143432" y="2044700"/>
+            <a:off x="4641600" y="3770964"/>
             <a:ext cx="2832168" cy="1485900"/>
           </a:xfrm>
           <a:custGeom>
@@ -4845,7 +4774,7 @@
         </p:nvSpPr>
         <p:spPr>
           <a:xfrm>
-            <a:off x="4572000" y="684948"/>
+            <a:off x="4070168" y="2411212"/>
             <a:ext cx="2921000" cy="826352"/>
           </a:xfrm>
           <a:custGeom>
@@ -5029,6 +4958,333 @@
           </a:p>
         </p:txBody>
       </p:sp>
+      <p:grpSp>
+        <p:nvGrpSpPr>
+          <p:cNvPr id="17" name="Grupo 16">
+            <a:extLst>
+              <a:ext uri="{FF2B5EF4-FFF2-40B4-BE49-F238E27FC236}">
+                <a16:creationId xmlns:a16="http://schemas.microsoft.com/office/drawing/2014/main" id="{1C086AAB-FF69-EFED-21C2-41EE37C733F5}"/>
+              </a:ext>
+            </a:extLst>
+          </p:cNvPr>
+          <p:cNvGrpSpPr/>
+          <p:nvPr/>
+        </p:nvGrpSpPr>
+        <p:grpSpPr>
+          <a:xfrm>
+            <a:off x="7063553" y="2778801"/>
+            <a:ext cx="3735004" cy="1095425"/>
+            <a:chOff x="7316008" y="3231645"/>
+            <a:chExt cx="3735004" cy="1095425"/>
+          </a:xfrm>
+        </p:grpSpPr>
+        <p:sp>
+          <p:nvSpPr>
+            <p:cNvPr id="16" name="Rombo 15">
+              <a:extLst>
+                <a:ext uri="{FF2B5EF4-FFF2-40B4-BE49-F238E27FC236}">
+                  <a16:creationId xmlns:a16="http://schemas.microsoft.com/office/drawing/2014/main" id="{18A8D79E-E171-C8D5-3342-D60C45368AA0}"/>
+                </a:ext>
+              </a:extLst>
+            </p:cNvPr>
+            <p:cNvSpPr/>
+            <p:nvPr/>
+          </p:nvSpPr>
+          <p:spPr>
+            <a:xfrm>
+              <a:off x="7316008" y="3286271"/>
+              <a:ext cx="3735004" cy="1040799"/>
+            </a:xfrm>
+            <a:prstGeom prst="diamond">
+              <a:avLst/>
+            </a:prstGeom>
+            <a:solidFill>
+              <a:srgbClr val="CAD7EE"/>
+            </a:solidFill>
+            <a:ln w="38100"/>
+          </p:spPr>
+          <p:style>
+            <a:lnRef idx="2">
+              <a:schemeClr val="accent1">
+                <a:shade val="15000"/>
+              </a:schemeClr>
+            </a:lnRef>
+            <a:fillRef idx="1">
+              <a:schemeClr val="accent1"/>
+            </a:fillRef>
+            <a:effectRef idx="0">
+              <a:schemeClr val="accent1"/>
+            </a:effectRef>
+            <a:fontRef idx="minor">
+              <a:schemeClr val="lt1"/>
+            </a:fontRef>
+          </p:style>
+          <p:txBody>
+            <a:bodyPr rtlCol="0" anchor="ctr"/>
+            <a:lstStyle/>
+            <a:p>
+              <a:pPr algn="ctr"/>
+              <a:endParaRPr lang="en-US"/>
+            </a:p>
+          </p:txBody>
+        </p:sp>
+        <p:sp>
+          <p:nvSpPr>
+            <p:cNvPr id="12" name="CuadroTexto 11">
+              <a:extLst>
+                <a:ext uri="{FF2B5EF4-FFF2-40B4-BE49-F238E27FC236}">
+                  <a16:creationId xmlns:a16="http://schemas.microsoft.com/office/drawing/2014/main" id="{02345419-483F-DACF-4D0A-1EF64029834A}"/>
+                </a:ext>
+              </a:extLst>
+            </p:cNvPr>
+            <p:cNvSpPr txBox="1"/>
+            <p:nvPr/>
+          </p:nvSpPr>
+          <p:spPr>
+            <a:xfrm>
+              <a:off x="7631318" y="3231645"/>
+              <a:ext cx="847164" cy="369332"/>
+            </a:xfrm>
+            <a:prstGeom prst="rect">
+              <a:avLst/>
+            </a:prstGeom>
+            <a:noFill/>
+          </p:spPr>
+          <p:txBody>
+            <a:bodyPr wrap="square" rtlCol="0">
+              <a:spAutoFit/>
+            </a:bodyPr>
+            <a:lstStyle/>
+            <a:p>
+              <a:r>
+                <a:rPr lang="en-US" dirty="0"/>
+                <a:t>Ln 3</a:t>
+              </a:r>
+            </a:p>
+          </p:txBody>
+        </p:sp>
+        <p:sp>
+          <p:nvSpPr>
+            <p:cNvPr id="15" name="CuadroTexto 14">
+              <a:extLst>
+                <a:ext uri="{FF2B5EF4-FFF2-40B4-BE49-F238E27FC236}">
+                  <a16:creationId xmlns:a16="http://schemas.microsoft.com/office/drawing/2014/main" id="{4B4F8199-CCFA-42D1-8ED2-649051600151}"/>
+                </a:ext>
+              </a:extLst>
+            </p:cNvPr>
+            <p:cNvSpPr txBox="1"/>
+            <p:nvPr/>
+          </p:nvSpPr>
+          <p:spPr>
+            <a:xfrm>
+              <a:off x="7780320" y="3616696"/>
+              <a:ext cx="2943068" cy="369332"/>
+            </a:xfrm>
+            <a:prstGeom prst="rect">
+              <a:avLst/>
+            </a:prstGeom>
+            <a:noFill/>
+          </p:spPr>
+          <p:txBody>
+            <a:bodyPr wrap="square" rtlCol="0">
+              <a:spAutoFit/>
+            </a:bodyPr>
+            <a:lstStyle/>
+            <a:p>
+              <a:r>
+                <a:rPr lang="en-US" dirty="0"/>
+                <a:t>is </a:t>
+              </a:r>
+              <a:r>
+                <a:rPr lang="en-US" dirty="0" err="1"/>
+                <a:t>kettle_temperature</a:t>
+              </a:r>
+              <a:r>
+                <a:rPr lang="en-US" dirty="0"/>
+                <a:t> &lt; 100?</a:t>
+              </a:r>
+            </a:p>
+          </p:txBody>
+        </p:sp>
+      </p:grpSp>
+      <p:grpSp>
+        <p:nvGrpSpPr>
+          <p:cNvPr id="24" name="Grupo 23">
+            <a:extLst>
+              <a:ext uri="{FF2B5EF4-FFF2-40B4-BE49-F238E27FC236}">
+                <a16:creationId xmlns:a16="http://schemas.microsoft.com/office/drawing/2014/main" id="{7CC32200-6290-ED39-C6EE-1FE6B7E9691B}"/>
+              </a:ext>
+            </a:extLst>
+          </p:cNvPr>
+          <p:cNvGrpSpPr/>
+          <p:nvPr/>
+        </p:nvGrpSpPr>
+        <p:grpSpPr>
+          <a:xfrm>
+            <a:off x="8876407" y="2064424"/>
+            <a:ext cx="189715" cy="654403"/>
+            <a:chOff x="8839563" y="1988339"/>
+            <a:chExt cx="317500" cy="1095184"/>
+          </a:xfrm>
+        </p:grpSpPr>
+        <p:cxnSp>
+          <p:nvCxnSpPr>
+            <p:cNvPr id="20" name="Conector recto 19">
+              <a:extLst>
+                <a:ext uri="{FF2B5EF4-FFF2-40B4-BE49-F238E27FC236}">
+                  <a16:creationId xmlns:a16="http://schemas.microsoft.com/office/drawing/2014/main" id="{6202E547-FB47-063D-62FB-FBF43A30E875}"/>
+                </a:ext>
+              </a:extLst>
+            </p:cNvPr>
+            <p:cNvCxnSpPr>
+              <a:cxnSpLocks/>
+            </p:cNvCxnSpPr>
+            <p:nvPr/>
+          </p:nvCxnSpPr>
+          <p:spPr>
+            <a:xfrm>
+              <a:off x="8980418" y="1988339"/>
+              <a:ext cx="0" cy="1078443"/>
+            </a:xfrm>
+            <a:prstGeom prst="line">
+              <a:avLst/>
+            </a:prstGeom>
+            <a:ln w="38100">
+              <a:solidFill>
+                <a:srgbClr val="8A008A"/>
+              </a:solidFill>
+            </a:ln>
+          </p:spPr>
+          <p:style>
+            <a:lnRef idx="1">
+              <a:schemeClr val="accent1"/>
+            </a:lnRef>
+            <a:fillRef idx="0">
+              <a:schemeClr val="accent1"/>
+            </a:fillRef>
+            <a:effectRef idx="0">
+              <a:schemeClr val="accent1"/>
+            </a:effectRef>
+            <a:fontRef idx="minor">
+              <a:schemeClr val="tx1"/>
+            </a:fontRef>
+          </p:style>
+        </p:cxnSp>
+        <p:cxnSp>
+          <p:nvCxnSpPr>
+            <p:cNvPr id="22" name="Conector recto 21">
+              <a:extLst>
+                <a:ext uri="{FF2B5EF4-FFF2-40B4-BE49-F238E27FC236}">
+                  <a16:creationId xmlns:a16="http://schemas.microsoft.com/office/drawing/2014/main" id="{BE7EEDC0-F8EB-48B6-3C73-B4CAD62CC271}"/>
+                </a:ext>
+              </a:extLst>
+            </p:cNvPr>
+            <p:cNvCxnSpPr>
+              <a:cxnSpLocks/>
+            </p:cNvCxnSpPr>
+            <p:nvPr/>
+          </p:nvCxnSpPr>
+          <p:spPr>
+            <a:xfrm flipV="1">
+              <a:off x="8979263" y="2841788"/>
+              <a:ext cx="177800" cy="241735"/>
+            </a:xfrm>
+            <a:prstGeom prst="line">
+              <a:avLst/>
+            </a:prstGeom>
+            <a:ln w="38100">
+              <a:solidFill>
+                <a:srgbClr val="8A008A"/>
+              </a:solidFill>
+            </a:ln>
+          </p:spPr>
+          <p:style>
+            <a:lnRef idx="1">
+              <a:schemeClr val="accent1"/>
+            </a:lnRef>
+            <a:fillRef idx="0">
+              <a:schemeClr val="accent1"/>
+            </a:fillRef>
+            <a:effectRef idx="0">
+              <a:schemeClr val="accent1"/>
+            </a:effectRef>
+            <a:fontRef idx="minor">
+              <a:schemeClr val="tx1"/>
+            </a:fontRef>
+          </p:style>
+        </p:cxnSp>
+        <p:cxnSp>
+          <p:nvCxnSpPr>
+            <p:cNvPr id="23" name="Conector recto 22">
+              <a:extLst>
+                <a:ext uri="{FF2B5EF4-FFF2-40B4-BE49-F238E27FC236}">
+                  <a16:creationId xmlns:a16="http://schemas.microsoft.com/office/drawing/2014/main" id="{80B6EB50-BF66-87A1-881F-118308008BE7}"/>
+                </a:ext>
+              </a:extLst>
+            </p:cNvPr>
+            <p:cNvCxnSpPr/>
+            <p:nvPr/>
+          </p:nvCxnSpPr>
+          <p:spPr>
+            <a:xfrm flipH="1" flipV="1">
+              <a:off x="8839563" y="2841788"/>
+              <a:ext cx="139700" cy="241735"/>
+            </a:xfrm>
+            <a:prstGeom prst="line">
+              <a:avLst/>
+            </a:prstGeom>
+            <a:ln w="38100">
+              <a:solidFill>
+                <a:srgbClr val="8A008A"/>
+              </a:solidFill>
+            </a:ln>
+          </p:spPr>
+          <p:style>
+            <a:lnRef idx="1">
+              <a:schemeClr val="accent1"/>
+            </a:lnRef>
+            <a:fillRef idx="0">
+              <a:schemeClr val="accent1"/>
+            </a:fillRef>
+            <a:effectRef idx="0">
+              <a:schemeClr val="accent1"/>
+            </a:effectRef>
+            <a:fontRef idx="minor">
+              <a:schemeClr val="tx1"/>
+            </a:fontRef>
+          </p:style>
+        </p:cxnSp>
+      </p:grpSp>
+      <p:pic>
+        <p:nvPicPr>
+          <p:cNvPr id="29" name="Imagen 28">
+            <a:extLst>
+              <a:ext uri="{FF2B5EF4-FFF2-40B4-BE49-F238E27FC236}">
+                <a16:creationId xmlns:a16="http://schemas.microsoft.com/office/drawing/2014/main" id="{445E5E45-EAC2-9B4B-5CFF-A2392827DFB4}"/>
+              </a:ext>
+            </a:extLst>
+          </p:cNvPr>
+          <p:cNvPicPr>
+            <a:picLocks noChangeAspect="1"/>
+          </p:cNvPicPr>
+          <p:nvPr/>
+        </p:nvPicPr>
+        <p:blipFill>
+          <a:blip r:embed="rId3"/>
+          <a:stretch>
+            <a:fillRect/>
+          </a:stretch>
+        </p:blipFill>
+        <p:spPr>
+          <a:xfrm>
+            <a:off x="0" y="5035593"/>
+            <a:ext cx="7527865" cy="1852537"/>
+          </a:xfrm>
+          <a:prstGeom prst="rect">
+            <a:avLst/>
+          </a:prstGeom>
+        </p:spPr>
+      </p:pic>
     </p:spTree>
     <p:extLst>
       <p:ext uri="{BB962C8B-B14F-4D97-AF65-F5344CB8AC3E}">
@@ -5043,6 +5299,136 @@
 </file>
 
 <file path=ppt/slides/slide12.xml><?xml version="1.0" encoding="utf-8"?>
+<p:sld xmlns:a="http://schemas.openxmlformats.org/drawingml/2006/main" xmlns:r="http://schemas.openxmlformats.org/officeDocument/2006/relationships" xmlns:p="http://schemas.openxmlformats.org/presentationml/2006/main" show="0">
+  <p:cSld>
+    <p:spTree>
+      <p:nvGrpSpPr>
+        <p:cNvPr id="1" name=""/>
+        <p:cNvGrpSpPr/>
+        <p:nvPr/>
+      </p:nvGrpSpPr>
+      <p:grpSpPr>
+        <a:xfrm>
+          <a:off x="0" y="0"/>
+          <a:ext cx="0" cy="0"/>
+          <a:chOff x="0" y="0"/>
+          <a:chExt cx="0" cy="0"/>
+        </a:xfrm>
+      </p:grpSpPr>
+      <p:sp>
+        <p:nvSpPr>
+          <p:cNvPr id="2" name="Título 1">
+            <a:extLst>
+              <a:ext uri="{FF2B5EF4-FFF2-40B4-BE49-F238E27FC236}">
+                <a16:creationId xmlns:a16="http://schemas.microsoft.com/office/drawing/2014/main" id="{EB761AC0-1651-93EA-7F7C-6B3A31630A39}"/>
+              </a:ext>
+            </a:extLst>
+          </p:cNvPr>
+          <p:cNvSpPr>
+            <a:spLocks noGrp="1"/>
+          </p:cNvSpPr>
+          <p:nvPr>
+            <p:ph type="title"/>
+          </p:nvPr>
+        </p:nvSpPr>
+        <p:spPr/>
+        <p:txBody>
+          <a:bodyPr/>
+          <a:lstStyle/>
+          <a:p>
+            <a:endParaRPr lang="en-US"/>
+          </a:p>
+        </p:txBody>
+      </p:sp>
+      <p:sp>
+        <p:nvSpPr>
+          <p:cNvPr id="3" name="Marcador de contenido 2">
+            <a:extLst>
+              <a:ext uri="{FF2B5EF4-FFF2-40B4-BE49-F238E27FC236}">
+                <a16:creationId xmlns:a16="http://schemas.microsoft.com/office/drawing/2014/main" id="{3832B827-5427-06F7-B8D5-33FBBC406CEE}"/>
+              </a:ext>
+            </a:extLst>
+          </p:cNvPr>
+          <p:cNvSpPr>
+            <a:spLocks noGrp="1"/>
+          </p:cNvSpPr>
+          <p:nvPr>
+            <p:ph idx="1"/>
+          </p:nvPr>
+        </p:nvSpPr>
+        <p:spPr/>
+        <p:txBody>
+          <a:bodyPr/>
+          <a:lstStyle/>
+          <a:p>
+            <a:endParaRPr lang="en-US"/>
+          </a:p>
+        </p:txBody>
+      </p:sp>
+      <p:sp>
+        <p:nvSpPr>
+          <p:cNvPr id="5" name="Rombo 4">
+            <a:extLst>
+              <a:ext uri="{FF2B5EF4-FFF2-40B4-BE49-F238E27FC236}">
+                <a16:creationId xmlns:a16="http://schemas.microsoft.com/office/drawing/2014/main" id="{63A91BC5-1800-DA92-ABAD-994707B66D7A}"/>
+              </a:ext>
+            </a:extLst>
+          </p:cNvPr>
+          <p:cNvSpPr/>
+          <p:nvPr/>
+        </p:nvSpPr>
+        <p:spPr>
+          <a:xfrm>
+            <a:off x="7063553" y="2833427"/>
+            <a:ext cx="3735004" cy="1040799"/>
+          </a:xfrm>
+          <a:prstGeom prst="diamond">
+            <a:avLst/>
+          </a:prstGeom>
+          <a:solidFill>
+            <a:srgbClr val="CAD7EE"/>
+          </a:solidFill>
+          <a:ln w="38100"/>
+        </p:spPr>
+        <p:style>
+          <a:lnRef idx="2">
+            <a:schemeClr val="accent1">
+              <a:shade val="15000"/>
+            </a:schemeClr>
+          </a:lnRef>
+          <a:fillRef idx="1">
+            <a:schemeClr val="accent1"/>
+          </a:fillRef>
+          <a:effectRef idx="0">
+            <a:schemeClr val="accent1"/>
+          </a:effectRef>
+          <a:fontRef idx="minor">
+            <a:schemeClr val="lt1"/>
+          </a:fontRef>
+        </p:style>
+        <p:txBody>
+          <a:bodyPr rtlCol="0" anchor="ctr"/>
+          <a:lstStyle/>
+          <a:p>
+            <a:pPr algn="ctr"/>
+            <a:endParaRPr lang="en-US"/>
+          </a:p>
+        </p:txBody>
+      </p:sp>
+    </p:spTree>
+    <p:extLst>
+      <p:ext uri="{BB962C8B-B14F-4D97-AF65-F5344CB8AC3E}">
+        <p14:creationId xmlns:p14="http://schemas.microsoft.com/office/powerpoint/2010/main" val="2649726510"/>
+      </p:ext>
+    </p:extLst>
+  </p:cSld>
+  <p:clrMapOvr>
+    <a:masterClrMapping/>
+  </p:clrMapOvr>
+</p:sld>
+</file>
+
+<file path=ppt/slides/slide13.xml><?xml version="1.0" encoding="utf-8"?>
 <p:sld xmlns:a="http://schemas.openxmlformats.org/drawingml/2006/main" xmlns:r="http://schemas.openxmlformats.org/officeDocument/2006/relationships" xmlns:p="http://schemas.openxmlformats.org/presentationml/2006/main">
   <p:cSld>
     <p:spTree>
@@ -5065,6 +5451,56 @@
           <a:chExt cx="0" cy="0"/>
         </a:xfrm>
       </p:grpSpPr>
+      <p:sp>
+        <p:nvSpPr>
+          <p:cNvPr id="34" name="Rombo 33">
+            <a:extLst>
+              <a:ext uri="{FF2B5EF4-FFF2-40B4-BE49-F238E27FC236}">
+                <a16:creationId xmlns:a16="http://schemas.microsoft.com/office/drawing/2014/main" id="{1CEB91F5-1526-09AD-F295-A35CA365FE04}"/>
+              </a:ext>
+            </a:extLst>
+          </p:cNvPr>
+          <p:cNvSpPr/>
+          <p:nvPr/>
+        </p:nvSpPr>
+        <p:spPr>
+          <a:xfrm>
+            <a:off x="7329259" y="2782565"/>
+            <a:ext cx="3735004" cy="1040799"/>
+          </a:xfrm>
+          <a:prstGeom prst="diamond">
+            <a:avLst/>
+          </a:prstGeom>
+          <a:solidFill>
+            <a:srgbClr val="CAD7EE"/>
+          </a:solidFill>
+          <a:ln w="38100"/>
+        </p:spPr>
+        <p:style>
+          <a:lnRef idx="2">
+            <a:schemeClr val="accent1">
+              <a:shade val="15000"/>
+            </a:schemeClr>
+          </a:lnRef>
+          <a:fillRef idx="1">
+            <a:schemeClr val="accent1"/>
+          </a:fillRef>
+          <a:effectRef idx="0">
+            <a:schemeClr val="accent1"/>
+          </a:effectRef>
+          <a:fontRef idx="minor">
+            <a:schemeClr val="lt1"/>
+          </a:fontRef>
+        </p:style>
+        <p:txBody>
+          <a:bodyPr rtlCol="0" anchor="ctr"/>
+          <a:lstStyle/>
+          <a:p>
+            <a:pPr algn="ctr"/>
+            <a:endParaRPr lang="en-US"/>
+          </a:p>
+        </p:txBody>
+      </p:sp>
       <p:sp>
         <p:nvSpPr>
           <p:cNvPr id="4" name="Forma libre: forma 3">
@@ -5378,9 +5814,9 @@
           </a:stretch>
         </p:blipFill>
         <p:spPr>
-          <a:xfrm>
-            <a:off x="10765173" y="3428999"/>
-            <a:ext cx="1177254" cy="2261919"/>
+          <a:xfrm rot="386393">
+            <a:off x="10756589" y="3581595"/>
+            <a:ext cx="1177254" cy="2108840"/>
           </a:xfrm>
           <a:prstGeom prst="rect">
             <a:avLst/>
@@ -5417,7 +5853,7 @@
           <a:p>
             <a:r>
               <a:rPr lang="en-US" dirty="0"/>
-              <a:t>Ln 5</a:t>
+              <a:t>Ln 6</a:t>
             </a:r>
           </a:p>
         </p:txBody>
@@ -5750,62 +6186,12 @@
         </p:nvGrpSpPr>
         <p:grpSpPr>
           <a:xfrm>
-            <a:off x="6983289" y="2512539"/>
-            <a:ext cx="4662725" cy="1254083"/>
-            <a:chOff x="7661456" y="695741"/>
-            <a:chExt cx="4002164" cy="1254083"/>
+            <a:off x="6880265" y="2512539"/>
+            <a:ext cx="4662725" cy="950548"/>
+            <a:chOff x="7573024" y="695741"/>
+            <a:chExt cx="4002164" cy="950548"/>
           </a:xfrm>
         </p:grpSpPr>
-        <p:sp>
-          <p:nvSpPr>
-            <p:cNvPr id="19" name="Elipse 18">
-              <a:extLst>
-                <a:ext uri="{FF2B5EF4-FFF2-40B4-BE49-F238E27FC236}">
-                  <a16:creationId xmlns:a16="http://schemas.microsoft.com/office/drawing/2014/main" id="{88420749-9489-9DC9-2AC9-45B601981308}"/>
-                </a:ext>
-              </a:extLst>
-            </p:cNvPr>
-            <p:cNvSpPr/>
-            <p:nvPr/>
-          </p:nvSpPr>
-          <p:spPr>
-            <a:xfrm>
-              <a:off x="7661457" y="991441"/>
-              <a:ext cx="3984558" cy="958383"/>
-            </a:xfrm>
-            <a:prstGeom prst="ellipse">
-              <a:avLst/>
-            </a:prstGeom>
-            <a:solidFill>
-              <a:srgbClr val="CAD7EE"/>
-            </a:solidFill>
-            <a:ln w="38100"/>
-          </p:spPr>
-          <p:style>
-            <a:lnRef idx="2">
-              <a:schemeClr val="accent1">
-                <a:shade val="15000"/>
-              </a:schemeClr>
-            </a:lnRef>
-            <a:fillRef idx="1">
-              <a:schemeClr val="accent1"/>
-            </a:fillRef>
-            <a:effectRef idx="0">
-              <a:schemeClr val="accent1"/>
-            </a:effectRef>
-            <a:fontRef idx="minor">
-              <a:schemeClr val="lt1"/>
-            </a:fontRef>
-          </p:style>
-          <p:txBody>
-            <a:bodyPr rtlCol="0" anchor="ctr"/>
-            <a:lstStyle/>
-            <a:p>
-              <a:pPr algn="ctr"/>
-              <a:endParaRPr lang="en-US"/>
-            </a:p>
-          </p:txBody>
-        </p:sp>
         <p:sp>
           <p:nvSpPr>
             <p:cNvPr id="20" name="CuadroTexto 19">
@@ -5820,7 +6206,7 @@
           </p:nvSpPr>
           <p:spPr>
             <a:xfrm>
-              <a:off x="7661456" y="1276957"/>
+              <a:off x="7573024" y="1276957"/>
               <a:ext cx="4002164" cy="369332"/>
             </a:xfrm>
             <a:prstGeom prst="rect">
@@ -7398,7 +7784,7 @@
 </p:sld>
 </file>
 
-<file path=ppt/slides/slide13.xml><?xml version="1.0" encoding="utf-8"?>
+<file path=ppt/slides/slide14.xml><?xml version="1.0" encoding="utf-8"?>
 <p:sld xmlns:a="http://schemas.openxmlformats.org/drawingml/2006/main" xmlns:r="http://schemas.openxmlformats.org/officeDocument/2006/relationships" xmlns:p="http://schemas.openxmlformats.org/presentationml/2006/main" show="0">
   <p:cSld>
     <p:spTree>
@@ -9135,7 +9521,7 @@
 </p:sld>
 </file>
 
-<file path=ppt/slides/slide14.xml><?xml version="1.0" encoding="utf-8"?>
+<file path=ppt/slides/slide15.xml><?xml version="1.0" encoding="utf-8"?>
 <p:sld xmlns:a="http://schemas.openxmlformats.org/drawingml/2006/main" xmlns:r="http://schemas.openxmlformats.org/officeDocument/2006/relationships" xmlns:p="http://schemas.openxmlformats.org/presentationml/2006/main" show="0">
   <p:cSld>
     <p:spTree>
@@ -10616,7 +11002,7 @@
 </p:sld>
 </file>
 
-<file path=ppt/slides/slide15.xml><?xml version="1.0" encoding="utf-8"?>
+<file path=ppt/slides/slide16.xml><?xml version="1.0" encoding="utf-8"?>
 <p:sld xmlns:a="http://schemas.openxmlformats.org/drawingml/2006/main" xmlns:r="http://schemas.openxmlformats.org/officeDocument/2006/relationships" xmlns:p="http://schemas.openxmlformats.org/presentationml/2006/main">
   <p:cSld>
     <p:spTree>
@@ -10666,8 +11052,8 @@
           </a:stretch>
         </p:blipFill>
         <p:spPr>
-          <a:xfrm>
-            <a:off x="10765173" y="3428999"/>
+          <a:xfrm rot="931378">
+            <a:off x="10382542" y="3594603"/>
             <a:ext cx="1177254" cy="2261919"/>
           </a:xfrm>
           <a:prstGeom prst="rect">
@@ -10689,8 +11075,8 @@
         </p:nvSpPr>
         <p:spPr>
           <a:xfrm>
-            <a:off x="7833625" y="5131780"/>
-            <a:ext cx="847164" cy="369332"/>
+            <a:off x="3145547" y="3735558"/>
+            <a:ext cx="674006" cy="369332"/>
           </a:xfrm>
           <a:prstGeom prst="rect">
             <a:avLst/>
@@ -10724,8 +11110,8 @@
         </p:nvSpPr>
         <p:spPr>
           <a:xfrm>
-            <a:off x="7847480" y="5381559"/>
-            <a:ext cx="2743200" cy="958383"/>
+            <a:off x="3606286" y="3803766"/>
+            <a:ext cx="2182496" cy="762490"/>
           </a:xfrm>
           <a:prstGeom prst="ellipse">
             <a:avLst/>
@@ -10774,8 +11160,8 @@
         </p:nvSpPr>
         <p:spPr>
           <a:xfrm>
-            <a:off x="8300251" y="5696331"/>
-            <a:ext cx="1932803" cy="369332"/>
+            <a:off x="3809573" y="4012258"/>
+            <a:ext cx="1841513" cy="369332"/>
           </a:xfrm>
           <a:prstGeom prst="rect">
             <a:avLst/>
@@ -10794,7 +11180,7 @@
             </a:r>
             <a:r>
               <a:rPr lang="en-US" dirty="0" err="1"/>
-              <a:t>full_names</a:t>
+              <a:t>full_name</a:t>
             </a:r>
             <a:r>
               <a:rPr lang="en-US" dirty="0"/>
@@ -10817,10 +11203,10 @@
         </p:nvGrpSpPr>
         <p:grpSpPr>
           <a:xfrm>
-            <a:off x="6996279" y="38921"/>
-            <a:ext cx="5298410" cy="1254083"/>
-            <a:chOff x="7661457" y="695741"/>
-            <a:chExt cx="4543293" cy="1254083"/>
+            <a:off x="7026314" y="218233"/>
+            <a:ext cx="4773677" cy="983342"/>
+            <a:chOff x="7687212" y="875053"/>
+            <a:chExt cx="4093344" cy="983342"/>
           </a:xfrm>
         </p:grpSpPr>
         <p:sp>
@@ -10837,8 +11223,8 @@
           </p:nvSpPr>
           <p:spPr>
             <a:xfrm>
-              <a:off x="7661457" y="991441"/>
-              <a:ext cx="3984558" cy="958383"/>
+              <a:off x="8041583" y="1082871"/>
+              <a:ext cx="3224308" cy="775524"/>
             </a:xfrm>
             <a:prstGeom prst="ellipse">
               <a:avLst/>
@@ -10887,8 +11273,8 @@
           </p:nvSpPr>
           <p:spPr>
             <a:xfrm>
-              <a:off x="7758234" y="1276957"/>
-              <a:ext cx="4446516" cy="369332"/>
+              <a:off x="8182431" y="1312191"/>
+              <a:ext cx="3598125" cy="307777"/>
             </a:xfrm>
             <a:prstGeom prst="rect">
               <a:avLst/>
@@ -10902,35 +11288,35 @@
             <a:lstStyle/>
             <a:p>
               <a:r>
-                <a:rPr lang="en-US" dirty="0"/>
+                <a:rPr lang="en-US" sz="1400" dirty="0"/>
                 <a:t>names = [“Lionel </a:t>
               </a:r>
               <a:r>
-                <a:rPr lang="es-AR" dirty="0"/>
+                <a:rPr lang="es-AR" sz="1400" dirty="0"/>
                 <a:t>”</a:t>
               </a:r>
               <a:r>
-                <a:rPr lang="en-US" dirty="0"/>
+                <a:rPr lang="en-US" sz="1400" dirty="0"/>
                 <a:t>, “Juli</a:t>
               </a:r>
               <a:r>
-                <a:rPr lang="es-AR" dirty="0" err="1"/>
+                <a:rPr lang="es-AR" sz="1400" dirty="0" err="1"/>
                 <a:t>án</a:t>
               </a:r>
               <a:r>
-                <a:rPr lang="es-AR" dirty="0"/>
+                <a:rPr lang="es-AR" sz="1400" dirty="0"/>
                 <a:t> ”, “Ángel ”, “</a:t>
               </a:r>
               <a:r>
-                <a:rPr lang="es-AR" dirty="0" err="1"/>
+                <a:rPr lang="es-AR" sz="1400" dirty="0" err="1"/>
                 <a:t>Dibu</a:t>
               </a:r>
               <a:r>
-                <a:rPr lang="es-AR" dirty="0"/>
+                <a:rPr lang="es-AR" sz="1400" dirty="0"/>
                 <a:t> “</a:t>
               </a:r>
               <a:r>
-                <a:rPr lang="en-US" dirty="0"/>
+                <a:rPr lang="en-US" sz="1400" dirty="0"/>
                 <a:t>]</a:t>
               </a:r>
             </a:p>
@@ -10950,7 +11336,7 @@
           </p:nvSpPr>
           <p:spPr>
             <a:xfrm>
-              <a:off x="7896781" y="695741"/>
+              <a:off x="7687212" y="875053"/>
               <a:ext cx="847164" cy="369332"/>
             </a:xfrm>
             <a:prstGeom prst="rect">
@@ -10972,6 +11358,1349 @@
           </p:txBody>
         </p:sp>
       </p:grpSp>
+      <p:sp>
+        <p:nvSpPr>
+          <p:cNvPr id="14" name="CuadroTexto 13">
+            <a:extLst>
+              <a:ext uri="{FF2B5EF4-FFF2-40B4-BE49-F238E27FC236}">
+                <a16:creationId xmlns:a16="http://schemas.microsoft.com/office/drawing/2014/main" id="{04AE7A53-B1E0-4563-9349-021659839603}"/>
+              </a:ext>
+            </a:extLst>
+          </p:cNvPr>
+          <p:cNvSpPr txBox="1"/>
+          <p:nvPr/>
+        </p:nvSpPr>
+        <p:spPr>
+          <a:xfrm>
+            <a:off x="6983290" y="4105348"/>
+            <a:ext cx="361682" cy="769441"/>
+          </a:xfrm>
+          <a:prstGeom prst="rect">
+            <a:avLst/>
+          </a:prstGeom>
+          <a:noFill/>
+        </p:spPr>
+        <p:txBody>
+          <a:bodyPr wrap="square" rtlCol="0">
+            <a:spAutoFit/>
+          </a:bodyPr>
+          <a:lstStyle/>
+          <a:p>
+            <a:r>
+              <a:rPr lang="en-US" sz="4400" b="1" dirty="0">
+                <a:solidFill>
+                  <a:srgbClr val="00B050"/>
+                </a:solidFill>
+              </a:rPr>
+              <a:t>T</a:t>
+            </a:r>
+          </a:p>
+        </p:txBody>
+      </p:sp>
+      <p:sp>
+        <p:nvSpPr>
+          <p:cNvPr id="15" name="CuadroTexto 14">
+            <a:extLst>
+              <a:ext uri="{FF2B5EF4-FFF2-40B4-BE49-F238E27FC236}">
+                <a16:creationId xmlns:a16="http://schemas.microsoft.com/office/drawing/2014/main" id="{1BB2F5FF-F9E4-6F50-01E1-9D59F374D97D}"/>
+              </a:ext>
+            </a:extLst>
+          </p:cNvPr>
+          <p:cNvSpPr txBox="1"/>
+          <p:nvPr/>
+        </p:nvSpPr>
+        <p:spPr>
+          <a:xfrm>
+            <a:off x="10800715" y="3812203"/>
+            <a:ext cx="583841" cy="769441"/>
+          </a:xfrm>
+          <a:prstGeom prst="rect">
+            <a:avLst/>
+          </a:prstGeom>
+          <a:noFill/>
+        </p:spPr>
+        <p:txBody>
+          <a:bodyPr wrap="square" rtlCol="0">
+            <a:spAutoFit/>
+          </a:bodyPr>
+          <a:lstStyle/>
+          <a:p>
+            <a:r>
+              <a:rPr lang="en-US" sz="4400" b="1" dirty="0">
+                <a:solidFill>
+                  <a:srgbClr val="FF0000"/>
+                </a:solidFill>
+              </a:rPr>
+              <a:t>F</a:t>
+            </a:r>
+          </a:p>
+        </p:txBody>
+      </p:sp>
+      <p:grpSp>
+        <p:nvGrpSpPr>
+          <p:cNvPr id="18" name="Grupo 17">
+            <a:extLst>
+              <a:ext uri="{FF2B5EF4-FFF2-40B4-BE49-F238E27FC236}">
+                <a16:creationId xmlns:a16="http://schemas.microsoft.com/office/drawing/2014/main" id="{03961BC6-C033-D500-B2D4-35182B5AEC5A}"/>
+              </a:ext>
+            </a:extLst>
+          </p:cNvPr>
+          <p:cNvGrpSpPr/>
+          <p:nvPr/>
+        </p:nvGrpSpPr>
+        <p:grpSpPr>
+          <a:xfrm>
+            <a:off x="7041849" y="1532758"/>
+            <a:ext cx="4078219" cy="835513"/>
+            <a:chOff x="7711461" y="-528648"/>
+            <a:chExt cx="3500463" cy="835513"/>
+          </a:xfrm>
+        </p:grpSpPr>
+        <p:sp>
+          <p:nvSpPr>
+            <p:cNvPr id="19" name="Elipse 18">
+              <a:extLst>
+                <a:ext uri="{FF2B5EF4-FFF2-40B4-BE49-F238E27FC236}">
+                  <a16:creationId xmlns:a16="http://schemas.microsoft.com/office/drawing/2014/main" id="{EBF9D2C2-E97F-BFF3-42B7-76CD45078678}"/>
+                </a:ext>
+              </a:extLst>
+            </p:cNvPr>
+            <p:cNvSpPr/>
+            <p:nvPr/>
+          </p:nvSpPr>
+          <p:spPr>
+            <a:xfrm>
+              <a:off x="8087214" y="-432975"/>
+              <a:ext cx="3075948" cy="739840"/>
+            </a:xfrm>
+            <a:prstGeom prst="ellipse">
+              <a:avLst/>
+            </a:prstGeom>
+            <a:solidFill>
+              <a:srgbClr val="CAD7EE"/>
+            </a:solidFill>
+            <a:ln w="38100"/>
+          </p:spPr>
+          <p:style>
+            <a:lnRef idx="2">
+              <a:schemeClr val="accent1">
+                <a:shade val="15000"/>
+              </a:schemeClr>
+            </a:lnRef>
+            <a:fillRef idx="1">
+              <a:schemeClr val="accent1"/>
+            </a:fillRef>
+            <a:effectRef idx="0">
+              <a:schemeClr val="accent1"/>
+            </a:effectRef>
+            <a:fontRef idx="minor">
+              <a:schemeClr val="lt1"/>
+            </a:fontRef>
+          </p:style>
+          <p:txBody>
+            <a:bodyPr rtlCol="0" anchor="ctr"/>
+            <a:lstStyle/>
+            <a:p>
+              <a:pPr algn="ctr"/>
+              <a:endParaRPr lang="en-US"/>
+            </a:p>
+          </p:txBody>
+        </p:sp>
+        <p:sp>
+          <p:nvSpPr>
+            <p:cNvPr id="20" name="CuadroTexto 19">
+              <a:extLst>
+                <a:ext uri="{FF2B5EF4-FFF2-40B4-BE49-F238E27FC236}">
+                  <a16:creationId xmlns:a16="http://schemas.microsoft.com/office/drawing/2014/main" id="{F10A66E0-DD23-9607-DA70-45B4BF424C21}"/>
+                </a:ext>
+              </a:extLst>
+            </p:cNvPr>
+            <p:cNvSpPr txBox="1"/>
+            <p:nvPr/>
+          </p:nvSpPr>
+          <p:spPr>
+            <a:xfrm>
+              <a:off x="8122386" y="-214621"/>
+              <a:ext cx="3089538" cy="307777"/>
+            </a:xfrm>
+            <a:prstGeom prst="rect">
+              <a:avLst/>
+            </a:prstGeom>
+            <a:noFill/>
+          </p:spPr>
+          <p:txBody>
+            <a:bodyPr wrap="square" rtlCol="0">
+              <a:spAutoFit/>
+            </a:bodyPr>
+            <a:lstStyle/>
+            <a:p>
+              <a:r>
+                <a:rPr lang="en-US" sz="1400" dirty="0"/>
+                <a:t>surnames = [“Messi”, “Juli</a:t>
+              </a:r>
+              <a:r>
+                <a:rPr lang="es-AR" sz="1400" dirty="0" err="1"/>
+                <a:t>án</a:t>
+              </a:r>
+              <a:r>
+                <a:rPr lang="es-AR" sz="1400" dirty="0"/>
+                <a:t>”, “Ángel”, “</a:t>
+              </a:r>
+              <a:r>
+                <a:rPr lang="es-AR" sz="1400" dirty="0" err="1"/>
+                <a:t>Dibu</a:t>
+              </a:r>
+              <a:r>
+                <a:rPr lang="es-AR" sz="1400" dirty="0"/>
+                <a:t>”</a:t>
+              </a:r>
+              <a:r>
+                <a:rPr lang="en-US" sz="1400" dirty="0"/>
+                <a:t>]</a:t>
+              </a:r>
+            </a:p>
+          </p:txBody>
+        </p:sp>
+        <p:sp>
+          <p:nvSpPr>
+            <p:cNvPr id="21" name="CuadroTexto 20">
+              <a:extLst>
+                <a:ext uri="{FF2B5EF4-FFF2-40B4-BE49-F238E27FC236}">
+                  <a16:creationId xmlns:a16="http://schemas.microsoft.com/office/drawing/2014/main" id="{B43E2AD1-9584-53E5-A629-AF377D70E7B3}"/>
+                </a:ext>
+              </a:extLst>
+            </p:cNvPr>
+            <p:cNvSpPr txBox="1"/>
+            <p:nvPr/>
+          </p:nvSpPr>
+          <p:spPr>
+            <a:xfrm>
+              <a:off x="7711461" y="-528648"/>
+              <a:ext cx="653983" cy="369332"/>
+            </a:xfrm>
+            <a:prstGeom prst="rect">
+              <a:avLst/>
+            </a:prstGeom>
+            <a:noFill/>
+          </p:spPr>
+          <p:txBody>
+            <a:bodyPr wrap="square" rtlCol="0">
+              <a:spAutoFit/>
+            </a:bodyPr>
+            <a:lstStyle/>
+            <a:p>
+              <a:r>
+                <a:rPr lang="en-US" dirty="0"/>
+                <a:t>Ln 2</a:t>
+              </a:r>
+            </a:p>
+          </p:txBody>
+        </p:sp>
+      </p:grpSp>
+      <p:sp>
+        <p:nvSpPr>
+          <p:cNvPr id="16" name="Forma libre: forma 15">
+            <a:extLst>
+              <a:ext uri="{FF2B5EF4-FFF2-40B4-BE49-F238E27FC236}">
+                <a16:creationId xmlns:a16="http://schemas.microsoft.com/office/drawing/2014/main" id="{38E607E6-0C76-6F3A-7B42-BC8CF9661986}"/>
+              </a:ext>
+            </a:extLst>
+          </p:cNvPr>
+          <p:cNvSpPr/>
+          <p:nvPr/>
+        </p:nvSpPr>
+        <p:spPr>
+          <a:xfrm>
+            <a:off x="150980" y="1179031"/>
+            <a:ext cx="404454" cy="1170609"/>
+          </a:xfrm>
+          <a:custGeom>
+            <a:avLst/>
+            <a:gdLst>
+              <a:gd name="connsiteX0" fmla="*/ 1268696 w 1907325"/>
+              <a:gd name="connsiteY0" fmla="*/ 0 h 4513942"/>
+              <a:gd name="connsiteX1" fmla="*/ 1544467 w 1907325"/>
+              <a:gd name="connsiteY1" fmla="*/ 348342 h 4513942"/>
+              <a:gd name="connsiteX2" fmla="*/ 1762181 w 1907325"/>
+              <a:gd name="connsiteY2" fmla="*/ 914400 h 4513942"/>
+              <a:gd name="connsiteX3" fmla="*/ 1776696 w 1907325"/>
+              <a:gd name="connsiteY3" fmla="*/ 1524000 h 4513942"/>
+              <a:gd name="connsiteX4" fmla="*/ 1500924 w 1907325"/>
+              <a:gd name="connsiteY4" fmla="*/ 2206171 h 4513942"/>
+              <a:gd name="connsiteX5" fmla="*/ 1297724 w 1907325"/>
+              <a:gd name="connsiteY5" fmla="*/ 2496457 h 4513942"/>
+              <a:gd name="connsiteX6" fmla="*/ 572010 w 1907325"/>
+              <a:gd name="connsiteY6" fmla="*/ 2772228 h 4513942"/>
+              <a:gd name="connsiteX7" fmla="*/ 281724 w 1907325"/>
+              <a:gd name="connsiteY7" fmla="*/ 2714171 h 4513942"/>
+              <a:gd name="connsiteX8" fmla="*/ 5953 w 1907325"/>
+              <a:gd name="connsiteY8" fmla="*/ 2119085 h 4513942"/>
+              <a:gd name="connsiteX9" fmla="*/ 20467 w 1907325"/>
+              <a:gd name="connsiteY9" fmla="*/ 1640114 h 4513942"/>
+              <a:gd name="connsiteX10" fmla="*/ 194638 w 1907325"/>
+              <a:gd name="connsiteY10" fmla="*/ 1364342 h 4513942"/>
+              <a:gd name="connsiteX11" fmla="*/ 891324 w 1907325"/>
+              <a:gd name="connsiteY11" fmla="*/ 1088571 h 4513942"/>
+              <a:gd name="connsiteX12" fmla="*/ 1181610 w 1907325"/>
+              <a:gd name="connsiteY12" fmla="*/ 1059542 h 4513942"/>
+              <a:gd name="connsiteX13" fmla="*/ 1370296 w 1907325"/>
+              <a:gd name="connsiteY13" fmla="*/ 1103085 h 4513942"/>
+              <a:gd name="connsiteX14" fmla="*/ 1646067 w 1907325"/>
+              <a:gd name="connsiteY14" fmla="*/ 1320800 h 4513942"/>
+              <a:gd name="connsiteX15" fmla="*/ 1747667 w 1907325"/>
+              <a:gd name="connsiteY15" fmla="*/ 1640114 h 4513942"/>
+              <a:gd name="connsiteX16" fmla="*/ 1892810 w 1907325"/>
+              <a:gd name="connsiteY16" fmla="*/ 2249714 h 4513942"/>
+              <a:gd name="connsiteX17" fmla="*/ 1805724 w 1907325"/>
+              <a:gd name="connsiteY17" fmla="*/ 3135085 h 4513942"/>
+              <a:gd name="connsiteX18" fmla="*/ 1660581 w 1907325"/>
+              <a:gd name="connsiteY18" fmla="*/ 3614057 h 4513942"/>
+              <a:gd name="connsiteX19" fmla="*/ 1399324 w 1907325"/>
+              <a:gd name="connsiteY19" fmla="*/ 3947885 h 4513942"/>
+              <a:gd name="connsiteX20" fmla="*/ 1283210 w 1907325"/>
+              <a:gd name="connsiteY20" fmla="*/ 4122057 h 4513942"/>
+              <a:gd name="connsiteX21" fmla="*/ 1196124 w 1907325"/>
+              <a:gd name="connsiteY21" fmla="*/ 4397828 h 4513942"/>
+              <a:gd name="connsiteX22" fmla="*/ 1152581 w 1907325"/>
+              <a:gd name="connsiteY22" fmla="*/ 4513942 h 4513942"/>
+            </a:gdLst>
+            <a:ahLst/>
+            <a:cxnLst>
+              <a:cxn ang="0">
+                <a:pos x="connsiteX0" y="connsiteY0"/>
+              </a:cxn>
+              <a:cxn ang="0">
+                <a:pos x="connsiteX1" y="connsiteY1"/>
+              </a:cxn>
+              <a:cxn ang="0">
+                <a:pos x="connsiteX2" y="connsiteY2"/>
+              </a:cxn>
+              <a:cxn ang="0">
+                <a:pos x="connsiteX3" y="connsiteY3"/>
+              </a:cxn>
+              <a:cxn ang="0">
+                <a:pos x="connsiteX4" y="connsiteY4"/>
+              </a:cxn>
+              <a:cxn ang="0">
+                <a:pos x="connsiteX5" y="connsiteY5"/>
+              </a:cxn>
+              <a:cxn ang="0">
+                <a:pos x="connsiteX6" y="connsiteY6"/>
+              </a:cxn>
+              <a:cxn ang="0">
+                <a:pos x="connsiteX7" y="connsiteY7"/>
+              </a:cxn>
+              <a:cxn ang="0">
+                <a:pos x="connsiteX8" y="connsiteY8"/>
+              </a:cxn>
+              <a:cxn ang="0">
+                <a:pos x="connsiteX9" y="connsiteY9"/>
+              </a:cxn>
+              <a:cxn ang="0">
+                <a:pos x="connsiteX10" y="connsiteY10"/>
+              </a:cxn>
+              <a:cxn ang="0">
+                <a:pos x="connsiteX11" y="connsiteY11"/>
+              </a:cxn>
+              <a:cxn ang="0">
+                <a:pos x="connsiteX12" y="connsiteY12"/>
+              </a:cxn>
+              <a:cxn ang="0">
+                <a:pos x="connsiteX13" y="connsiteY13"/>
+              </a:cxn>
+              <a:cxn ang="0">
+                <a:pos x="connsiteX14" y="connsiteY14"/>
+              </a:cxn>
+              <a:cxn ang="0">
+                <a:pos x="connsiteX15" y="connsiteY15"/>
+              </a:cxn>
+              <a:cxn ang="0">
+                <a:pos x="connsiteX16" y="connsiteY16"/>
+              </a:cxn>
+              <a:cxn ang="0">
+                <a:pos x="connsiteX17" y="connsiteY17"/>
+              </a:cxn>
+              <a:cxn ang="0">
+                <a:pos x="connsiteX18" y="connsiteY18"/>
+              </a:cxn>
+              <a:cxn ang="0">
+                <a:pos x="connsiteX19" y="connsiteY19"/>
+              </a:cxn>
+              <a:cxn ang="0">
+                <a:pos x="connsiteX20" y="connsiteY20"/>
+              </a:cxn>
+              <a:cxn ang="0">
+                <a:pos x="connsiteX21" y="connsiteY21"/>
+              </a:cxn>
+              <a:cxn ang="0">
+                <a:pos x="connsiteX22" y="connsiteY22"/>
+              </a:cxn>
+            </a:cxnLst>
+            <a:rect l="l" t="t" r="r" b="b"/>
+            <a:pathLst>
+              <a:path w="1907325" h="4513942">
+                <a:moveTo>
+                  <a:pt x="1268696" y="0"/>
+                </a:moveTo>
+                <a:cubicBezTo>
+                  <a:pt x="1442773" y="124340"/>
+                  <a:pt x="1389854" y="67227"/>
+                  <a:pt x="1544467" y="348342"/>
+                </a:cubicBezTo>
+                <a:cubicBezTo>
+                  <a:pt x="1699367" y="629979"/>
+                  <a:pt x="1682866" y="628863"/>
+                  <a:pt x="1762181" y="914400"/>
+                </a:cubicBezTo>
+                <a:cubicBezTo>
+                  <a:pt x="1776471" y="1078734"/>
+                  <a:pt x="1815799" y="1351947"/>
+                  <a:pt x="1776696" y="1524000"/>
+                </a:cubicBezTo>
+                <a:cubicBezTo>
+                  <a:pt x="1747705" y="1651561"/>
+                  <a:pt x="1570804" y="2083882"/>
+                  <a:pt x="1500924" y="2206171"/>
+                </a:cubicBezTo>
+                <a:cubicBezTo>
+                  <a:pt x="1442324" y="2308722"/>
+                  <a:pt x="1384895" y="2416758"/>
+                  <a:pt x="1297724" y="2496457"/>
+                </a:cubicBezTo>
+                <a:cubicBezTo>
+                  <a:pt x="1086760" y="2689339"/>
+                  <a:pt x="836364" y="2708418"/>
+                  <a:pt x="572010" y="2772228"/>
+                </a:cubicBezTo>
+                <a:cubicBezTo>
+                  <a:pt x="475248" y="2752876"/>
+                  <a:pt x="368793" y="2760608"/>
+                  <a:pt x="281724" y="2714171"/>
+                </a:cubicBezTo>
+                <a:cubicBezTo>
+                  <a:pt x="101836" y="2618231"/>
+                  <a:pt x="43703" y="2240724"/>
+                  <a:pt x="5953" y="2119085"/>
+                </a:cubicBezTo>
+                <a:cubicBezTo>
+                  <a:pt x="10791" y="1959428"/>
+                  <a:pt x="-18273" y="1795075"/>
+                  <a:pt x="20467" y="1640114"/>
+                </a:cubicBezTo>
+                <a:cubicBezTo>
+                  <a:pt x="46836" y="1534637"/>
+                  <a:pt x="119120" y="1442557"/>
+                  <a:pt x="194638" y="1364342"/>
+                </a:cubicBezTo>
+                <a:cubicBezTo>
+                  <a:pt x="353037" y="1200286"/>
+                  <a:pt x="709339" y="1127068"/>
+                  <a:pt x="891324" y="1088571"/>
+                </a:cubicBezTo>
+                <a:cubicBezTo>
+                  <a:pt x="986463" y="1068445"/>
+                  <a:pt x="1084848" y="1069218"/>
+                  <a:pt x="1181610" y="1059542"/>
+                </a:cubicBezTo>
+                <a:cubicBezTo>
+                  <a:pt x="1244505" y="1074056"/>
+                  <a:pt x="1310554" y="1078645"/>
+                  <a:pt x="1370296" y="1103085"/>
+                </a:cubicBezTo>
+                <a:cubicBezTo>
+                  <a:pt x="1458125" y="1139015"/>
+                  <a:pt x="1582620" y="1263698"/>
+                  <a:pt x="1646067" y="1320800"/>
+                </a:cubicBezTo>
+                <a:cubicBezTo>
+                  <a:pt x="1679934" y="1427238"/>
+                  <a:pt x="1718992" y="1532161"/>
+                  <a:pt x="1747667" y="1640114"/>
+                </a:cubicBezTo>
+                <a:cubicBezTo>
+                  <a:pt x="1801291" y="1841994"/>
+                  <a:pt x="1892810" y="2249714"/>
+                  <a:pt x="1892810" y="2249714"/>
+                </a:cubicBezTo>
+                <a:cubicBezTo>
+                  <a:pt x="1912101" y="2693420"/>
+                  <a:pt x="1933113" y="2603050"/>
+                  <a:pt x="1805724" y="3135085"/>
+                </a:cubicBezTo>
+                <a:cubicBezTo>
+                  <a:pt x="1766878" y="3297326"/>
+                  <a:pt x="1735188" y="3464843"/>
+                  <a:pt x="1660581" y="3614057"/>
+                </a:cubicBezTo>
+                <a:cubicBezTo>
+                  <a:pt x="1597389" y="3740441"/>
+                  <a:pt x="1483586" y="3834456"/>
+                  <a:pt x="1399324" y="3947885"/>
+                </a:cubicBezTo>
+                <a:cubicBezTo>
+                  <a:pt x="1357715" y="4003897"/>
+                  <a:pt x="1321915" y="4064000"/>
+                  <a:pt x="1283210" y="4122057"/>
+                </a:cubicBezTo>
+                <a:cubicBezTo>
+                  <a:pt x="1254181" y="4213981"/>
+                  <a:pt x="1226608" y="4306377"/>
+                  <a:pt x="1196124" y="4397828"/>
+                </a:cubicBezTo>
+                <a:cubicBezTo>
+                  <a:pt x="1183052" y="4437043"/>
+                  <a:pt x="1152581" y="4513942"/>
+                  <a:pt x="1152581" y="4513942"/>
+                </a:cubicBezTo>
+              </a:path>
+            </a:pathLst>
+          </a:custGeom>
+          <a:noFill/>
+          <a:ln w="57150"/>
+        </p:spPr>
+        <p:style>
+          <a:lnRef idx="2">
+            <a:schemeClr val="accent1">
+              <a:shade val="15000"/>
+            </a:schemeClr>
+          </a:lnRef>
+          <a:fillRef idx="1">
+            <a:schemeClr val="accent1"/>
+          </a:fillRef>
+          <a:effectRef idx="0">
+            <a:schemeClr val="accent1"/>
+          </a:effectRef>
+          <a:fontRef idx="minor">
+            <a:schemeClr val="lt1"/>
+          </a:fontRef>
+        </p:style>
+        <p:txBody>
+          <a:bodyPr rtlCol="0" anchor="ctr"/>
+          <a:lstStyle/>
+          <a:p>
+            <a:pPr algn="ctr"/>
+            <a:endParaRPr lang="en-US"/>
+          </a:p>
+        </p:txBody>
+      </p:sp>
+      <p:sp>
+        <p:nvSpPr>
+          <p:cNvPr id="24" name="Título 1">
+            <a:extLst>
+              <a:ext uri="{FF2B5EF4-FFF2-40B4-BE49-F238E27FC236}">
+                <a16:creationId xmlns:a16="http://schemas.microsoft.com/office/drawing/2014/main" id="{33C17B9E-9B9F-F39B-4C2D-6356E6F19C1A}"/>
+              </a:ext>
+            </a:extLst>
+          </p:cNvPr>
+          <p:cNvSpPr txBox="1">
+            <a:spLocks/>
+          </p:cNvSpPr>
+          <p:nvPr/>
+        </p:nvSpPr>
+        <p:spPr>
+          <a:xfrm>
+            <a:off x="129860" y="-53975"/>
+            <a:ext cx="6853430" cy="1174941"/>
+          </a:xfrm>
+          <a:prstGeom prst="rect">
+            <a:avLst/>
+          </a:prstGeom>
+        </p:spPr>
+        <p:txBody>
+          <a:bodyPr vert="horz" lIns="91440" tIns="45720" rIns="91440" bIns="45720" rtlCol="0" anchor="ctr">
+            <a:normAutofit/>
+          </a:bodyPr>
+          <a:lstStyle>
+            <a:lvl1pPr algn="l" defTabSz="914400" rtl="0" eaLnBrk="1" latinLnBrk="0" hangingPunct="1">
+              <a:lnSpc>
+                <a:spcPct val="90000"/>
+              </a:lnSpc>
+              <a:spcBef>
+                <a:spcPct val="0"/>
+              </a:spcBef>
+              <a:buNone/>
+              <a:defRPr sz="4400" kern="1200">
+                <a:solidFill>
+                  <a:schemeClr val="tx1"/>
+                </a:solidFill>
+                <a:latin typeface="+mj-lt"/>
+                <a:ea typeface="+mj-ea"/>
+                <a:cs typeface="+mj-cs"/>
+              </a:defRPr>
+            </a:lvl1pPr>
+          </a:lstStyle>
+          <a:p>
+            <a:r>
+              <a:rPr lang="es-AR" sz="2800" b="1" dirty="0" err="1">
+                <a:latin typeface="Consolas" panose="020B0609020204030204" pitchFamily="49" charset="0"/>
+                <a:cs typeface="Cascadia Code SemiBold" panose="020B0609020000020004" pitchFamily="49" charset="0"/>
+              </a:rPr>
+              <a:t>For</a:t>
+            </a:r>
+            <a:r>
+              <a:rPr lang="es-AR" sz="2800" b="1" dirty="0">
+                <a:latin typeface="Consolas" panose="020B0609020204030204" pitchFamily="49" charset="0"/>
+                <a:cs typeface="Cascadia Code SemiBold" panose="020B0609020000020004" pitchFamily="49" charset="0"/>
+              </a:rPr>
+              <a:t> ____ in </a:t>
+            </a:r>
+            <a:r>
+              <a:rPr lang="es-AR" sz="2800" b="1" dirty="0" err="1">
+                <a:latin typeface="Consolas" panose="020B0609020204030204" pitchFamily="49" charset="0"/>
+                <a:cs typeface="Cascadia Code SemiBold" panose="020B0609020000020004" pitchFamily="49" charset="0"/>
+              </a:rPr>
+              <a:t>range</a:t>
+            </a:r>
+            <a:r>
+              <a:rPr lang="es-AR" sz="2800" b="1" dirty="0">
+                <a:latin typeface="Consolas" panose="020B0609020204030204" pitchFamily="49" charset="0"/>
+                <a:cs typeface="Cascadia Code SemiBold" panose="020B0609020000020004" pitchFamily="49" charset="0"/>
+              </a:rPr>
+              <a:t>(a, b, c)</a:t>
+            </a:r>
+            <a:br>
+              <a:rPr lang="es-AR" sz="3600" dirty="0"/>
+            </a:br>
+            <a:r>
+              <a:rPr lang="es-AR" sz="2800" i="1" dirty="0">
+                <a:solidFill>
+                  <a:schemeClr val="bg2">
+                    <a:lumMod val="50000"/>
+                  </a:schemeClr>
+                </a:solidFill>
+              </a:rPr>
+              <a:t>(</a:t>
+            </a:r>
+            <a:r>
+              <a:rPr lang="es-AR" sz="2800" i="1" dirty="0" err="1">
+                <a:solidFill>
+                  <a:schemeClr val="bg2">
+                    <a:lumMod val="50000"/>
+                  </a:schemeClr>
+                </a:solidFill>
+              </a:rPr>
+              <a:t>loop</a:t>
+            </a:r>
+            <a:r>
+              <a:rPr lang="es-AR" sz="2800" i="1" dirty="0">
+                <a:solidFill>
+                  <a:schemeClr val="bg2">
+                    <a:lumMod val="50000"/>
+                  </a:schemeClr>
+                </a:solidFill>
+              </a:rPr>
+              <a:t>)</a:t>
+            </a:r>
+            <a:r>
+              <a:rPr lang="es-AR" sz="2800" dirty="0"/>
+              <a:t> </a:t>
+            </a:r>
+            <a:endParaRPr lang="en-US" sz="3600" dirty="0"/>
+          </a:p>
+        </p:txBody>
+      </p:sp>
+      <p:pic>
+        <p:nvPicPr>
+          <p:cNvPr id="22" name="Imagen 21">
+            <a:extLst>
+              <a:ext uri="{FF2B5EF4-FFF2-40B4-BE49-F238E27FC236}">
+                <a16:creationId xmlns:a16="http://schemas.microsoft.com/office/drawing/2014/main" id="{7054C6D3-14D5-8B2E-A726-FDDAF51888CF}"/>
+              </a:ext>
+            </a:extLst>
+          </p:cNvPr>
+          <p:cNvPicPr>
+            <a:picLocks noChangeAspect="1"/>
+          </p:cNvPicPr>
+          <p:nvPr/>
+        </p:nvPicPr>
+        <p:blipFill>
+          <a:blip r:embed="rId3"/>
+          <a:stretch>
+            <a:fillRect/>
+          </a:stretch>
+        </p:blipFill>
+        <p:spPr>
+          <a:xfrm>
+            <a:off x="-12354" y="4955580"/>
+            <a:ext cx="7488353" cy="1906544"/>
+          </a:xfrm>
+          <a:prstGeom prst="rect">
+            <a:avLst/>
+          </a:prstGeom>
+        </p:spPr>
+      </p:pic>
+      <p:grpSp>
+        <p:nvGrpSpPr>
+          <p:cNvPr id="23" name="Grupo 22">
+            <a:extLst>
+              <a:ext uri="{FF2B5EF4-FFF2-40B4-BE49-F238E27FC236}">
+                <a16:creationId xmlns:a16="http://schemas.microsoft.com/office/drawing/2014/main" id="{AAFF3476-566A-EA25-E66C-20C0D4A8493C}"/>
+              </a:ext>
+            </a:extLst>
+          </p:cNvPr>
+          <p:cNvGrpSpPr/>
+          <p:nvPr/>
+        </p:nvGrpSpPr>
+        <p:grpSpPr>
+          <a:xfrm>
+            <a:off x="7121568" y="2563490"/>
+            <a:ext cx="4021409" cy="835513"/>
+            <a:chOff x="7711461" y="-528648"/>
+            <a:chExt cx="3451701" cy="835513"/>
+          </a:xfrm>
+        </p:grpSpPr>
+        <p:sp>
+          <p:nvSpPr>
+            <p:cNvPr id="25" name="Elipse 24">
+              <a:extLst>
+                <a:ext uri="{FF2B5EF4-FFF2-40B4-BE49-F238E27FC236}">
+                  <a16:creationId xmlns:a16="http://schemas.microsoft.com/office/drawing/2014/main" id="{8DB4925A-F673-F7C2-F61E-8F57A17E0760}"/>
+                </a:ext>
+              </a:extLst>
+            </p:cNvPr>
+            <p:cNvSpPr/>
+            <p:nvPr/>
+          </p:nvSpPr>
+          <p:spPr>
+            <a:xfrm>
+              <a:off x="8087214" y="-432975"/>
+              <a:ext cx="3075948" cy="739840"/>
+            </a:xfrm>
+            <a:prstGeom prst="ellipse">
+              <a:avLst/>
+            </a:prstGeom>
+            <a:solidFill>
+              <a:srgbClr val="CAD7EE"/>
+            </a:solidFill>
+            <a:ln w="38100"/>
+          </p:spPr>
+          <p:style>
+            <a:lnRef idx="2">
+              <a:schemeClr val="accent1">
+                <a:shade val="15000"/>
+              </a:schemeClr>
+            </a:lnRef>
+            <a:fillRef idx="1">
+              <a:schemeClr val="accent1"/>
+            </a:fillRef>
+            <a:effectRef idx="0">
+              <a:schemeClr val="accent1"/>
+            </a:effectRef>
+            <a:fontRef idx="minor">
+              <a:schemeClr val="lt1"/>
+            </a:fontRef>
+          </p:style>
+          <p:txBody>
+            <a:bodyPr rtlCol="0" anchor="ctr"/>
+            <a:lstStyle/>
+            <a:p>
+              <a:pPr algn="ctr"/>
+              <a:endParaRPr lang="en-US"/>
+            </a:p>
+          </p:txBody>
+        </p:sp>
+        <p:sp>
+          <p:nvSpPr>
+            <p:cNvPr id="26" name="CuadroTexto 25">
+              <a:extLst>
+                <a:ext uri="{FF2B5EF4-FFF2-40B4-BE49-F238E27FC236}">
+                  <a16:creationId xmlns:a16="http://schemas.microsoft.com/office/drawing/2014/main" id="{996FC952-E985-B081-4411-B09F65C8F42D}"/>
+                </a:ext>
+              </a:extLst>
+            </p:cNvPr>
+            <p:cNvSpPr txBox="1"/>
+            <p:nvPr/>
+          </p:nvSpPr>
+          <p:spPr>
+            <a:xfrm>
+              <a:off x="8365444" y="-214621"/>
+              <a:ext cx="2519147" cy="307777"/>
+            </a:xfrm>
+            <a:prstGeom prst="rect">
+              <a:avLst/>
+            </a:prstGeom>
+            <a:noFill/>
+          </p:spPr>
+          <p:txBody>
+            <a:bodyPr wrap="square" rtlCol="0">
+              <a:spAutoFit/>
+            </a:bodyPr>
+            <a:lstStyle/>
+            <a:p>
+              <a:r>
+                <a:rPr lang="en-US" sz="1400" dirty="0"/>
+                <a:t> Is </a:t>
+              </a:r>
+              <a:r>
+                <a:rPr lang="en-US" sz="1400" u="sng" dirty="0"/>
+                <a:t>player</a:t>
+              </a:r>
+              <a:r>
+                <a:rPr lang="en-US" sz="1400" dirty="0"/>
+                <a:t> between </a:t>
+              </a:r>
+              <a:r>
+                <a:rPr lang="en-US" sz="1400" b="1" dirty="0"/>
+                <a:t>0</a:t>
+              </a:r>
+              <a:r>
+                <a:rPr lang="en-US" sz="1400" dirty="0"/>
+                <a:t> and </a:t>
+              </a:r>
+              <a:r>
+                <a:rPr lang="en-US" sz="1400" b="1" dirty="0" err="1"/>
+                <a:t>len</a:t>
+              </a:r>
+              <a:r>
+                <a:rPr lang="en-US" sz="1400" b="1" dirty="0"/>
+                <a:t>(names)</a:t>
+              </a:r>
+              <a:r>
+                <a:rPr lang="en-US" sz="1400" dirty="0"/>
+                <a:t>?</a:t>
+              </a:r>
+            </a:p>
+          </p:txBody>
+        </p:sp>
+        <p:sp>
+          <p:nvSpPr>
+            <p:cNvPr id="27" name="CuadroTexto 26">
+              <a:extLst>
+                <a:ext uri="{FF2B5EF4-FFF2-40B4-BE49-F238E27FC236}">
+                  <a16:creationId xmlns:a16="http://schemas.microsoft.com/office/drawing/2014/main" id="{A33BAEA9-6F07-753C-155B-AEF86ED411B2}"/>
+                </a:ext>
+              </a:extLst>
+            </p:cNvPr>
+            <p:cNvSpPr txBox="1"/>
+            <p:nvPr/>
+          </p:nvSpPr>
+          <p:spPr>
+            <a:xfrm>
+              <a:off x="7711461" y="-528648"/>
+              <a:ext cx="653983" cy="369332"/>
+            </a:xfrm>
+            <a:prstGeom prst="rect">
+              <a:avLst/>
+            </a:prstGeom>
+            <a:noFill/>
+          </p:spPr>
+          <p:txBody>
+            <a:bodyPr wrap="square" rtlCol="0">
+              <a:spAutoFit/>
+            </a:bodyPr>
+            <a:lstStyle/>
+            <a:p>
+              <a:r>
+                <a:rPr lang="en-US" dirty="0"/>
+                <a:t>Ln 4</a:t>
+              </a:r>
+            </a:p>
+          </p:txBody>
+        </p:sp>
+      </p:grpSp>
+      <p:grpSp>
+        <p:nvGrpSpPr>
+          <p:cNvPr id="36" name="Grupo 35">
+            <a:extLst>
+              <a:ext uri="{FF2B5EF4-FFF2-40B4-BE49-F238E27FC236}">
+                <a16:creationId xmlns:a16="http://schemas.microsoft.com/office/drawing/2014/main" id="{44098DF5-33B8-55AB-1832-9F1EA201FCB4}"/>
+              </a:ext>
+            </a:extLst>
+          </p:cNvPr>
+          <p:cNvGrpSpPr/>
+          <p:nvPr/>
+        </p:nvGrpSpPr>
+        <p:grpSpPr>
+          <a:xfrm>
+            <a:off x="9238264" y="1298575"/>
+            <a:ext cx="101190" cy="241491"/>
+            <a:chOff x="9238264" y="1298575"/>
+            <a:chExt cx="101190" cy="241491"/>
+          </a:xfrm>
+        </p:grpSpPr>
+        <p:cxnSp>
+          <p:nvCxnSpPr>
+            <p:cNvPr id="31" name="Conector recto 30">
+              <a:extLst>
+                <a:ext uri="{FF2B5EF4-FFF2-40B4-BE49-F238E27FC236}">
+                  <a16:creationId xmlns:a16="http://schemas.microsoft.com/office/drawing/2014/main" id="{6D822A8C-DE09-0163-08E9-22EC34B16D70}"/>
+                </a:ext>
+              </a:extLst>
+            </p:cNvPr>
+            <p:cNvCxnSpPr/>
+            <p:nvPr/>
+          </p:nvCxnSpPr>
+          <p:spPr>
+            <a:xfrm>
+              <a:off x="9290050" y="1298575"/>
+              <a:ext cx="0" cy="241491"/>
+            </a:xfrm>
+            <a:prstGeom prst="line">
+              <a:avLst/>
+            </a:prstGeom>
+            <a:ln w="19050">
+              <a:solidFill>
+                <a:srgbClr val="7030A0"/>
+              </a:solidFill>
+            </a:ln>
+          </p:spPr>
+          <p:style>
+            <a:lnRef idx="1">
+              <a:schemeClr val="accent1"/>
+            </a:lnRef>
+            <a:fillRef idx="0">
+              <a:schemeClr val="accent1"/>
+            </a:fillRef>
+            <a:effectRef idx="0">
+              <a:schemeClr val="accent1"/>
+            </a:effectRef>
+            <a:fontRef idx="minor">
+              <a:schemeClr val="tx1"/>
+            </a:fontRef>
+          </p:style>
+        </p:cxnSp>
+        <p:cxnSp>
+          <p:nvCxnSpPr>
+            <p:cNvPr id="33" name="Conector recto 32">
+              <a:extLst>
+                <a:ext uri="{FF2B5EF4-FFF2-40B4-BE49-F238E27FC236}">
+                  <a16:creationId xmlns:a16="http://schemas.microsoft.com/office/drawing/2014/main" id="{0CDCA0E8-B925-454C-366D-F7F89B36F83A}"/>
+                </a:ext>
+              </a:extLst>
+            </p:cNvPr>
+            <p:cNvCxnSpPr/>
+            <p:nvPr/>
+          </p:nvCxnSpPr>
+          <p:spPr>
+            <a:xfrm flipH="1" flipV="1">
+              <a:off x="9238264" y="1485900"/>
+              <a:ext cx="54166" cy="54166"/>
+            </a:xfrm>
+            <a:prstGeom prst="line">
+              <a:avLst/>
+            </a:prstGeom>
+            <a:ln w="19050">
+              <a:solidFill>
+                <a:srgbClr val="7030A0"/>
+              </a:solidFill>
+            </a:ln>
+          </p:spPr>
+          <p:style>
+            <a:lnRef idx="1">
+              <a:schemeClr val="accent1"/>
+            </a:lnRef>
+            <a:fillRef idx="0">
+              <a:schemeClr val="accent1"/>
+            </a:fillRef>
+            <a:effectRef idx="0">
+              <a:schemeClr val="accent1"/>
+            </a:effectRef>
+            <a:fontRef idx="minor">
+              <a:schemeClr val="tx1"/>
+            </a:fontRef>
+          </p:style>
+        </p:cxnSp>
+        <p:cxnSp>
+          <p:nvCxnSpPr>
+            <p:cNvPr id="35" name="Conector recto 34">
+              <a:extLst>
+                <a:ext uri="{FF2B5EF4-FFF2-40B4-BE49-F238E27FC236}">
+                  <a16:creationId xmlns:a16="http://schemas.microsoft.com/office/drawing/2014/main" id="{EF8F683C-9428-C394-F6F2-3D837B0E9676}"/>
+                </a:ext>
+              </a:extLst>
+            </p:cNvPr>
+            <p:cNvCxnSpPr/>
+            <p:nvPr/>
+          </p:nvCxnSpPr>
+          <p:spPr>
+            <a:xfrm flipV="1">
+              <a:off x="9285288" y="1485900"/>
+              <a:ext cx="54166" cy="54166"/>
+            </a:xfrm>
+            <a:prstGeom prst="line">
+              <a:avLst/>
+            </a:prstGeom>
+            <a:ln w="19050">
+              <a:solidFill>
+                <a:srgbClr val="7030A0"/>
+              </a:solidFill>
+            </a:ln>
+          </p:spPr>
+          <p:style>
+            <a:lnRef idx="1">
+              <a:schemeClr val="accent1"/>
+            </a:lnRef>
+            <a:fillRef idx="0">
+              <a:schemeClr val="accent1"/>
+            </a:fillRef>
+            <a:effectRef idx="0">
+              <a:schemeClr val="accent1"/>
+            </a:effectRef>
+            <a:fontRef idx="minor">
+              <a:schemeClr val="tx1"/>
+            </a:fontRef>
+          </p:style>
+        </p:cxnSp>
+      </p:grpSp>
+      <p:grpSp>
+        <p:nvGrpSpPr>
+          <p:cNvPr id="37" name="Grupo 36">
+            <a:extLst>
+              <a:ext uri="{FF2B5EF4-FFF2-40B4-BE49-F238E27FC236}">
+                <a16:creationId xmlns:a16="http://schemas.microsoft.com/office/drawing/2014/main" id="{A9CB9A38-4EED-BF97-6010-6303332B2406}"/>
+              </a:ext>
+            </a:extLst>
+          </p:cNvPr>
+          <p:cNvGrpSpPr/>
+          <p:nvPr/>
+        </p:nvGrpSpPr>
+        <p:grpSpPr>
+          <a:xfrm>
+            <a:off x="9203939" y="2417978"/>
+            <a:ext cx="75792" cy="180878"/>
+            <a:chOff x="9238264" y="1298575"/>
+            <a:chExt cx="101190" cy="241491"/>
+          </a:xfrm>
+        </p:grpSpPr>
+        <p:cxnSp>
+          <p:nvCxnSpPr>
+            <p:cNvPr id="38" name="Conector recto 37">
+              <a:extLst>
+                <a:ext uri="{FF2B5EF4-FFF2-40B4-BE49-F238E27FC236}">
+                  <a16:creationId xmlns:a16="http://schemas.microsoft.com/office/drawing/2014/main" id="{42F2191B-C121-1459-E7EF-7741711B43E1}"/>
+                </a:ext>
+              </a:extLst>
+            </p:cNvPr>
+            <p:cNvCxnSpPr/>
+            <p:nvPr/>
+          </p:nvCxnSpPr>
+          <p:spPr>
+            <a:xfrm>
+              <a:off x="9290050" y="1298575"/>
+              <a:ext cx="0" cy="241491"/>
+            </a:xfrm>
+            <a:prstGeom prst="line">
+              <a:avLst/>
+            </a:prstGeom>
+            <a:ln w="19050">
+              <a:solidFill>
+                <a:srgbClr val="7030A0"/>
+              </a:solidFill>
+            </a:ln>
+          </p:spPr>
+          <p:style>
+            <a:lnRef idx="1">
+              <a:schemeClr val="accent1"/>
+            </a:lnRef>
+            <a:fillRef idx="0">
+              <a:schemeClr val="accent1"/>
+            </a:fillRef>
+            <a:effectRef idx="0">
+              <a:schemeClr val="accent1"/>
+            </a:effectRef>
+            <a:fontRef idx="minor">
+              <a:schemeClr val="tx1"/>
+            </a:fontRef>
+          </p:style>
+        </p:cxnSp>
+        <p:cxnSp>
+          <p:nvCxnSpPr>
+            <p:cNvPr id="39" name="Conector recto 38">
+              <a:extLst>
+                <a:ext uri="{FF2B5EF4-FFF2-40B4-BE49-F238E27FC236}">
+                  <a16:creationId xmlns:a16="http://schemas.microsoft.com/office/drawing/2014/main" id="{156312E6-621F-9308-A419-DD8EEB78F966}"/>
+                </a:ext>
+              </a:extLst>
+            </p:cNvPr>
+            <p:cNvCxnSpPr/>
+            <p:nvPr/>
+          </p:nvCxnSpPr>
+          <p:spPr>
+            <a:xfrm flipH="1" flipV="1">
+              <a:off x="9238264" y="1485900"/>
+              <a:ext cx="54166" cy="54166"/>
+            </a:xfrm>
+            <a:prstGeom prst="line">
+              <a:avLst/>
+            </a:prstGeom>
+            <a:ln w="19050">
+              <a:solidFill>
+                <a:srgbClr val="7030A0"/>
+              </a:solidFill>
+            </a:ln>
+          </p:spPr>
+          <p:style>
+            <a:lnRef idx="1">
+              <a:schemeClr val="accent1"/>
+            </a:lnRef>
+            <a:fillRef idx="0">
+              <a:schemeClr val="accent1"/>
+            </a:fillRef>
+            <a:effectRef idx="0">
+              <a:schemeClr val="accent1"/>
+            </a:effectRef>
+            <a:fontRef idx="minor">
+              <a:schemeClr val="tx1"/>
+            </a:fontRef>
+          </p:style>
+        </p:cxnSp>
+        <p:cxnSp>
+          <p:nvCxnSpPr>
+            <p:cNvPr id="40" name="Conector recto 39">
+              <a:extLst>
+                <a:ext uri="{FF2B5EF4-FFF2-40B4-BE49-F238E27FC236}">
+                  <a16:creationId xmlns:a16="http://schemas.microsoft.com/office/drawing/2014/main" id="{A863CE9B-10FF-5DAB-C4F6-4B67E5CD6778}"/>
+                </a:ext>
+              </a:extLst>
+            </p:cNvPr>
+            <p:cNvCxnSpPr/>
+            <p:nvPr/>
+          </p:nvCxnSpPr>
+          <p:spPr>
+            <a:xfrm flipV="1">
+              <a:off x="9285288" y="1485900"/>
+              <a:ext cx="54166" cy="54166"/>
+            </a:xfrm>
+            <a:prstGeom prst="line">
+              <a:avLst/>
+            </a:prstGeom>
+            <a:ln w="19050">
+              <a:solidFill>
+                <a:srgbClr val="7030A0"/>
+              </a:solidFill>
+            </a:ln>
+          </p:spPr>
+          <p:style>
+            <a:lnRef idx="1">
+              <a:schemeClr val="accent1"/>
+            </a:lnRef>
+            <a:fillRef idx="0">
+              <a:schemeClr val="accent1"/>
+            </a:fillRef>
+            <a:effectRef idx="0">
+              <a:schemeClr val="accent1"/>
+            </a:effectRef>
+            <a:fontRef idx="minor">
+              <a:schemeClr val="tx1"/>
+            </a:fontRef>
+          </p:style>
+        </p:cxnSp>
+      </p:grpSp>
+      <p:grpSp>
+        <p:nvGrpSpPr>
+          <p:cNvPr id="46" name="Grupo 45">
+            <a:extLst>
+              <a:ext uri="{FF2B5EF4-FFF2-40B4-BE49-F238E27FC236}">
+                <a16:creationId xmlns:a16="http://schemas.microsoft.com/office/drawing/2014/main" id="{308CC9D6-AFD4-F541-06D2-A2492D794D41}"/>
+              </a:ext>
+            </a:extLst>
+          </p:cNvPr>
+          <p:cNvGrpSpPr/>
+          <p:nvPr/>
+        </p:nvGrpSpPr>
+        <p:grpSpPr>
+          <a:xfrm>
+            <a:off x="754644" y="2429365"/>
+            <a:ext cx="5583318" cy="963782"/>
+            <a:chOff x="1657702" y="2363230"/>
+            <a:chExt cx="5583318" cy="1058423"/>
+          </a:xfrm>
+        </p:grpSpPr>
+        <p:sp>
+          <p:nvSpPr>
+            <p:cNvPr id="41" name="CuadroTexto 40">
+              <a:extLst>
+                <a:ext uri="{FF2B5EF4-FFF2-40B4-BE49-F238E27FC236}">
+                  <a16:creationId xmlns:a16="http://schemas.microsoft.com/office/drawing/2014/main" id="{861F0D73-B44B-2BD2-E548-BA98AE8BFEF3}"/>
+                </a:ext>
+              </a:extLst>
+            </p:cNvPr>
+            <p:cNvSpPr txBox="1"/>
+            <p:nvPr/>
+          </p:nvSpPr>
+          <p:spPr>
+            <a:xfrm>
+              <a:off x="1986182" y="2363230"/>
+              <a:ext cx="674006" cy="369332"/>
+            </a:xfrm>
+            <a:prstGeom prst="rect">
+              <a:avLst/>
+            </a:prstGeom>
+            <a:noFill/>
+          </p:spPr>
+          <p:txBody>
+            <a:bodyPr wrap="square" rtlCol="0">
+              <a:spAutoFit/>
+            </a:bodyPr>
+            <a:lstStyle/>
+            <a:p>
+              <a:r>
+                <a:rPr lang="en-US" dirty="0"/>
+                <a:t>Ln 6</a:t>
+              </a:r>
+            </a:p>
+          </p:txBody>
+        </p:sp>
+        <p:sp>
+          <p:nvSpPr>
+            <p:cNvPr id="42" name="Elipse 41">
+              <a:extLst>
+                <a:ext uri="{FF2B5EF4-FFF2-40B4-BE49-F238E27FC236}">
+                  <a16:creationId xmlns:a16="http://schemas.microsoft.com/office/drawing/2014/main" id="{DE679562-971A-FBE4-8881-B2F0B753AA42}"/>
+                </a:ext>
+              </a:extLst>
+            </p:cNvPr>
+            <p:cNvSpPr/>
+            <p:nvPr/>
+          </p:nvSpPr>
+          <p:spPr>
+            <a:xfrm>
+              <a:off x="1657702" y="2659163"/>
+              <a:ext cx="5583318" cy="762490"/>
+            </a:xfrm>
+            <a:prstGeom prst="ellipse">
+              <a:avLst/>
+            </a:prstGeom>
+            <a:solidFill>
+              <a:srgbClr val="CAD7EE"/>
+            </a:solidFill>
+            <a:ln w="38100"/>
+          </p:spPr>
+          <p:style>
+            <a:lnRef idx="2">
+              <a:schemeClr val="accent1">
+                <a:shade val="15000"/>
+              </a:schemeClr>
+            </a:lnRef>
+            <a:fillRef idx="1">
+              <a:schemeClr val="accent1"/>
+            </a:fillRef>
+            <a:effectRef idx="0">
+              <a:schemeClr val="accent1"/>
+            </a:effectRef>
+            <a:fontRef idx="minor">
+              <a:schemeClr val="lt1"/>
+            </a:fontRef>
+          </p:style>
+          <p:txBody>
+            <a:bodyPr rtlCol="0" anchor="ctr"/>
+            <a:lstStyle/>
+            <a:p>
+              <a:pPr algn="ctr"/>
+              <a:endParaRPr lang="en-US"/>
+            </a:p>
+          </p:txBody>
+        </p:sp>
+        <p:sp>
+          <p:nvSpPr>
+            <p:cNvPr id="43" name="CuadroTexto 42">
+              <a:extLst>
+                <a:ext uri="{FF2B5EF4-FFF2-40B4-BE49-F238E27FC236}">
+                  <a16:creationId xmlns:a16="http://schemas.microsoft.com/office/drawing/2014/main" id="{D7BFAE45-5DFE-06F5-EE9F-BA00516C5A5F}"/>
+                </a:ext>
+              </a:extLst>
+            </p:cNvPr>
+            <p:cNvSpPr txBox="1"/>
+            <p:nvPr/>
+          </p:nvSpPr>
+          <p:spPr>
+            <a:xfrm>
+              <a:off x="2021073" y="2812775"/>
+              <a:ext cx="5067859" cy="369332"/>
+            </a:xfrm>
+            <a:prstGeom prst="rect">
+              <a:avLst/>
+            </a:prstGeom>
+            <a:noFill/>
+          </p:spPr>
+          <p:txBody>
+            <a:bodyPr wrap="square" rtlCol="0">
+              <a:spAutoFit/>
+            </a:bodyPr>
+            <a:lstStyle/>
+            <a:p>
+              <a:r>
+                <a:rPr lang="en-US" dirty="0" err="1"/>
+                <a:t>full_name</a:t>
+              </a:r>
+              <a:r>
+                <a:rPr lang="en-US" dirty="0"/>
+                <a:t> = names[player] + “ “ + surnames[player]</a:t>
+              </a:r>
+            </a:p>
+          </p:txBody>
+        </p:sp>
+      </p:grpSp>
+      <p:sp>
+        <p:nvSpPr>
+          <p:cNvPr id="44" name="CuadroTexto 43">
+            <a:extLst>
+              <a:ext uri="{FF2B5EF4-FFF2-40B4-BE49-F238E27FC236}">
+                <a16:creationId xmlns:a16="http://schemas.microsoft.com/office/drawing/2014/main" id="{378EA95F-DEB2-5E04-EBFE-7A2102C4AB4A}"/>
+              </a:ext>
+            </a:extLst>
+          </p:cNvPr>
+          <p:cNvSpPr txBox="1"/>
+          <p:nvPr/>
+        </p:nvSpPr>
+        <p:spPr>
+          <a:xfrm>
+            <a:off x="9437120" y="5506252"/>
+            <a:ext cx="674006" cy="369332"/>
+          </a:xfrm>
+          <a:prstGeom prst="rect">
+            <a:avLst/>
+          </a:prstGeom>
+          <a:noFill/>
+        </p:spPr>
+        <p:txBody>
+          <a:bodyPr wrap="square" rtlCol="0">
+            <a:spAutoFit/>
+          </a:bodyPr>
+          <a:lstStyle/>
+          <a:p>
+            <a:r>
+              <a:rPr lang="en-US" dirty="0"/>
+              <a:t>Ln 7</a:t>
+            </a:r>
+          </a:p>
+        </p:txBody>
+      </p:sp>
+      <p:sp>
+        <p:nvSpPr>
+          <p:cNvPr id="45" name="CuadroTexto 44">
+            <a:extLst>
+              <a:ext uri="{FF2B5EF4-FFF2-40B4-BE49-F238E27FC236}">
+                <a16:creationId xmlns:a16="http://schemas.microsoft.com/office/drawing/2014/main" id="{7FD6E253-86E8-9EA0-30E9-6FD8F6F9B10B}"/>
+              </a:ext>
+            </a:extLst>
+          </p:cNvPr>
+          <p:cNvSpPr txBox="1"/>
+          <p:nvPr/>
+        </p:nvSpPr>
+        <p:spPr>
+          <a:xfrm>
+            <a:off x="9451746" y="6062617"/>
+            <a:ext cx="674006" cy="369332"/>
+          </a:xfrm>
+          <a:prstGeom prst="rect">
+            <a:avLst/>
+          </a:prstGeom>
+          <a:noFill/>
+        </p:spPr>
+        <p:txBody>
+          <a:bodyPr wrap="square" rtlCol="0">
+            <a:spAutoFit/>
+          </a:bodyPr>
+          <a:lstStyle/>
+          <a:p>
+            <a:r>
+              <a:rPr lang="en-US" dirty="0"/>
+              <a:t>Ln 8</a:t>
+            </a:r>
+          </a:p>
+        </p:txBody>
+      </p:sp>
       <p:grpSp>
         <p:nvGrpSpPr>
           <p:cNvPr id="11" name="Grupo 10">
@@ -10986,8 +12715,8 @@
         </p:nvGrpSpPr>
         <p:grpSpPr>
           <a:xfrm rot="1017173">
-            <a:off x="5372715" y="2382051"/>
-            <a:ext cx="2337358" cy="2087943"/>
+            <a:off x="5832418" y="2972626"/>
+            <a:ext cx="1506546" cy="1468286"/>
             <a:chOff x="4312494" y="1392221"/>
             <a:chExt cx="2564824" cy="2291137"/>
           </a:xfrm>
@@ -11423,10 +13152,10 @@
       </p:grpSp>
       <p:sp>
         <p:nvSpPr>
-          <p:cNvPr id="14" name="CuadroTexto 13">
-            <a:extLst>
-              <a:ext uri="{FF2B5EF4-FFF2-40B4-BE49-F238E27FC236}">
-                <a16:creationId xmlns:a16="http://schemas.microsoft.com/office/drawing/2014/main" id="{04AE7A53-B1E0-4563-9349-021659839603}"/>
+          <p:cNvPr id="47" name="CuadroTexto 46">
+            <a:extLst>
+              <a:ext uri="{FF2B5EF4-FFF2-40B4-BE49-F238E27FC236}">
+                <a16:creationId xmlns:a16="http://schemas.microsoft.com/office/drawing/2014/main" id="{65EBC8C0-633B-4451-45BD-91DBAD361D88}"/>
               </a:ext>
             </a:extLst>
           </p:cNvPr>
@@ -11435,8 +13164,8 @@
         </p:nvSpPr>
         <p:spPr>
           <a:xfrm>
-            <a:off x="6983290" y="4105348"/>
-            <a:ext cx="361682" cy="769441"/>
+            <a:off x="9573874" y="6495449"/>
+            <a:ext cx="1779926" cy="369332"/>
           </a:xfrm>
           <a:prstGeom prst="rect">
             <a:avLst/>
@@ -11450,22 +13179,372 @@
           <a:lstStyle/>
           <a:p>
             <a:r>
-              <a:rPr lang="en-US" sz="4400" b="1" dirty="0">
-                <a:solidFill>
-                  <a:srgbClr val="00B050"/>
-                </a:solidFill>
-              </a:rPr>
-              <a:t>T</a:t>
+              <a:rPr lang="en-US" dirty="0"/>
+              <a:t>…</a:t>
             </a:r>
           </a:p>
         </p:txBody>
       </p:sp>
+      <p:grpSp>
+        <p:nvGrpSpPr>
+          <p:cNvPr id="48" name="Grupo 47">
+            <a:extLst>
+              <a:ext uri="{FF2B5EF4-FFF2-40B4-BE49-F238E27FC236}">
+                <a16:creationId xmlns:a16="http://schemas.microsoft.com/office/drawing/2014/main" id="{133246C1-FBA9-0BB7-57A7-5F3D992AF239}"/>
+              </a:ext>
+            </a:extLst>
+          </p:cNvPr>
+          <p:cNvGrpSpPr/>
+          <p:nvPr/>
+        </p:nvGrpSpPr>
+        <p:grpSpPr>
+          <a:xfrm>
+            <a:off x="9698331" y="5908852"/>
+            <a:ext cx="75792" cy="180878"/>
+            <a:chOff x="9238264" y="1298575"/>
+            <a:chExt cx="101190" cy="241491"/>
+          </a:xfrm>
+        </p:grpSpPr>
+        <p:cxnSp>
+          <p:nvCxnSpPr>
+            <p:cNvPr id="49" name="Conector recto 48">
+              <a:extLst>
+                <a:ext uri="{FF2B5EF4-FFF2-40B4-BE49-F238E27FC236}">
+                  <a16:creationId xmlns:a16="http://schemas.microsoft.com/office/drawing/2014/main" id="{DE91E204-2D85-745D-4EF1-ADF05866D685}"/>
+                </a:ext>
+              </a:extLst>
+            </p:cNvPr>
+            <p:cNvCxnSpPr/>
+            <p:nvPr/>
+          </p:nvCxnSpPr>
+          <p:spPr>
+            <a:xfrm>
+              <a:off x="9290050" y="1298575"/>
+              <a:ext cx="0" cy="241491"/>
+            </a:xfrm>
+            <a:prstGeom prst="line">
+              <a:avLst/>
+            </a:prstGeom>
+            <a:ln w="19050">
+              <a:solidFill>
+                <a:srgbClr val="7030A0"/>
+              </a:solidFill>
+            </a:ln>
+          </p:spPr>
+          <p:style>
+            <a:lnRef idx="1">
+              <a:schemeClr val="accent1"/>
+            </a:lnRef>
+            <a:fillRef idx="0">
+              <a:schemeClr val="accent1"/>
+            </a:fillRef>
+            <a:effectRef idx="0">
+              <a:schemeClr val="accent1"/>
+            </a:effectRef>
+            <a:fontRef idx="minor">
+              <a:schemeClr val="tx1"/>
+            </a:fontRef>
+          </p:style>
+        </p:cxnSp>
+        <p:cxnSp>
+          <p:nvCxnSpPr>
+            <p:cNvPr id="50" name="Conector recto 49">
+              <a:extLst>
+                <a:ext uri="{FF2B5EF4-FFF2-40B4-BE49-F238E27FC236}">
+                  <a16:creationId xmlns:a16="http://schemas.microsoft.com/office/drawing/2014/main" id="{4AE0AA25-7B61-247F-88CA-81C06C56C1D9}"/>
+                </a:ext>
+              </a:extLst>
+            </p:cNvPr>
+            <p:cNvCxnSpPr/>
+            <p:nvPr/>
+          </p:nvCxnSpPr>
+          <p:spPr>
+            <a:xfrm flipH="1" flipV="1">
+              <a:off x="9238264" y="1485900"/>
+              <a:ext cx="54166" cy="54166"/>
+            </a:xfrm>
+            <a:prstGeom prst="line">
+              <a:avLst/>
+            </a:prstGeom>
+            <a:ln w="19050">
+              <a:solidFill>
+                <a:srgbClr val="7030A0"/>
+              </a:solidFill>
+            </a:ln>
+          </p:spPr>
+          <p:style>
+            <a:lnRef idx="1">
+              <a:schemeClr val="accent1"/>
+            </a:lnRef>
+            <a:fillRef idx="0">
+              <a:schemeClr val="accent1"/>
+            </a:fillRef>
+            <a:effectRef idx="0">
+              <a:schemeClr val="accent1"/>
+            </a:effectRef>
+            <a:fontRef idx="minor">
+              <a:schemeClr val="tx1"/>
+            </a:fontRef>
+          </p:style>
+        </p:cxnSp>
+        <p:cxnSp>
+          <p:nvCxnSpPr>
+            <p:cNvPr id="51" name="Conector recto 50">
+              <a:extLst>
+                <a:ext uri="{FF2B5EF4-FFF2-40B4-BE49-F238E27FC236}">
+                  <a16:creationId xmlns:a16="http://schemas.microsoft.com/office/drawing/2014/main" id="{5C760A58-34E0-F735-7049-0342BCE838ED}"/>
+                </a:ext>
+              </a:extLst>
+            </p:cNvPr>
+            <p:cNvCxnSpPr/>
+            <p:nvPr/>
+          </p:nvCxnSpPr>
+          <p:spPr>
+            <a:xfrm flipV="1">
+              <a:off x="9285288" y="1485900"/>
+              <a:ext cx="54166" cy="54166"/>
+            </a:xfrm>
+            <a:prstGeom prst="line">
+              <a:avLst/>
+            </a:prstGeom>
+            <a:ln w="19050">
+              <a:solidFill>
+                <a:srgbClr val="7030A0"/>
+              </a:solidFill>
+            </a:ln>
+          </p:spPr>
+          <p:style>
+            <a:lnRef idx="1">
+              <a:schemeClr val="accent1"/>
+            </a:lnRef>
+            <a:fillRef idx="0">
+              <a:schemeClr val="accent1"/>
+            </a:fillRef>
+            <a:effectRef idx="0">
+              <a:schemeClr val="accent1"/>
+            </a:effectRef>
+            <a:fontRef idx="minor">
+              <a:schemeClr val="tx1"/>
+            </a:fontRef>
+          </p:style>
+        </p:cxnSp>
+      </p:grpSp>
+      <p:grpSp>
+        <p:nvGrpSpPr>
+          <p:cNvPr id="52" name="Grupo 51">
+            <a:extLst>
+              <a:ext uri="{FF2B5EF4-FFF2-40B4-BE49-F238E27FC236}">
+                <a16:creationId xmlns:a16="http://schemas.microsoft.com/office/drawing/2014/main" id="{D026FAC0-BF65-E185-C7F9-5169E6AD908F}"/>
+              </a:ext>
+            </a:extLst>
+          </p:cNvPr>
+          <p:cNvGrpSpPr/>
+          <p:nvPr/>
+        </p:nvGrpSpPr>
+        <p:grpSpPr>
+          <a:xfrm>
+            <a:off x="9698331" y="6419329"/>
+            <a:ext cx="75792" cy="180878"/>
+            <a:chOff x="9238264" y="1298575"/>
+            <a:chExt cx="101190" cy="241491"/>
+          </a:xfrm>
+        </p:grpSpPr>
+        <p:cxnSp>
+          <p:nvCxnSpPr>
+            <p:cNvPr id="53" name="Conector recto 52">
+              <a:extLst>
+                <a:ext uri="{FF2B5EF4-FFF2-40B4-BE49-F238E27FC236}">
+                  <a16:creationId xmlns:a16="http://schemas.microsoft.com/office/drawing/2014/main" id="{23F46DAB-1D20-E100-C796-3EA35E1FF072}"/>
+                </a:ext>
+              </a:extLst>
+            </p:cNvPr>
+            <p:cNvCxnSpPr/>
+            <p:nvPr/>
+          </p:nvCxnSpPr>
+          <p:spPr>
+            <a:xfrm>
+              <a:off x="9290050" y="1298575"/>
+              <a:ext cx="0" cy="241491"/>
+            </a:xfrm>
+            <a:prstGeom prst="line">
+              <a:avLst/>
+            </a:prstGeom>
+            <a:ln w="19050">
+              <a:solidFill>
+                <a:srgbClr val="7030A0"/>
+              </a:solidFill>
+            </a:ln>
+          </p:spPr>
+          <p:style>
+            <a:lnRef idx="1">
+              <a:schemeClr val="accent1"/>
+            </a:lnRef>
+            <a:fillRef idx="0">
+              <a:schemeClr val="accent1"/>
+            </a:fillRef>
+            <a:effectRef idx="0">
+              <a:schemeClr val="accent1"/>
+            </a:effectRef>
+            <a:fontRef idx="minor">
+              <a:schemeClr val="tx1"/>
+            </a:fontRef>
+          </p:style>
+        </p:cxnSp>
+        <p:cxnSp>
+          <p:nvCxnSpPr>
+            <p:cNvPr id="54" name="Conector recto 53">
+              <a:extLst>
+                <a:ext uri="{FF2B5EF4-FFF2-40B4-BE49-F238E27FC236}">
+                  <a16:creationId xmlns:a16="http://schemas.microsoft.com/office/drawing/2014/main" id="{AF854FF0-44CE-E6B5-ED60-D8A00521009E}"/>
+                </a:ext>
+              </a:extLst>
+            </p:cNvPr>
+            <p:cNvCxnSpPr/>
+            <p:nvPr/>
+          </p:nvCxnSpPr>
+          <p:spPr>
+            <a:xfrm flipH="1" flipV="1">
+              <a:off x="9238264" y="1485900"/>
+              <a:ext cx="54166" cy="54166"/>
+            </a:xfrm>
+            <a:prstGeom prst="line">
+              <a:avLst/>
+            </a:prstGeom>
+            <a:ln w="19050">
+              <a:solidFill>
+                <a:srgbClr val="7030A0"/>
+              </a:solidFill>
+            </a:ln>
+          </p:spPr>
+          <p:style>
+            <a:lnRef idx="1">
+              <a:schemeClr val="accent1"/>
+            </a:lnRef>
+            <a:fillRef idx="0">
+              <a:schemeClr val="accent1"/>
+            </a:fillRef>
+            <a:effectRef idx="0">
+              <a:schemeClr val="accent1"/>
+            </a:effectRef>
+            <a:fontRef idx="minor">
+              <a:schemeClr val="tx1"/>
+            </a:fontRef>
+          </p:style>
+        </p:cxnSp>
+        <p:cxnSp>
+          <p:nvCxnSpPr>
+            <p:cNvPr id="55" name="Conector recto 54">
+              <a:extLst>
+                <a:ext uri="{FF2B5EF4-FFF2-40B4-BE49-F238E27FC236}">
+                  <a16:creationId xmlns:a16="http://schemas.microsoft.com/office/drawing/2014/main" id="{58A35B8F-70BF-A1CD-6DB8-8A459F48A136}"/>
+                </a:ext>
+              </a:extLst>
+            </p:cNvPr>
+            <p:cNvCxnSpPr/>
+            <p:nvPr/>
+          </p:nvCxnSpPr>
+          <p:spPr>
+            <a:xfrm flipV="1">
+              <a:off x="9285288" y="1485900"/>
+              <a:ext cx="54166" cy="54166"/>
+            </a:xfrm>
+            <a:prstGeom prst="line">
+              <a:avLst/>
+            </a:prstGeom>
+            <a:ln w="19050">
+              <a:solidFill>
+                <a:srgbClr val="7030A0"/>
+              </a:solidFill>
+            </a:ln>
+          </p:spPr>
+          <p:style>
+            <a:lnRef idx="1">
+              <a:schemeClr val="accent1"/>
+            </a:lnRef>
+            <a:fillRef idx="0">
+              <a:schemeClr val="accent1"/>
+            </a:fillRef>
+            <a:effectRef idx="0">
+              <a:schemeClr val="accent1"/>
+            </a:effectRef>
+            <a:fontRef idx="minor">
+              <a:schemeClr val="tx1"/>
+            </a:fontRef>
+          </p:style>
+        </p:cxnSp>
+      </p:grpSp>
+    </p:spTree>
+    <p:extLst>
+      <p:ext uri="{BB962C8B-B14F-4D97-AF65-F5344CB8AC3E}">
+        <p14:creationId xmlns:p14="http://schemas.microsoft.com/office/powerpoint/2010/main" val="2107084744"/>
+      </p:ext>
+    </p:extLst>
+  </p:cSld>
+  <p:clrMapOvr>
+    <a:masterClrMapping/>
+  </p:clrMapOvr>
+</p:sld>
+</file>
+
+<file path=ppt/slides/slide17.xml><?xml version="1.0" encoding="utf-8"?>
+<p:sld xmlns:a="http://schemas.openxmlformats.org/drawingml/2006/main" xmlns:r="http://schemas.openxmlformats.org/officeDocument/2006/relationships" xmlns:p="http://schemas.openxmlformats.org/presentationml/2006/main">
+  <p:cSld>
+    <p:spTree>
+      <p:nvGrpSpPr>
+        <p:cNvPr id="1" name="">
+          <a:extLst>
+            <a:ext uri="{FF2B5EF4-FFF2-40B4-BE49-F238E27FC236}">
+              <a16:creationId xmlns:a16="http://schemas.microsoft.com/office/drawing/2014/main" id="{849DCD28-CD76-17D8-ECAB-C5B8F7FCA1FA}"/>
+            </a:ext>
+          </a:extLst>
+        </p:cNvPr>
+        <p:cNvGrpSpPr/>
+        <p:nvPr/>
+      </p:nvGrpSpPr>
+      <p:grpSpPr>
+        <a:xfrm>
+          <a:off x="0" y="0"/>
+          <a:ext cx="0" cy="0"/>
+          <a:chOff x="0" y="0"/>
+          <a:chExt cx="0" cy="0"/>
+        </a:xfrm>
+      </p:grpSpPr>
+      <p:pic>
+        <p:nvPicPr>
+          <p:cNvPr id="22" name="Imagen 21">
+            <a:extLst>
+              <a:ext uri="{FF2B5EF4-FFF2-40B4-BE49-F238E27FC236}">
+                <a16:creationId xmlns:a16="http://schemas.microsoft.com/office/drawing/2014/main" id="{5085AC2F-099C-CD40-3C64-435EA4C08146}"/>
+              </a:ext>
+            </a:extLst>
+          </p:cNvPr>
+          <p:cNvPicPr>
+            <a:picLocks noChangeAspect="1"/>
+          </p:cNvPicPr>
+          <p:nvPr/>
+        </p:nvPicPr>
+        <p:blipFill>
+          <a:blip r:embed="rId2"/>
+          <a:stretch>
+            <a:fillRect/>
+          </a:stretch>
+        </p:blipFill>
+        <p:spPr>
+          <a:xfrm>
+            <a:off x="-12354" y="4955580"/>
+            <a:ext cx="7488353" cy="1906544"/>
+          </a:xfrm>
+          <a:prstGeom prst="rect">
+            <a:avLst/>
+          </a:prstGeom>
+        </p:spPr>
+      </p:pic>
       <p:sp>
         <p:nvSpPr>
-          <p:cNvPr id="15" name="CuadroTexto 14">
-            <a:extLst>
-              <a:ext uri="{FF2B5EF4-FFF2-40B4-BE49-F238E27FC236}">
-                <a16:creationId xmlns:a16="http://schemas.microsoft.com/office/drawing/2014/main" id="{1BB2F5FF-F9E4-6F50-01E1-9D59F374D97D}"/>
+          <p:cNvPr id="2" name="CuadroTexto 1">
+            <a:extLst>
+              <a:ext uri="{FF2B5EF4-FFF2-40B4-BE49-F238E27FC236}">
+                <a16:creationId xmlns:a16="http://schemas.microsoft.com/office/drawing/2014/main" id="{D55AA62F-D8BA-9D36-58DB-105F861CB35F}"/>
               </a:ext>
             </a:extLst>
           </p:cNvPr>
@@ -11474,8 +13553,8 @@
         </p:nvSpPr>
         <p:spPr>
           <a:xfrm>
-            <a:off x="11199788" y="3877657"/>
-            <a:ext cx="583841" cy="769441"/>
+            <a:off x="579549" y="618186"/>
+            <a:ext cx="11217499" cy="954107"/>
           </a:xfrm>
           <a:prstGeom prst="rect">
             <a:avLst/>
@@ -11488,614 +13567,233 @@
           </a:bodyPr>
           <a:lstStyle/>
           <a:p>
-            <a:r>
-              <a:rPr lang="en-US" sz="4400" b="1" dirty="0">
+            <a:pPr marL="285750" indent="-285750">
+              <a:buFont typeface="Arial" panose="020B0604020202020204" pitchFamily="34" charset="0"/>
+              <a:buChar char="•"/>
+            </a:pPr>
+            <a:r>
+              <a:rPr lang="es-AR" sz="2800" dirty="0"/>
+              <a:t> </a:t>
+            </a:r>
+            <a:r>
+              <a:rPr lang="es-AR" sz="2800" dirty="0" err="1">
                 <a:solidFill>
-                  <a:srgbClr val="FF0000"/>
+                  <a:srgbClr val="8A008A"/>
                 </a:solidFill>
               </a:rPr>
-              <a:t>F</a:t>
+              <a:t>len</a:t>
+            </a:r>
+            <a:r>
+              <a:rPr lang="en-US" sz="2800" dirty="0">
+                <a:solidFill>
+                  <a:srgbClr val="8A008A"/>
+                </a:solidFill>
+              </a:rPr>
+              <a:t>(</a:t>
+            </a:r>
+            <a:r>
+              <a:rPr lang="en-US" sz="2800" dirty="0"/>
+              <a:t>names</a:t>
+            </a:r>
+            <a:r>
+              <a:rPr lang="en-US" sz="2800" dirty="0">
+                <a:solidFill>
+                  <a:srgbClr val="8A008A"/>
+                </a:solidFill>
+              </a:rPr>
+              <a:t>)</a:t>
+            </a:r>
+            <a:r>
+              <a:rPr lang="en-US" sz="2800" dirty="0"/>
+              <a:t>        ==   4</a:t>
+            </a:r>
+          </a:p>
+          <a:p>
+            <a:pPr marL="285750" indent="-285750">
+              <a:buFont typeface="Arial" panose="020B0604020202020204" pitchFamily="34" charset="0"/>
+              <a:buChar char="•"/>
+            </a:pPr>
+            <a:r>
+              <a:rPr lang="en-US" sz="2800" dirty="0"/>
+              <a:t> </a:t>
+            </a:r>
+            <a:r>
+              <a:rPr lang="en-US" sz="2800" dirty="0" err="1">
+                <a:solidFill>
+                  <a:srgbClr val="8A008A"/>
+                </a:solidFill>
+              </a:rPr>
+              <a:t>len</a:t>
+            </a:r>
+            <a:r>
+              <a:rPr lang="en-US" sz="2800" dirty="0">
+                <a:solidFill>
+                  <a:srgbClr val="8A008A"/>
+                </a:solidFill>
+              </a:rPr>
+              <a:t>(</a:t>
+            </a:r>
+            <a:r>
+              <a:rPr lang="en-US" sz="2800" dirty="0"/>
+              <a:t>surnames</a:t>
+            </a:r>
+            <a:r>
+              <a:rPr lang="en-US" sz="2800" dirty="0">
+                <a:solidFill>
+                  <a:srgbClr val="8A008A"/>
+                </a:solidFill>
+              </a:rPr>
+              <a:t>)</a:t>
+            </a:r>
+            <a:r>
+              <a:rPr lang="en-US" sz="2800" dirty="0"/>
+              <a:t>   ==   4</a:t>
             </a:r>
           </a:p>
         </p:txBody>
       </p:sp>
-      <p:grpSp>
-        <p:nvGrpSpPr>
-          <p:cNvPr id="18" name="Grupo 17">
-            <a:extLst>
-              <a:ext uri="{FF2B5EF4-FFF2-40B4-BE49-F238E27FC236}">
-                <a16:creationId xmlns:a16="http://schemas.microsoft.com/office/drawing/2014/main" id="{03961BC6-C033-D500-B2D4-35182B5AEC5A}"/>
-              </a:ext>
-            </a:extLst>
-          </p:cNvPr>
-          <p:cNvGrpSpPr/>
-          <p:nvPr/>
-        </p:nvGrpSpPr>
-        <p:grpSpPr>
-          <a:xfrm>
-            <a:off x="6983290" y="2512539"/>
-            <a:ext cx="4791515" cy="1254083"/>
-            <a:chOff x="7661457" y="695741"/>
-            <a:chExt cx="4112709" cy="1254083"/>
-          </a:xfrm>
-        </p:grpSpPr>
-        <p:sp>
-          <p:nvSpPr>
-            <p:cNvPr id="19" name="Elipse 18">
-              <a:extLst>
-                <a:ext uri="{FF2B5EF4-FFF2-40B4-BE49-F238E27FC236}">
-                  <a16:creationId xmlns:a16="http://schemas.microsoft.com/office/drawing/2014/main" id="{EBF9D2C2-E97F-BFF3-42B7-76CD45078678}"/>
-                </a:ext>
-              </a:extLst>
-            </p:cNvPr>
-            <p:cNvSpPr/>
-            <p:nvPr/>
-          </p:nvSpPr>
-          <p:spPr>
-            <a:xfrm>
-              <a:off x="7661457" y="991441"/>
-              <a:ext cx="3984558" cy="958383"/>
-            </a:xfrm>
-            <a:prstGeom prst="ellipse">
-              <a:avLst/>
-            </a:prstGeom>
-            <a:solidFill>
-              <a:srgbClr val="CAD7EE"/>
-            </a:solidFill>
-            <a:ln w="38100"/>
-          </p:spPr>
-          <p:style>
-            <a:lnRef idx="2">
-              <a:schemeClr val="accent1">
-                <a:shade val="15000"/>
-              </a:schemeClr>
-            </a:lnRef>
-            <a:fillRef idx="1">
-              <a:schemeClr val="accent1"/>
-            </a:fillRef>
-            <a:effectRef idx="0">
-              <a:schemeClr val="accent1"/>
-            </a:effectRef>
-            <a:fontRef idx="minor">
-              <a:schemeClr val="lt1"/>
-            </a:fontRef>
-          </p:style>
-          <p:txBody>
-            <a:bodyPr rtlCol="0" anchor="ctr"/>
-            <a:lstStyle/>
-            <a:p>
-              <a:pPr algn="ctr"/>
-              <a:endParaRPr lang="en-US"/>
-            </a:p>
-          </p:txBody>
-        </p:sp>
-        <p:sp>
-          <p:nvSpPr>
-            <p:cNvPr id="20" name="CuadroTexto 19">
-              <a:extLst>
-                <a:ext uri="{FF2B5EF4-FFF2-40B4-BE49-F238E27FC236}">
-                  <a16:creationId xmlns:a16="http://schemas.microsoft.com/office/drawing/2014/main" id="{F10A66E0-DD23-9607-DA70-45B4BF424C21}"/>
-                </a:ext>
-              </a:extLst>
-            </p:cNvPr>
-            <p:cNvSpPr txBox="1"/>
-            <p:nvPr/>
-          </p:nvSpPr>
-          <p:spPr>
-            <a:xfrm>
-              <a:off x="7772002" y="1276957"/>
-              <a:ext cx="4002164" cy="369332"/>
-            </a:xfrm>
-            <a:prstGeom prst="rect">
-              <a:avLst/>
-            </a:prstGeom>
-            <a:noFill/>
-          </p:spPr>
-          <p:txBody>
-            <a:bodyPr wrap="square" rtlCol="0">
-              <a:spAutoFit/>
-            </a:bodyPr>
-            <a:lstStyle/>
-            <a:p>
-              <a:r>
-                <a:rPr lang="en-US" dirty="0"/>
-                <a:t>surnames = [“Messi”, “Juli</a:t>
-              </a:r>
-              <a:r>
-                <a:rPr lang="es-AR" dirty="0" err="1"/>
-                <a:t>án</a:t>
-              </a:r>
-              <a:r>
-                <a:rPr lang="es-AR" dirty="0"/>
-                <a:t>”, “Ángel”, “</a:t>
-              </a:r>
-              <a:r>
-                <a:rPr lang="es-AR" dirty="0" err="1"/>
-                <a:t>Dibu</a:t>
-              </a:r>
-              <a:r>
-                <a:rPr lang="es-AR" dirty="0"/>
-                <a:t>”</a:t>
-              </a:r>
-              <a:r>
-                <a:rPr lang="en-US" dirty="0"/>
-                <a:t>]</a:t>
-              </a:r>
-            </a:p>
-          </p:txBody>
-        </p:sp>
-        <p:sp>
-          <p:nvSpPr>
-            <p:cNvPr id="21" name="CuadroTexto 20">
-              <a:extLst>
-                <a:ext uri="{FF2B5EF4-FFF2-40B4-BE49-F238E27FC236}">
-                  <a16:creationId xmlns:a16="http://schemas.microsoft.com/office/drawing/2014/main" id="{B43E2AD1-9584-53E5-A629-AF377D70E7B3}"/>
-                </a:ext>
-              </a:extLst>
-            </p:cNvPr>
-            <p:cNvSpPr txBox="1"/>
-            <p:nvPr/>
-          </p:nvSpPr>
-          <p:spPr>
-            <a:xfrm>
-              <a:off x="7896781" y="695741"/>
-              <a:ext cx="847164" cy="369332"/>
-            </a:xfrm>
-            <a:prstGeom prst="rect">
-              <a:avLst/>
-            </a:prstGeom>
-            <a:noFill/>
-          </p:spPr>
-          <p:txBody>
-            <a:bodyPr wrap="square" rtlCol="0">
-              <a:spAutoFit/>
-            </a:bodyPr>
-            <a:lstStyle/>
-            <a:p>
-              <a:r>
-                <a:rPr lang="en-US" dirty="0"/>
-                <a:t>Ln 2</a:t>
-              </a:r>
-            </a:p>
-          </p:txBody>
-        </p:sp>
-      </p:grpSp>
       <p:sp>
         <p:nvSpPr>
-          <p:cNvPr id="16" name="Forma libre: forma 15">
-            <a:extLst>
-              <a:ext uri="{FF2B5EF4-FFF2-40B4-BE49-F238E27FC236}">
-                <a16:creationId xmlns:a16="http://schemas.microsoft.com/office/drawing/2014/main" id="{38E607E6-0C76-6F3A-7B42-BC8CF9661986}"/>
-              </a:ext>
-            </a:extLst>
-          </p:cNvPr>
-          <p:cNvSpPr/>
+          <p:cNvPr id="4" name="CuadroTexto 3">
+            <a:extLst>
+              <a:ext uri="{FF2B5EF4-FFF2-40B4-BE49-F238E27FC236}">
+                <a16:creationId xmlns:a16="http://schemas.microsoft.com/office/drawing/2014/main" id="{53F5E722-46E7-FBD7-734D-F76DC435358C}"/>
+              </a:ext>
+            </a:extLst>
+          </p:cNvPr>
+          <p:cNvSpPr txBox="1"/>
           <p:nvPr/>
         </p:nvSpPr>
         <p:spPr>
           <a:xfrm>
-            <a:off x="391405" y="1900135"/>
-            <a:ext cx="747686" cy="1769502"/>
-          </a:xfrm>
-          <a:custGeom>
-            <a:avLst/>
-            <a:gdLst>
-              <a:gd name="connsiteX0" fmla="*/ 1268696 w 1907325"/>
-              <a:gd name="connsiteY0" fmla="*/ 0 h 4513942"/>
-              <a:gd name="connsiteX1" fmla="*/ 1544467 w 1907325"/>
-              <a:gd name="connsiteY1" fmla="*/ 348342 h 4513942"/>
-              <a:gd name="connsiteX2" fmla="*/ 1762181 w 1907325"/>
-              <a:gd name="connsiteY2" fmla="*/ 914400 h 4513942"/>
-              <a:gd name="connsiteX3" fmla="*/ 1776696 w 1907325"/>
-              <a:gd name="connsiteY3" fmla="*/ 1524000 h 4513942"/>
-              <a:gd name="connsiteX4" fmla="*/ 1500924 w 1907325"/>
-              <a:gd name="connsiteY4" fmla="*/ 2206171 h 4513942"/>
-              <a:gd name="connsiteX5" fmla="*/ 1297724 w 1907325"/>
-              <a:gd name="connsiteY5" fmla="*/ 2496457 h 4513942"/>
-              <a:gd name="connsiteX6" fmla="*/ 572010 w 1907325"/>
-              <a:gd name="connsiteY6" fmla="*/ 2772228 h 4513942"/>
-              <a:gd name="connsiteX7" fmla="*/ 281724 w 1907325"/>
-              <a:gd name="connsiteY7" fmla="*/ 2714171 h 4513942"/>
-              <a:gd name="connsiteX8" fmla="*/ 5953 w 1907325"/>
-              <a:gd name="connsiteY8" fmla="*/ 2119085 h 4513942"/>
-              <a:gd name="connsiteX9" fmla="*/ 20467 w 1907325"/>
-              <a:gd name="connsiteY9" fmla="*/ 1640114 h 4513942"/>
-              <a:gd name="connsiteX10" fmla="*/ 194638 w 1907325"/>
-              <a:gd name="connsiteY10" fmla="*/ 1364342 h 4513942"/>
-              <a:gd name="connsiteX11" fmla="*/ 891324 w 1907325"/>
-              <a:gd name="connsiteY11" fmla="*/ 1088571 h 4513942"/>
-              <a:gd name="connsiteX12" fmla="*/ 1181610 w 1907325"/>
-              <a:gd name="connsiteY12" fmla="*/ 1059542 h 4513942"/>
-              <a:gd name="connsiteX13" fmla="*/ 1370296 w 1907325"/>
-              <a:gd name="connsiteY13" fmla="*/ 1103085 h 4513942"/>
-              <a:gd name="connsiteX14" fmla="*/ 1646067 w 1907325"/>
-              <a:gd name="connsiteY14" fmla="*/ 1320800 h 4513942"/>
-              <a:gd name="connsiteX15" fmla="*/ 1747667 w 1907325"/>
-              <a:gd name="connsiteY15" fmla="*/ 1640114 h 4513942"/>
-              <a:gd name="connsiteX16" fmla="*/ 1892810 w 1907325"/>
-              <a:gd name="connsiteY16" fmla="*/ 2249714 h 4513942"/>
-              <a:gd name="connsiteX17" fmla="*/ 1805724 w 1907325"/>
-              <a:gd name="connsiteY17" fmla="*/ 3135085 h 4513942"/>
-              <a:gd name="connsiteX18" fmla="*/ 1660581 w 1907325"/>
-              <a:gd name="connsiteY18" fmla="*/ 3614057 h 4513942"/>
-              <a:gd name="connsiteX19" fmla="*/ 1399324 w 1907325"/>
-              <a:gd name="connsiteY19" fmla="*/ 3947885 h 4513942"/>
-              <a:gd name="connsiteX20" fmla="*/ 1283210 w 1907325"/>
-              <a:gd name="connsiteY20" fmla="*/ 4122057 h 4513942"/>
-              <a:gd name="connsiteX21" fmla="*/ 1196124 w 1907325"/>
-              <a:gd name="connsiteY21" fmla="*/ 4397828 h 4513942"/>
-              <a:gd name="connsiteX22" fmla="*/ 1152581 w 1907325"/>
-              <a:gd name="connsiteY22" fmla="*/ 4513942 h 4513942"/>
-            </a:gdLst>
-            <a:ahLst/>
-            <a:cxnLst>
-              <a:cxn ang="0">
-                <a:pos x="connsiteX0" y="connsiteY0"/>
-              </a:cxn>
-              <a:cxn ang="0">
-                <a:pos x="connsiteX1" y="connsiteY1"/>
-              </a:cxn>
-              <a:cxn ang="0">
-                <a:pos x="connsiteX2" y="connsiteY2"/>
-              </a:cxn>
-              <a:cxn ang="0">
-                <a:pos x="connsiteX3" y="connsiteY3"/>
-              </a:cxn>
-              <a:cxn ang="0">
-                <a:pos x="connsiteX4" y="connsiteY4"/>
-              </a:cxn>
-              <a:cxn ang="0">
-                <a:pos x="connsiteX5" y="connsiteY5"/>
-              </a:cxn>
-              <a:cxn ang="0">
-                <a:pos x="connsiteX6" y="connsiteY6"/>
-              </a:cxn>
-              <a:cxn ang="0">
-                <a:pos x="connsiteX7" y="connsiteY7"/>
-              </a:cxn>
-              <a:cxn ang="0">
-                <a:pos x="connsiteX8" y="connsiteY8"/>
-              </a:cxn>
-              <a:cxn ang="0">
-                <a:pos x="connsiteX9" y="connsiteY9"/>
-              </a:cxn>
-              <a:cxn ang="0">
-                <a:pos x="connsiteX10" y="connsiteY10"/>
-              </a:cxn>
-              <a:cxn ang="0">
-                <a:pos x="connsiteX11" y="connsiteY11"/>
-              </a:cxn>
-              <a:cxn ang="0">
-                <a:pos x="connsiteX12" y="connsiteY12"/>
-              </a:cxn>
-              <a:cxn ang="0">
-                <a:pos x="connsiteX13" y="connsiteY13"/>
-              </a:cxn>
-              <a:cxn ang="0">
-                <a:pos x="connsiteX14" y="connsiteY14"/>
-              </a:cxn>
-              <a:cxn ang="0">
-                <a:pos x="connsiteX15" y="connsiteY15"/>
-              </a:cxn>
-              <a:cxn ang="0">
-                <a:pos x="connsiteX16" y="connsiteY16"/>
-              </a:cxn>
-              <a:cxn ang="0">
-                <a:pos x="connsiteX17" y="connsiteY17"/>
-              </a:cxn>
-              <a:cxn ang="0">
-                <a:pos x="connsiteX18" y="connsiteY18"/>
-              </a:cxn>
-              <a:cxn ang="0">
-                <a:pos x="connsiteX19" y="connsiteY19"/>
-              </a:cxn>
-              <a:cxn ang="0">
-                <a:pos x="connsiteX20" y="connsiteY20"/>
-              </a:cxn>
-              <a:cxn ang="0">
-                <a:pos x="connsiteX21" y="connsiteY21"/>
-              </a:cxn>
-              <a:cxn ang="0">
-                <a:pos x="connsiteX22" y="connsiteY22"/>
-              </a:cxn>
-            </a:cxnLst>
-            <a:rect l="l" t="t" r="r" b="b"/>
-            <a:pathLst>
-              <a:path w="1907325" h="4513942">
-                <a:moveTo>
-                  <a:pt x="1268696" y="0"/>
-                </a:moveTo>
-                <a:cubicBezTo>
-                  <a:pt x="1442773" y="124340"/>
-                  <a:pt x="1389854" y="67227"/>
-                  <a:pt x="1544467" y="348342"/>
-                </a:cubicBezTo>
-                <a:cubicBezTo>
-                  <a:pt x="1699367" y="629979"/>
-                  <a:pt x="1682866" y="628863"/>
-                  <a:pt x="1762181" y="914400"/>
-                </a:cubicBezTo>
-                <a:cubicBezTo>
-                  <a:pt x="1776471" y="1078734"/>
-                  <a:pt x="1815799" y="1351947"/>
-                  <a:pt x="1776696" y="1524000"/>
-                </a:cubicBezTo>
-                <a:cubicBezTo>
-                  <a:pt x="1747705" y="1651561"/>
-                  <a:pt x="1570804" y="2083882"/>
-                  <a:pt x="1500924" y="2206171"/>
-                </a:cubicBezTo>
-                <a:cubicBezTo>
-                  <a:pt x="1442324" y="2308722"/>
-                  <a:pt x="1384895" y="2416758"/>
-                  <a:pt x="1297724" y="2496457"/>
-                </a:cubicBezTo>
-                <a:cubicBezTo>
-                  <a:pt x="1086760" y="2689339"/>
-                  <a:pt x="836364" y="2708418"/>
-                  <a:pt x="572010" y="2772228"/>
-                </a:cubicBezTo>
-                <a:cubicBezTo>
-                  <a:pt x="475248" y="2752876"/>
-                  <a:pt x="368793" y="2760608"/>
-                  <a:pt x="281724" y="2714171"/>
-                </a:cubicBezTo>
-                <a:cubicBezTo>
-                  <a:pt x="101836" y="2618231"/>
-                  <a:pt x="43703" y="2240724"/>
-                  <a:pt x="5953" y="2119085"/>
-                </a:cubicBezTo>
-                <a:cubicBezTo>
-                  <a:pt x="10791" y="1959428"/>
-                  <a:pt x="-18273" y="1795075"/>
-                  <a:pt x="20467" y="1640114"/>
-                </a:cubicBezTo>
-                <a:cubicBezTo>
-                  <a:pt x="46836" y="1534637"/>
-                  <a:pt x="119120" y="1442557"/>
-                  <a:pt x="194638" y="1364342"/>
-                </a:cubicBezTo>
-                <a:cubicBezTo>
-                  <a:pt x="353037" y="1200286"/>
-                  <a:pt x="709339" y="1127068"/>
-                  <a:pt x="891324" y="1088571"/>
-                </a:cubicBezTo>
-                <a:cubicBezTo>
-                  <a:pt x="986463" y="1068445"/>
-                  <a:pt x="1084848" y="1069218"/>
-                  <a:pt x="1181610" y="1059542"/>
-                </a:cubicBezTo>
-                <a:cubicBezTo>
-                  <a:pt x="1244505" y="1074056"/>
-                  <a:pt x="1310554" y="1078645"/>
-                  <a:pt x="1370296" y="1103085"/>
-                </a:cubicBezTo>
-                <a:cubicBezTo>
-                  <a:pt x="1458125" y="1139015"/>
-                  <a:pt x="1582620" y="1263698"/>
-                  <a:pt x="1646067" y="1320800"/>
-                </a:cubicBezTo>
-                <a:cubicBezTo>
-                  <a:pt x="1679934" y="1427238"/>
-                  <a:pt x="1718992" y="1532161"/>
-                  <a:pt x="1747667" y="1640114"/>
-                </a:cubicBezTo>
-                <a:cubicBezTo>
-                  <a:pt x="1801291" y="1841994"/>
-                  <a:pt x="1892810" y="2249714"/>
-                  <a:pt x="1892810" y="2249714"/>
-                </a:cubicBezTo>
-                <a:cubicBezTo>
-                  <a:pt x="1912101" y="2693420"/>
-                  <a:pt x="1933113" y="2603050"/>
-                  <a:pt x="1805724" y="3135085"/>
-                </a:cubicBezTo>
-                <a:cubicBezTo>
-                  <a:pt x="1766878" y="3297326"/>
-                  <a:pt x="1735188" y="3464843"/>
-                  <a:pt x="1660581" y="3614057"/>
-                </a:cubicBezTo>
-                <a:cubicBezTo>
-                  <a:pt x="1597389" y="3740441"/>
-                  <a:pt x="1483586" y="3834456"/>
-                  <a:pt x="1399324" y="3947885"/>
-                </a:cubicBezTo>
-                <a:cubicBezTo>
-                  <a:pt x="1357715" y="4003897"/>
-                  <a:pt x="1321915" y="4064000"/>
-                  <a:pt x="1283210" y="4122057"/>
-                </a:cubicBezTo>
-                <a:cubicBezTo>
-                  <a:pt x="1254181" y="4213981"/>
-                  <a:pt x="1226608" y="4306377"/>
-                  <a:pt x="1196124" y="4397828"/>
-                </a:cubicBezTo>
-                <a:cubicBezTo>
-                  <a:pt x="1183052" y="4437043"/>
-                  <a:pt x="1152581" y="4513942"/>
-                  <a:pt x="1152581" y="4513942"/>
-                </a:cubicBezTo>
-              </a:path>
-            </a:pathLst>
-          </a:custGeom>
-          <a:noFill/>
-          <a:ln w="76200"/>
-        </p:spPr>
-        <p:style>
-          <a:lnRef idx="2">
-            <a:schemeClr val="accent1">
-              <a:shade val="15000"/>
-            </a:schemeClr>
-          </a:lnRef>
-          <a:fillRef idx="1">
-            <a:schemeClr val="accent1"/>
-          </a:fillRef>
-          <a:effectRef idx="0">
-            <a:schemeClr val="accent1"/>
-          </a:effectRef>
-          <a:fontRef idx="minor">
-            <a:schemeClr val="lt1"/>
-          </a:fontRef>
-        </p:style>
-        <p:txBody>
-          <a:bodyPr rtlCol="0" anchor="ctr"/>
-          <a:lstStyle/>
-          <a:p>
-            <a:pPr algn="ctr"/>
-            <a:endParaRPr lang="en-US"/>
-          </a:p>
-        </p:txBody>
-      </p:sp>
-      <p:sp>
-        <p:nvSpPr>
-          <p:cNvPr id="24" name="Título 1">
-            <a:extLst>
-              <a:ext uri="{FF2B5EF4-FFF2-40B4-BE49-F238E27FC236}">
-                <a16:creationId xmlns:a16="http://schemas.microsoft.com/office/drawing/2014/main" id="{33C17B9E-9B9F-F39B-4C2D-6356E6F19C1A}"/>
-              </a:ext>
-            </a:extLst>
-          </p:cNvPr>
-          <p:cNvSpPr txBox="1">
-            <a:spLocks/>
-          </p:cNvSpPr>
-          <p:nvPr/>
-        </p:nvSpPr>
-        <p:spPr>
-          <a:xfrm>
-            <a:off x="129860" y="365125"/>
-            <a:ext cx="6853430" cy="1174941"/>
+            <a:off x="4108361" y="2382591"/>
+            <a:ext cx="7237926" cy="1200329"/>
           </a:xfrm>
           <a:prstGeom prst="rect">
             <a:avLst/>
           </a:prstGeom>
+          <a:noFill/>
         </p:spPr>
         <p:txBody>
-          <a:bodyPr vert="horz" lIns="91440" tIns="45720" rIns="91440" bIns="45720" rtlCol="0" anchor="ctr">
-            <a:normAutofit/>
+          <a:bodyPr wrap="square" rtlCol="0">
+            <a:spAutoFit/>
           </a:bodyPr>
-          <a:lstStyle>
-            <a:lvl1pPr algn="l" defTabSz="914400" rtl="0" eaLnBrk="1" latinLnBrk="0" hangingPunct="1">
-              <a:lnSpc>
-                <a:spcPct val="90000"/>
-              </a:lnSpc>
-              <a:spcBef>
-                <a:spcPct val="0"/>
-              </a:spcBef>
-              <a:buNone/>
-              <a:defRPr sz="4400" kern="1200">
+          <a:lstStyle/>
+          <a:p>
+            <a:pPr algn="ctr"/>
+            <a:r>
+              <a:rPr lang="en-US" dirty="0"/>
+              <a:t>What would happen if</a:t>
+            </a:r>
+          </a:p>
+          <a:p>
+            <a:pPr algn="ctr"/>
+            <a:endParaRPr lang="en-US" dirty="0"/>
+          </a:p>
+          <a:p>
+            <a:r>
+              <a:rPr lang="es-AR" sz="3200" dirty="0" err="1">
                 <a:solidFill>
-                  <a:schemeClr val="tx1"/>
+                  <a:srgbClr val="8A008A"/>
                 </a:solidFill>
-                <a:latin typeface="+mj-lt"/>
-                <a:ea typeface="+mj-ea"/>
-                <a:cs typeface="+mj-cs"/>
-              </a:defRPr>
-            </a:lvl1pPr>
-          </a:lstStyle>
-          <a:p>
-            <a:r>
-              <a:rPr lang="es-AR" sz="2800" b="1" dirty="0" err="1">
-                <a:latin typeface="Consolas" panose="020B0609020204030204" pitchFamily="49" charset="0"/>
-                <a:cs typeface="Cascadia Code SemiBold" panose="020B0609020000020004" pitchFamily="49" charset="0"/>
+                <a:latin typeface="Cascadia Mono SemiLight" panose="020B0609020000020004" pitchFamily="49" charset="0"/>
+                <a:cs typeface="Cascadia Mono SemiLight" panose="020B0609020000020004" pitchFamily="49" charset="0"/>
               </a:rPr>
-              <a:t>For</a:t>
-            </a:r>
-            <a:r>
-              <a:rPr lang="es-AR" sz="2800" b="1" dirty="0">
-                <a:latin typeface="Consolas" panose="020B0609020204030204" pitchFamily="49" charset="0"/>
-                <a:cs typeface="Cascadia Code SemiBold" panose="020B0609020000020004" pitchFamily="49" charset="0"/>
-              </a:rPr>
-              <a:t> ____ in </a:t>
-            </a:r>
-            <a:r>
-              <a:rPr lang="es-AR" sz="2800" b="1" dirty="0" err="1">
-                <a:latin typeface="Consolas" panose="020B0609020204030204" pitchFamily="49" charset="0"/>
-                <a:cs typeface="Cascadia Code SemiBold" panose="020B0609020000020004" pitchFamily="49" charset="0"/>
-              </a:rPr>
-              <a:t>range</a:t>
-            </a:r>
-            <a:r>
-              <a:rPr lang="es-AR" sz="2800" b="1" dirty="0">
-                <a:latin typeface="Consolas" panose="020B0609020204030204" pitchFamily="49" charset="0"/>
-                <a:cs typeface="Cascadia Code SemiBold" panose="020B0609020000020004" pitchFamily="49" charset="0"/>
-              </a:rPr>
-              <a:t>(a, b, c)</a:t>
-            </a:r>
-            <a:br>
-              <a:rPr lang="es-AR" sz="3600" dirty="0"/>
-            </a:br>
-            <a:r>
-              <a:rPr lang="es-AR" sz="2800" i="1" dirty="0">
+              <a:t>len</a:t>
+            </a:r>
+            <a:r>
+              <a:rPr lang="en-US" sz="3200" dirty="0">
                 <a:solidFill>
-                  <a:schemeClr val="bg2">
-                    <a:lumMod val="50000"/>
-                  </a:schemeClr>
+                  <a:srgbClr val="8A008A"/>
                 </a:solidFill>
+                <a:latin typeface="Cascadia Mono SemiLight" panose="020B0609020000020004" pitchFamily="49" charset="0"/>
+                <a:cs typeface="Cascadia Mono SemiLight" panose="020B0609020000020004" pitchFamily="49" charset="0"/>
               </a:rPr>
               <a:t>(</a:t>
             </a:r>
             <a:r>
-              <a:rPr lang="es-AR" sz="2800" i="1" dirty="0" err="1">
+              <a:rPr lang="en-US" sz="3200" dirty="0">
+                <a:latin typeface="Cascadia Mono SemiLight" panose="020B0609020000020004" pitchFamily="49" charset="0"/>
+                <a:cs typeface="Cascadia Mono SemiLight" panose="020B0609020000020004" pitchFamily="49" charset="0"/>
+              </a:rPr>
+              <a:t>names</a:t>
+            </a:r>
+            <a:r>
+              <a:rPr lang="en-US" sz="3200" dirty="0">
                 <a:solidFill>
-                  <a:schemeClr val="bg2">
-                    <a:lumMod val="50000"/>
-                  </a:schemeClr>
+                  <a:srgbClr val="8A008A"/>
                 </a:solidFill>
-              </a:rPr>
-              <a:t>loop</a:t>
-            </a:r>
-            <a:r>
-              <a:rPr lang="es-AR" sz="2800" i="1" dirty="0">
-                <a:solidFill>
-                  <a:schemeClr val="bg2">
-                    <a:lumMod val="50000"/>
-                  </a:schemeClr>
-                </a:solidFill>
+                <a:latin typeface="Cascadia Mono SemiLight" panose="020B0609020000020004" pitchFamily="49" charset="0"/>
+                <a:cs typeface="Cascadia Mono SemiLight" panose="020B0609020000020004" pitchFamily="49" charset="0"/>
               </a:rPr>
               <a:t>)</a:t>
             </a:r>
             <a:r>
-              <a:rPr lang="es-AR" sz="2800" dirty="0"/>
+              <a:rPr lang="en-US" sz="3200" dirty="0">
+                <a:latin typeface="Cascadia Mono SemiLight" panose="020B0609020000020004" pitchFamily="49" charset="0"/>
+                <a:cs typeface="Cascadia Mono SemiLight" panose="020B0609020000020004" pitchFamily="49" charset="0"/>
+              </a:rPr>
               <a:t> </a:t>
             </a:r>
-            <a:endParaRPr lang="en-US" sz="3600" dirty="0"/>
+            <a:r>
+              <a:rPr lang="en-US" sz="3200" b="1" dirty="0">
+                <a:solidFill>
+                  <a:srgbClr val="FF0000"/>
+                </a:solidFill>
+                <a:latin typeface="Cascadia Mono SemiLight" panose="020B0609020000020004" pitchFamily="49" charset="0"/>
+                <a:cs typeface="Cascadia Mono SemiLight" panose="020B0609020000020004" pitchFamily="49" charset="0"/>
+              </a:rPr>
+              <a:t>!= </a:t>
+            </a:r>
+            <a:r>
+              <a:rPr lang="en-US" sz="3200" dirty="0" err="1">
+                <a:solidFill>
+                  <a:srgbClr val="8A008A"/>
+                </a:solidFill>
+                <a:latin typeface="Cascadia Mono SemiLight" panose="020B0609020000020004" pitchFamily="49" charset="0"/>
+                <a:cs typeface="Cascadia Mono SemiLight" panose="020B0609020000020004" pitchFamily="49" charset="0"/>
+              </a:rPr>
+              <a:t>len</a:t>
+            </a:r>
+            <a:r>
+              <a:rPr lang="en-US" sz="3200" dirty="0">
+                <a:solidFill>
+                  <a:srgbClr val="8A008A"/>
+                </a:solidFill>
+                <a:latin typeface="Cascadia Mono SemiLight" panose="020B0609020000020004" pitchFamily="49" charset="0"/>
+                <a:cs typeface="Cascadia Mono SemiLight" panose="020B0609020000020004" pitchFamily="49" charset="0"/>
+              </a:rPr>
+              <a:t>(</a:t>
+            </a:r>
+            <a:r>
+              <a:rPr lang="en-US" sz="3200" dirty="0">
+                <a:latin typeface="Cascadia Mono SemiLight" panose="020B0609020000020004" pitchFamily="49" charset="0"/>
+                <a:cs typeface="Cascadia Mono SemiLight" panose="020B0609020000020004" pitchFamily="49" charset="0"/>
+              </a:rPr>
+              <a:t>surnames</a:t>
+            </a:r>
+            <a:r>
+              <a:rPr lang="en-US" sz="3200" dirty="0">
+                <a:solidFill>
+                  <a:srgbClr val="8A008A"/>
+                </a:solidFill>
+                <a:latin typeface="Cascadia Mono SemiLight" panose="020B0609020000020004" pitchFamily="49" charset="0"/>
+                <a:cs typeface="Cascadia Mono SemiLight" panose="020B0609020000020004" pitchFamily="49" charset="0"/>
+              </a:rPr>
+              <a:t>)</a:t>
+            </a:r>
+            <a:r>
+              <a:rPr lang="en-US" sz="3600" dirty="0"/>
+              <a:t>?</a:t>
+            </a:r>
+            <a:endParaRPr lang="en-US" dirty="0"/>
           </a:p>
         </p:txBody>
       </p:sp>
-      <p:pic>
-        <p:nvPicPr>
-          <p:cNvPr id="4" name="Imagen 3">
-            <a:extLst>
-              <a:ext uri="{FF2B5EF4-FFF2-40B4-BE49-F238E27FC236}">
-                <a16:creationId xmlns:a16="http://schemas.microsoft.com/office/drawing/2014/main" id="{C62399E7-661C-851F-0274-DE435BF9C3A1}"/>
-              </a:ext>
-            </a:extLst>
-          </p:cNvPr>
-          <p:cNvPicPr>
-            <a:picLocks noChangeAspect="1"/>
-          </p:cNvPicPr>
-          <p:nvPr/>
-        </p:nvPicPr>
-        <p:blipFill>
-          <a:blip r:embed="rId3"/>
-          <a:stretch>
-            <a:fillRect/>
-          </a:stretch>
-        </p:blipFill>
-        <p:spPr>
-          <a:xfrm>
-            <a:off x="0" y="5044703"/>
-            <a:ext cx="7109141" cy="1799621"/>
-          </a:xfrm>
-          <a:prstGeom prst="rect">
-            <a:avLst/>
-          </a:prstGeom>
-        </p:spPr>
-      </p:pic>
     </p:spTree>
     <p:extLst>
       <p:ext uri="{BB962C8B-B14F-4D97-AF65-F5344CB8AC3E}">
-        <p14:creationId xmlns:p14="http://schemas.microsoft.com/office/powerpoint/2010/main" val="2107084744"/>
+        <p14:creationId xmlns:p14="http://schemas.microsoft.com/office/powerpoint/2010/main" val="524851808"/>
       </p:ext>
     </p:extLst>
   </p:cSld>

</xml_diff>